<commit_message>
Refocus deck on high-impact solutions and flag assumptions
Reframe prioritisation as three pragmatic moves rather than a full transformation, make longer-term structural changes data-dependent, and label assumptions throughout plus a dedicated assumptions slide.

https://claude.ai/code/session_014EpSpf3QcBHWNPw4UskYmj
</commit_message>
<xml_diff>
--- a/NextTech_Procurement_Analysis.pptx
+++ b/NextTech_Procurement_Analysis.pptx
@@ -19,6 +19,7 @@
     <p:sldId id="267" r:id="rId18"/>
     <p:sldId id="268" r:id="rId19"/>
     <p:sldId id="269" r:id="rId20"/>
+    <p:sldId id="270" r:id="rId21"/>
   </p:sldIdLst>
   <p:sldSz cx="12191695" cy="6858000" type="screen4x3"/>
   <p:notesSz cx="6858000" cy="9144000"/>
@@ -3210,7 +3211,7 @@
                   <a:srgbClr val="C0392B"/>
                 </a:solidFill>
               </a:rPr>
-              <a:t>What to work on, and why</a:t>
+              <a:t>Three high-impact moves first — not a full redesign</a:t>
             </a:r>
           </a:p>
         </p:txBody>
@@ -3243,12 +3244,12 @@
               </a:spcAft>
             </a:pPr>
             <a:r>
-              <a:rPr sz="1600" b="1">
-                <a:solidFill>
-                  <a:srgbClr val="1F3864"/>
-                </a:solidFill>
-              </a:rPr>
-              <a:t>Priority order:</a:t>
+              <a:rPr sz="1500" b="0">
+                <a:solidFill>
+                  <a:srgbClr val="444444"/>
+                </a:solidFill>
+              </a:rPr>
+              <a:t>We deliberately focus on a few high-impact, low-disruption actions rather than a multi-year transformation:</a:t>
             </a:r>
           </a:p>
           <a:p>
@@ -3258,12 +3259,27 @@
               </a:spcAft>
             </a:pPr>
             <a:r>
-              <a:rPr sz="1500" b="1">
+              <a:rPr sz="1400" b="1">
                 <a:solidFill>
                   <a:srgbClr val="444444"/>
                 </a:solidFill>
               </a:rPr>
-              <a:t>1.  R1 — Executive sponsorship &amp; governance  (quick, foundational enabler)</a:t>
+              <a:t>1.  R1 — Secure executive sponsorship &amp; a compliance mandate</a:t>
+            </a:r>
+          </a:p>
+          <a:p>
+            <a:pPr lvl="2">
+              <a:spcAft>
+                <a:spcPts val="600"/>
+              </a:spcAft>
+            </a:pPr>
+            <a:r>
+              <a:rPr sz="1300" b="0">
+                <a:solidFill>
+                  <a:srgbClr val="444444"/>
+                </a:solidFill>
+              </a:rPr>
+              <a:t>Low cost, fast, and unlocks every other fix. Highest leverage move available.</a:t>
             </a:r>
           </a:p>
           <a:p>
@@ -3273,12 +3289,27 @@
               </a:spcAft>
             </a:pPr>
             <a:r>
-              <a:rPr sz="1500" b="1">
+              <a:rPr sz="1400" b="1">
                 <a:solidFill>
                   <a:srgbClr val="444444"/>
                 </a:solidFill>
               </a:rPr>
-              <a:t>2.  R3 + S3 — Standardise procure-to-pay &amp; rationalise catalogue / tail spend  (biggest near-term efficiency win at 1.8M txns/day)</a:t>
+              <a:t>2.  R3 + S3 — Standardise the procure-to-pay process &amp; rationalise catalogue / tail spend</a:t>
+            </a:r>
+          </a:p>
+          <a:p>
+            <a:pPr lvl="2">
+              <a:spcAft>
+                <a:spcPts val="600"/>
+              </a:spcAft>
+            </a:pPr>
+            <a:r>
+              <a:rPr sz="1300" b="0">
+                <a:solidFill>
+                  <a:srgbClr val="444444"/>
+                </a:solidFill>
+              </a:rPr>
+              <a:t>Biggest near-term efficiency gain at 1.8M txns/day — achievable WITHOUT replacing systems.</a:t>
             </a:r>
           </a:p>
           <a:p>
@@ -3288,12 +3319,27 @@
               </a:spcAft>
             </a:pPr>
             <a:r>
-              <a:rPr sz="1500" b="1">
+              <a:rPr sz="1400" b="1">
                 <a:solidFill>
                   <a:srgbClr val="444444"/>
                 </a:solidFill>
               </a:rPr>
-              <a:t>3.  S4 — Rebalance resourcing (fill Team 1 vacancies / shift work)  (fast operational win)</a:t>
+              <a:t>3.  S4 — Rebalance the two central teams (fill Team 1 vacancies / shift workload)</a:t>
+            </a:r>
+          </a:p>
+          <a:p>
+            <a:pPr lvl="2">
+              <a:spcAft>
+                <a:spcPts val="600"/>
+              </a:spcAft>
+            </a:pPr>
+            <a:r>
+              <a:rPr sz="1300" b="0">
+                <a:solidFill>
+                  <a:srgbClr val="444444"/>
+                </a:solidFill>
+              </a:rPr>
+              <a:t>Fast operational win that lifts throughput and morale.</a:t>
             </a:r>
           </a:p>
           <a:p>
@@ -3303,27 +3349,12 @@
               </a:spcAft>
             </a:pPr>
             <a:r>
-              <a:rPr sz="1600" b="1">
-                <a:solidFill>
-                  <a:srgbClr val="1F3864"/>
-                </a:solidFill>
-              </a:rPr>
-              <a:t>Why this order:</a:t>
-            </a:r>
-          </a:p>
-          <a:p>
-            <a:pPr lvl="1">
-              <a:spcAft>
-                <a:spcPts val="600"/>
-              </a:spcAft>
-            </a:pPr>
-            <a:r>
-              <a:rPr sz="1500" b="0">
-                <a:solidFill>
-                  <a:srgbClr val="444444"/>
-                </a:solidFill>
-              </a:rPr>
-              <a:t>Governance is the enabler; process + catalogue standardisation delivers the biggest near-term gain without a multi-year system rebuild; system replacement is highest cost/risk so it comes later, de-risked by the earlier steps.</a:t>
+              <a:rPr sz="1500" b="0" i="1">
+                <a:solidFill>
+                  <a:srgbClr val="C0392B"/>
+                </a:solidFill>
+              </a:rPr>
+              <a:t>Assumption: these three deliver most of the benefit; bigger structural changes are deferred until data justifies them.</a:t>
             </a:r>
           </a:p>
         </p:txBody>
@@ -3374,7 +3405,7 @@
                   <a:srgbClr val="1F3864"/>
                 </a:solidFill>
               </a:rPr>
-              <a:t>Long-term focus (related issues)</a:t>
+              <a:t>Longer-term — only if the data justifies it</a:t>
             </a:r>
           </a:p>
         </p:txBody>
@@ -3387,7 +3418,7 @@
         </p:nvSpPr>
         <p:spPr>
           <a:xfrm>
-            <a:off x="548640" y="1463040"/>
+            <a:off x="548640" y="1371600"/>
             <a:ext cx="11064240" cy="5029200"/>
           </a:xfrm>
           <a:prstGeom prst="rect">
@@ -3407,12 +3438,57 @@
               </a:spcAft>
             </a:pPr>
             <a:r>
-              <a:rPr sz="1800" b="1">
-                <a:solidFill>
-                  <a:srgbClr val="1F3864"/>
-                </a:solidFill>
-              </a:rPr>
-              <a:t>R4 — ERP / system consolidation onto a common platform</a:t>
+              <a:rPr sz="1600" b="0">
+                <a:solidFill>
+                  <a:srgbClr val="444444"/>
+                </a:solidFill>
+              </a:rPr>
+              <a:t>These are higher cost / higher risk, so treat as later-stage options, not day-one commitments:</a:t>
+            </a:r>
+          </a:p>
+          <a:p>
+            <a:pPr lvl="1">
+              <a:spcAft>
+                <a:spcPts val="600"/>
+              </a:spcAft>
+            </a:pPr>
+            <a:r>
+              <a:rPr sz="1500" b="1">
+                <a:solidFill>
+                  <a:srgbClr val="444444"/>
+                </a:solidFill>
+              </a:rPr>
+              <a:t>R4 — Consolidate / better integrate the ERPs (Oracle, SAP, PeopleSoft)</a:t>
+            </a:r>
+          </a:p>
+          <a:p>
+            <a:pPr lvl="1">
+              <a:spcAft>
+                <a:spcPts val="600"/>
+              </a:spcAft>
+            </a:pPr>
+            <a:r>
+              <a:rPr sz="1500" b="1">
+                <a:solidFill>
+                  <a:srgbClr val="444444"/>
+                </a:solidFill>
+              </a:rPr>
+              <a:t>S2 — Rationalise the supplier base to rebuild buying leverage</a:t>
+            </a:r>
+          </a:p>
+          <a:p>
+            <a:pPr lvl="1">
+              <a:spcAft>
+                <a:spcPts val="600"/>
+              </a:spcAft>
+            </a:pPr>
+            <a:r>
+              <a:rPr sz="1500" b="1">
+                <a:solidFill>
+                  <a:srgbClr val="444444"/>
+                </a:solidFill>
+              </a:rPr>
+              <a:t>R2 — Move the 59 units toward one operating model / shared services</a:t>
             </a:r>
           </a:p>
           <a:p>
@@ -3422,57 +3498,12 @@
               </a:spcAft>
             </a:pPr>
             <a:r>
-              <a:rPr sz="1800" b="1">
-                <a:solidFill>
-                  <a:srgbClr val="1F3864"/>
-                </a:solidFill>
-              </a:rPr>
-              <a:t>R2 — Integrate the 59 units into one operating model</a:t>
-            </a:r>
-          </a:p>
-          <a:p>
-            <a:pPr>
-              <a:spcAft>
-                <a:spcPts val="600"/>
-              </a:spcAft>
-            </a:pPr>
-            <a:r>
-              <a:rPr sz="1800" b="1">
-                <a:solidFill>
-                  <a:srgbClr val="1F3864"/>
-                </a:solidFill>
-              </a:rPr>
-              <a:t>S2 — Supplier-base rationalisation to rebuild economies of scale</a:t>
-            </a:r>
-          </a:p>
-          <a:p>
-            <a:pPr>
-              <a:spcAft>
-                <a:spcPts val="600"/>
-              </a:spcAft>
-            </a:pPr>
-            <a:r>
-              <a:rPr sz="1800" b="1">
-                <a:solidFill>
-                  <a:srgbClr val="1F3864"/>
-                </a:solidFill>
-              </a:rPr>
-              <a:t>Establish a shared-services / procurement centre of excellence</a:t>
-            </a:r>
-          </a:p>
-          <a:p>
-            <a:pPr>
-              <a:spcAft>
-                <a:spcPts val="600"/>
-              </a:spcAft>
-            </a:pPr>
-            <a:r>
-              <a:rPr sz="1800" b="1">
-                <a:solidFill>
-                  <a:srgbClr val="1F3864"/>
-                </a:solidFill>
-              </a:rPr>
-              <a:t>Address S5 — reposition procurement as a value-adding function to lift morale and retention</a:t>
+              <a:rPr sz="1600" b="0" i="1">
+                <a:solidFill>
+                  <a:srgbClr val="C0392B"/>
+                </a:solidFill>
+              </a:rPr>
+              <a:t>Assumption: a full ERP consolidation is NOT assumed to be the right answer yet — it should be a business case decided on spend, cost-to-serve and lock-in data.</a:t>
             </a:r>
           </a:p>
         </p:txBody>
@@ -3815,7 +3846,7 @@
                   <a:srgbClr val="444444"/>
                 </a:solidFill>
               </a:rPr>
-              <a:t>Budget, timeline and genuine executive appetite for transformation</a:t>
+              <a:t>Budget, timeline and genuine executive appetite for change</a:t>
             </a:r>
           </a:p>
         </p:txBody>
@@ -3866,6 +3897,180 @@
                   <a:srgbClr val="1F3864"/>
                 </a:solidFill>
               </a:rPr>
+              <a:t>Assumptions we have made</a:t>
+            </a:r>
+          </a:p>
+          <a:p>
+            <a:r>
+              <a:rPr sz="1500" i="1">
+                <a:solidFill>
+                  <a:srgbClr val="C0392B"/>
+                </a:solidFill>
+              </a:rPr>
+              <a:t>To be confirmed with the client</a:t>
+            </a:r>
+          </a:p>
+        </p:txBody>
+      </p:sp>
+      <p:sp>
+        <p:nvSpPr>
+          <p:cNvPr id="3" name="TextBox 2"/>
+          <p:cNvSpPr txBox="1"/>
+          <p:nvPr/>
+        </p:nvSpPr>
+        <p:spPr>
+          <a:xfrm>
+            <a:off x="548640" y="1371600"/>
+            <a:ext cx="11064240" cy="5029200"/>
+          </a:xfrm>
+          <a:prstGeom prst="rect">
+            <a:avLst/>
+          </a:prstGeom>
+          <a:noFill/>
+        </p:spPr>
+        <p:txBody>
+          <a:bodyPr wrap="square">
+            <a:spAutoFit/>
+          </a:bodyPr>
+          <a:lstStyle/>
+          <a:p>
+            <a:pPr>
+              <a:spcAft>
+                <a:spcPts val="600"/>
+              </a:spcAft>
+            </a:pPr>
+            <a:r>
+              <a:rPr sz="1600" b="0" i="1">
+                <a:solidFill>
+                  <a:srgbClr val="C0392B"/>
+                </a:solidFill>
+              </a:rPr>
+              <a:t>Assumption: protracted payables are causing real cost (penalties, lost discounts) — not yet quantified.</a:t>
+            </a:r>
+          </a:p>
+          <a:p>
+            <a:pPr>
+              <a:spcAft>
+                <a:spcPts val="600"/>
+              </a:spcAft>
+            </a:pPr>
+            <a:r>
+              <a:rPr sz="1600" b="0" i="1">
+                <a:solidFill>
+                  <a:srgbClr val="C0392B"/>
+                </a:solidFill>
+              </a:rPr>
+              <a:t>Assumption: fragmented spend is losing meaningful volume discounts across the 59 units.</a:t>
+            </a:r>
+          </a:p>
+          <a:p>
+            <a:pPr>
+              <a:spcAft>
+                <a:spcPts val="600"/>
+              </a:spcAft>
+            </a:pPr>
+            <a:r>
+              <a:rPr sz="1600" b="0" i="1">
+                <a:solidFill>
+                  <a:srgbClr val="C0392B"/>
+                </a:solidFill>
+              </a:rPr>
+              <a:t>Assumption: a large share of the 1.8M daily transactions is low-value/tail spend that can be consolidated.</a:t>
+            </a:r>
+          </a:p>
+          <a:p>
+            <a:pPr>
+              <a:spcAft>
+                <a:spcPts val="600"/>
+              </a:spcAft>
+            </a:pPr>
+            <a:r>
+              <a:rPr sz="1600" b="0" i="1">
+                <a:solidFill>
+                  <a:srgbClr val="C0392B"/>
+                </a:solidFill>
+              </a:rPr>
+              <a:t>Assumption: executive sponsorship is currently absent rather than present-but-ignored.</a:t>
+            </a:r>
+          </a:p>
+          <a:p>
+            <a:pPr>
+              <a:spcAft>
+                <a:spcPts val="600"/>
+              </a:spcAft>
+            </a:pPr>
+            <a:r>
+              <a:rPr sz="1600" b="0" i="1">
+                <a:solidFill>
+                  <a:srgbClr val="C0392B"/>
+                </a:solidFill>
+              </a:rPr>
+              <a:t>Assumption: the three named ERPs are the main systems; there may be more across 59 units.</a:t>
+            </a:r>
+          </a:p>
+          <a:p>
+            <a:pPr>
+              <a:spcAft>
+                <a:spcPts val="600"/>
+              </a:spcAft>
+            </a:pPr>
+            <a:r>
+              <a:rPr sz="1600" b="0" i="1">
+                <a:solidFill>
+                  <a:srgbClr val="C0392B"/>
+                </a:solidFill>
+              </a:rPr>
+              <a:t>Assumption: standardising process and catalogue delivers most of the benefit before any system replacement.</a:t>
+            </a:r>
+          </a:p>
+        </p:txBody>
+      </p:sp>
+    </p:spTree>
+  </p:cSld>
+  <p:clrMapOvr>
+    <a:masterClrMapping/>
+  </p:clrMapOvr>
+</p:sld>
+</file>
+
+<file path=ppt/slides/slide15.xml><?xml version="1.0" encoding="utf-8"?>
+<p:sld xmlns:a="http://schemas.openxmlformats.org/drawingml/2006/main" xmlns:p="http://schemas.openxmlformats.org/presentationml/2006/main" xmlns:r="http://schemas.openxmlformats.org/officeDocument/2006/relationships">
+  <p:cSld>
+    <p:spTree>
+      <p:nvGrpSpPr>
+        <p:cNvPr id="1" name=""/>
+        <p:cNvGrpSpPr/>
+        <p:nvPr/>
+      </p:nvGrpSpPr>
+      <p:grpSpPr/>
+      <p:sp>
+        <p:nvSpPr>
+          <p:cNvPr id="2" name="TextBox 1"/>
+          <p:cNvSpPr txBox="1"/>
+          <p:nvPr/>
+        </p:nvSpPr>
+        <p:spPr>
+          <a:xfrm>
+            <a:off x="457200" y="274320"/>
+            <a:ext cx="11247120" cy="1005840"/>
+          </a:xfrm>
+          <a:prstGeom prst="rect">
+            <a:avLst/>
+          </a:prstGeom>
+          <a:noFill/>
+        </p:spPr>
+        <p:txBody>
+          <a:bodyPr wrap="square">
+            <a:spAutoFit/>
+          </a:bodyPr>
+          <a:lstStyle/>
+          <a:p>
+            <a:r>
+              <a:rPr sz="3000" b="1">
+                <a:solidFill>
+                  <a:srgbClr val="1F3864"/>
+                </a:solidFill>
+              </a:rPr>
               <a:t>3.  Five questions for the client</a:t>
             </a:r>
           </a:p>
@@ -5132,7 +5337,7 @@
                   <a:srgbClr val="1F3864"/>
                 </a:solidFill>
               </a:rPr>
-              <a:t>S1  Protracted payables</a:t>
+              <a:t>S1  Protracted payables (stated in the analysis)</a:t>
             </a:r>
           </a:p>
           <a:p>
@@ -5142,12 +5347,72 @@
               </a:spcAft>
             </a:pPr>
             <a:r>
+              <a:rPr sz="1400" b="0" i="1">
+                <a:solidFill>
+                  <a:srgbClr val="C0392B"/>
+                </a:solidFill>
+              </a:rPr>
+              <a:t>Assumption: this drives late-payment penalties, strained supplier relationships and lost early-payment discounts.</a:t>
+            </a:r>
+          </a:p>
+          <a:p>
+            <a:pPr>
+              <a:spcAft>
+                <a:spcPts val="600"/>
+              </a:spcAft>
+            </a:pPr>
+            <a:r>
+              <a:rPr sz="1500" b="1">
+                <a:solidFill>
+                  <a:srgbClr val="1F3864"/>
+                </a:solidFill>
+              </a:rPr>
+              <a:t>S2  Lost economies of scale (stated)</a:t>
+            </a:r>
+          </a:p>
+          <a:p>
+            <a:pPr lvl="1">
+              <a:spcAft>
+                <a:spcPts val="600"/>
+              </a:spcAft>
+            </a:pPr>
+            <a:r>
+              <a:rPr sz="1400" b="0" i="1">
+                <a:solidFill>
+                  <a:srgbClr val="C0392B"/>
+                </a:solidFill>
+              </a:rPr>
+              <a:t>Assumption: fragmented spend means higher unit prices, duplicate contracts and no volume discounts.</a:t>
+            </a:r>
+          </a:p>
+          <a:p>
+            <a:pPr>
+              <a:spcAft>
+                <a:spcPts val="600"/>
+              </a:spcAft>
+            </a:pPr>
+            <a:r>
+              <a:rPr sz="1500" b="1">
+                <a:solidFill>
+                  <a:srgbClr val="1F3864"/>
+                </a:solidFill>
+              </a:rPr>
+              <a:t>S3  Catalogue proliferation &amp; tail spend (stated)</a:t>
+            </a:r>
+          </a:p>
+          <a:p>
+            <a:pPr lvl="1">
+              <a:spcAft>
+                <a:spcPts val="600"/>
+              </a:spcAft>
+            </a:pPr>
+            <a:r>
               <a:rPr sz="1400" b="0">
                 <a:solidFill>
                   <a:srgbClr val="444444"/>
                 </a:solidFill>
               </a:rPr>
-              <a:t>Late-payment penalties, strained supplier relationships, lost early-payment discounts, working-capital drag.</a:t>
+              <a:t>Low-value items require multiple orders to different suppliers — costly at 1.8M txns/day.</a:t>
             </a:r>
           </a:p>
           <a:p>
@@ -5162,7 +5427,7 @@
                   <a:srgbClr val="1F3864"/>
                 </a:solidFill>
               </a:rPr>
-              <a:t>S2  Lost economies of scale</a:t>
+              <a:t>S4  Resourcing imbalance (stated)</a:t>
             </a:r>
           </a:p>
           <a:p>
@@ -5177,7 +5442,7 @@
                   <a:srgbClr val="444444"/>
                 </a:solidFill>
               </a:rPr>
-              <a:t>Fragmented spend = higher prices, duplicate contracts, no volume discounts.</a:t>
+              <a:t>Team 1: 2 FTE + part-timers + 2 vacancies (slow).  Team 2: 7 + 2 seniors (fast). Inconsistent service.</a:t>
             </a:r>
           </a:p>
           <a:p>
@@ -5192,7 +5457,7 @@
                   <a:srgbClr val="1F3864"/>
                 </a:solidFill>
               </a:rPr>
-              <a:t>S3  Catalogue proliferation &amp; tail spend</a:t>
+              <a:t>S5  Low morale / perception (stated)</a:t>
             </a:r>
           </a:p>
           <a:p>
@@ -5202,72 +5467,12 @@
               </a:spcAft>
             </a:pPr>
             <a:r>
-              <a:rPr sz="1400" b="0">
-                <a:solidFill>
-                  <a:srgbClr val="444444"/>
-                </a:solidFill>
-              </a:rPr>
-              <a:t>Too many catalogue items; low-value items require multiple orders to different suppliers — costly at 1.8M txns/day.</a:t>
-            </a:r>
-          </a:p>
-          <a:p>
-            <a:pPr>
-              <a:spcAft>
-                <a:spcPts val="600"/>
-              </a:spcAft>
-            </a:pPr>
-            <a:r>
-              <a:rPr sz="1500" b="1">
-                <a:solidFill>
-                  <a:srgbClr val="1F3864"/>
-                </a:solidFill>
-              </a:rPr>
-              <a:t>S4  Resourcing imbalance</a:t>
-            </a:r>
-          </a:p>
-          <a:p>
-            <a:pPr lvl="1">
-              <a:spcAft>
-                <a:spcPts val="600"/>
-              </a:spcAft>
-            </a:pPr>
-            <a:r>
-              <a:rPr sz="1400" b="0">
-                <a:solidFill>
-                  <a:srgbClr val="444444"/>
-                </a:solidFill>
-              </a:rPr>
-              <a:t>Team 1: 2 FTE + part-timers + 2 vacancies (slow).  Team 2: 7 + 2 seniors (fast). Inconsistent service.</a:t>
-            </a:r>
-          </a:p>
-          <a:p>
-            <a:pPr>
-              <a:spcAft>
-                <a:spcPts val="600"/>
-              </a:spcAft>
-            </a:pPr>
-            <a:r>
-              <a:rPr sz="1500" b="1">
-                <a:solidFill>
-                  <a:srgbClr val="1F3864"/>
-                </a:solidFill>
-              </a:rPr>
-              <a:t>S5  Low morale / perception</a:t>
-            </a:r>
-          </a:p>
-          <a:p>
-            <a:pPr lvl="1">
-              <a:spcAft>
-                <a:spcPts val="600"/>
-              </a:spcAft>
-            </a:pPr>
-            <a:r>
-              <a:rPr sz="1400" b="0">
-                <a:solidFill>
-                  <a:srgbClr val="444444"/>
-                </a:solidFill>
-              </a:rPr>
-              <a:t>Procurement seen as low-value back-office work — attrition risk and change fatigue.</a:t>
+              <a:rPr sz="1400" b="0" i="1">
+                <a:solidFill>
+                  <a:srgbClr val="C0392B"/>
+                </a:solidFill>
+              </a:rPr>
+              <a:t>Assumption: this creates attrition risk and change fatigue.</a:t>
             </a:r>
           </a:p>
         </p:txBody>

</xml_diff>

<commit_message>
Add supplier base trend slide as evidence of lost economies of scale
2023 vs 2024 supplier count and spend show the base is fragmenting (avg spend per supplier falling), evidencing S2 and R2.

https://claude.ai/code/session_014EpSpf3QcBHWNPw4UskYmj
</commit_message>
<xml_diff>
--- a/NextTech_Procurement_Analysis.pptx
+++ b/NextTech_Procurement_Analysis.pptx
@@ -20,6 +20,7 @@
     <p:sldId id="268" r:id="rId19"/>
     <p:sldId id="269" r:id="rId20"/>
     <p:sldId id="270" r:id="rId21"/>
+    <p:sldId id="271" r:id="rId22"/>
   </p:sldIdLst>
   <p:sldSz cx="12191695" cy="6858000" type="screen4x3"/>
   <p:notesSz cx="6858000" cy="9144000"/>
@@ -3201,7 +3202,7 @@
                   <a:srgbClr val="1F3864"/>
                 </a:solidFill>
               </a:rPr>
-              <a:t>2.  Prioritisation</a:t>
+              <a:t>Which issue matters most?</a:t>
             </a:r>
           </a:p>
           <a:p>
@@ -3211,7 +3212,7 @@
                   <a:srgbClr val="C0392B"/>
                 </a:solidFill>
               </a:rPr>
-              <a:t>Three high-impact moves first — not a full redesign</a:t>
+              <a:t>Our view</a:t>
             </a:r>
           </a:p>
         </p:txBody>
@@ -3224,7 +3225,7 @@
         </p:nvSpPr>
         <p:spPr>
           <a:xfrm>
-            <a:off x="548640" y="1280160"/>
+            <a:off x="548640" y="1463040"/>
             <a:ext cx="11064240" cy="5029200"/>
           </a:xfrm>
           <a:prstGeom prst="rect">
@@ -3244,12 +3245,27 @@
               </a:spcAft>
             </a:pPr>
             <a:r>
-              <a:rPr sz="1500" b="0">
+              <a:rPr sz="1800" b="1">
+                <a:solidFill>
+                  <a:srgbClr val="1F3864"/>
+                </a:solidFill>
+              </a:rPr>
+              <a:t>Most important = R1: secure executive sponsorship and a governance mandate.</a:t>
+            </a:r>
+          </a:p>
+          <a:p>
+            <a:pPr lvl="1">
+              <a:spcAft>
+                <a:spcPts val="600"/>
+              </a:spcAft>
+            </a:pPr>
+            <a:r>
+              <a:rPr sz="1700" b="0">
                 <a:solidFill>
                   <a:srgbClr val="444444"/>
                 </a:solidFill>
               </a:rPr>
-              <a:t>We deliberately focus on a few high-impact, low-disruption actions rather than a multi-year transformation:</a:t>
+              <a:t>It is not the most expensive problem, but it is the dependency that unblocks everything else.</a:t>
             </a:r>
           </a:p>
           <a:p>
@@ -3259,102 +3275,27 @@
               </a:spcAft>
             </a:pPr>
             <a:r>
-              <a:rPr sz="1400" b="1">
+              <a:rPr sz="1700" b="0">
                 <a:solidFill>
                   <a:srgbClr val="444444"/>
                 </a:solidFill>
               </a:rPr>
-              <a:t>1.  R1 — Secure executive sponsorship &amp; a compliance mandate</a:t>
-            </a:r>
-          </a:p>
-          <a:p>
-            <a:pPr lvl="2">
-              <a:spcAft>
-                <a:spcPts val="600"/>
-              </a:spcAft>
-            </a:pPr>
-            <a:r>
-              <a:rPr sz="1300" b="0">
+              <a:t>With 59 autonomous units, you cannot standardise processes, consolidate systems or rationalise suppliers unless leadership mandates compliance.</a:t>
+            </a:r>
+          </a:p>
+          <a:p>
+            <a:pPr lvl="1">
+              <a:spcAft>
+                <a:spcPts val="600"/>
+              </a:spcAft>
+            </a:pPr>
+            <a:r>
+              <a:rPr sz="1700" b="0">
                 <a:solidFill>
                   <a:srgbClr val="444444"/>
                 </a:solidFill>
               </a:rPr>
-              <a:t>Low cost, fast, and unlocks every other fix. Highest leverage move available.</a:t>
-            </a:r>
-          </a:p>
-          <a:p>
-            <a:pPr lvl="1">
-              <a:spcAft>
-                <a:spcPts val="600"/>
-              </a:spcAft>
-            </a:pPr>
-            <a:r>
-              <a:rPr sz="1400" b="1">
-                <a:solidFill>
-                  <a:srgbClr val="444444"/>
-                </a:solidFill>
-              </a:rPr>
-              <a:t>2.  R3 + S3 — Standardise the procure-to-pay process &amp; rationalise catalogue / tail spend</a:t>
-            </a:r>
-          </a:p>
-          <a:p>
-            <a:pPr lvl="2">
-              <a:spcAft>
-                <a:spcPts val="600"/>
-              </a:spcAft>
-            </a:pPr>
-            <a:r>
-              <a:rPr sz="1300" b="0">
-                <a:solidFill>
-                  <a:srgbClr val="444444"/>
-                </a:solidFill>
-              </a:rPr>
-              <a:t>Biggest near-term efficiency gain at 1.8M txns/day — achievable WITHOUT replacing systems.</a:t>
-            </a:r>
-          </a:p>
-          <a:p>
-            <a:pPr lvl="1">
-              <a:spcAft>
-                <a:spcPts val="600"/>
-              </a:spcAft>
-            </a:pPr>
-            <a:r>
-              <a:rPr sz="1400" b="1">
-                <a:solidFill>
-                  <a:srgbClr val="444444"/>
-                </a:solidFill>
-              </a:rPr>
-              <a:t>3.  S4 — Rebalance the two central teams (fill Team 1 vacancies / shift workload)</a:t>
-            </a:r>
-          </a:p>
-          <a:p>
-            <a:pPr lvl="2">
-              <a:spcAft>
-                <a:spcPts val="600"/>
-              </a:spcAft>
-            </a:pPr>
-            <a:r>
-              <a:rPr sz="1300" b="0">
-                <a:solidFill>
-                  <a:srgbClr val="444444"/>
-                </a:solidFill>
-              </a:rPr>
-              <a:t>Fast operational win that lifts throughput and morale.</a:t>
-            </a:r>
-          </a:p>
-          <a:p>
-            <a:pPr>
-              <a:spcAft>
-                <a:spcPts val="600"/>
-              </a:spcAft>
-            </a:pPr>
-            <a:r>
-              <a:rPr sz="1500" b="0" i="1">
-                <a:solidFill>
-                  <a:srgbClr val="C0392B"/>
-                </a:solidFill>
-              </a:rPr>
-              <a:t>Assumption: these three deliver most of the benefit; bigger structural changes are deferred until data justifies them.</a:t>
+              <a:t>Low cost, high leverage — fix it first.</a:t>
             </a:r>
           </a:p>
         </p:txBody>
@@ -3405,7 +3346,17 @@
                   <a:srgbClr val="1F3864"/>
                 </a:solidFill>
               </a:rPr>
-              <a:t>Longer-term — only if the data justifies it</a:t>
+              <a:t>2.  Prioritisation</a:t>
+            </a:r>
+          </a:p>
+          <a:p>
+            <a:r>
+              <a:rPr sz="1500" i="1">
+                <a:solidFill>
+                  <a:srgbClr val="C0392B"/>
+                </a:solidFill>
+              </a:rPr>
+              <a:t>Three high-impact moves first — not a full redesign</a:t>
             </a:r>
           </a:p>
         </p:txBody>
@@ -3418,7 +3369,7 @@
         </p:nvSpPr>
         <p:spPr>
           <a:xfrm>
-            <a:off x="548640" y="1371600"/>
+            <a:off x="548640" y="1280160"/>
             <a:ext cx="11064240" cy="5029200"/>
           </a:xfrm>
           <a:prstGeom prst="rect">
@@ -3438,12 +3389,12 @@
               </a:spcAft>
             </a:pPr>
             <a:r>
-              <a:rPr sz="1600" b="0">
+              <a:rPr sz="1500" b="0">
                 <a:solidFill>
                   <a:srgbClr val="444444"/>
                 </a:solidFill>
               </a:rPr>
-              <a:t>These are higher cost / higher risk, so treat as later-stage options, not day-one commitments:</a:t>
+              <a:t>We deliberately focus on a few high-impact, low-disruption actions rather than a multi-year transformation:</a:t>
             </a:r>
           </a:p>
           <a:p>
@@ -3453,12 +3404,27 @@
               </a:spcAft>
             </a:pPr>
             <a:r>
-              <a:rPr sz="1500" b="1">
+              <a:rPr sz="1400" b="1">
                 <a:solidFill>
                   <a:srgbClr val="444444"/>
                 </a:solidFill>
               </a:rPr>
-              <a:t>R4 — Consolidate / better integrate the ERPs (Oracle, SAP, PeopleSoft)</a:t>
+              <a:t>1.  R1 — Secure executive sponsorship &amp; a compliance mandate</a:t>
+            </a:r>
+          </a:p>
+          <a:p>
+            <a:pPr lvl="2">
+              <a:spcAft>
+                <a:spcPts val="600"/>
+              </a:spcAft>
+            </a:pPr>
+            <a:r>
+              <a:rPr sz="1300" b="0">
+                <a:solidFill>
+                  <a:srgbClr val="444444"/>
+                </a:solidFill>
+              </a:rPr>
+              <a:t>Low cost, fast, and unlocks every other fix. Highest leverage move available.</a:t>
             </a:r>
           </a:p>
           <a:p>
@@ -3468,12 +3434,27 @@
               </a:spcAft>
             </a:pPr>
             <a:r>
-              <a:rPr sz="1500" b="1">
+              <a:rPr sz="1400" b="1">
                 <a:solidFill>
                   <a:srgbClr val="444444"/>
                 </a:solidFill>
               </a:rPr>
-              <a:t>S2 — Rationalise the supplier base to rebuild buying leverage</a:t>
+              <a:t>2.  R3 + S3 — Standardise the procure-to-pay process &amp; rationalise catalogue / tail spend</a:t>
+            </a:r>
+          </a:p>
+          <a:p>
+            <a:pPr lvl="2">
+              <a:spcAft>
+                <a:spcPts val="600"/>
+              </a:spcAft>
+            </a:pPr>
+            <a:r>
+              <a:rPr sz="1300" b="0">
+                <a:solidFill>
+                  <a:srgbClr val="444444"/>
+                </a:solidFill>
+              </a:rPr>
+              <a:t>Biggest near-term efficiency gain at 1.8M txns/day — achievable WITHOUT replacing systems.</a:t>
             </a:r>
           </a:p>
           <a:p>
@@ -3483,12 +3464,27 @@
               </a:spcAft>
             </a:pPr>
             <a:r>
-              <a:rPr sz="1500" b="1">
+              <a:rPr sz="1400" b="1">
                 <a:solidFill>
                   <a:srgbClr val="444444"/>
                 </a:solidFill>
               </a:rPr>
-              <a:t>R2 — Move the 59 units toward one operating model / shared services</a:t>
+              <a:t>3.  S4 — Rebalance the two central teams (fill Team 1 vacancies / shift workload)</a:t>
+            </a:r>
+          </a:p>
+          <a:p>
+            <a:pPr lvl="2">
+              <a:spcAft>
+                <a:spcPts val="600"/>
+              </a:spcAft>
+            </a:pPr>
+            <a:r>
+              <a:rPr sz="1300" b="0">
+                <a:solidFill>
+                  <a:srgbClr val="444444"/>
+                </a:solidFill>
+              </a:rPr>
+              <a:t>Fast operational win that lifts throughput and morale.</a:t>
             </a:r>
           </a:p>
           <a:p>
@@ -3498,12 +3494,12 @@
               </a:spcAft>
             </a:pPr>
             <a:r>
-              <a:rPr sz="1600" b="0" i="1">
+              <a:rPr sz="1500" b="0" i="1">
                 <a:solidFill>
                   <a:srgbClr val="C0392B"/>
                 </a:solidFill>
               </a:rPr>
-              <a:t>Assumption: a full ERP consolidation is NOT assumed to be the right answer yet — it should be a business case decided on spend, cost-to-serve and lock-in data.</a:t>
+              <a:t>Assumption: these three deliver most of the benefit; bigger structural changes are deferred until data justifies them.</a:t>
             </a:r>
           </a:p>
         </p:txBody>
@@ -3554,7 +3550,7 @@
                   <a:srgbClr val="1F3864"/>
                 </a:solidFill>
               </a:rPr>
-              <a:t>Risks, dependencies &amp; organisational factors</a:t>
+              <a:t>Longer-term — only if the data justifies it</a:t>
             </a:r>
           </a:p>
         </p:txBody>
@@ -3587,12 +3583,57 @@
               </a:spcAft>
             </a:pPr>
             <a:r>
-              <a:rPr sz="1700" b="0">
+              <a:rPr sz="1600" b="0">
                 <a:solidFill>
                   <a:srgbClr val="444444"/>
                 </a:solidFill>
               </a:rPr>
-              <a:t>Cultural resistance from 59 autonomous units to giving up control</a:t>
+              <a:t>These are higher cost / higher risk, so treat as later-stage options, not day-one commitments:</a:t>
+            </a:r>
+          </a:p>
+          <a:p>
+            <a:pPr lvl="1">
+              <a:spcAft>
+                <a:spcPts val="600"/>
+              </a:spcAft>
+            </a:pPr>
+            <a:r>
+              <a:rPr sz="1500" b="1">
+                <a:solidFill>
+                  <a:srgbClr val="444444"/>
+                </a:solidFill>
+              </a:rPr>
+              <a:t>R4 — Consolidate / better integrate the ERPs (Oracle, SAP, PeopleSoft)</a:t>
+            </a:r>
+          </a:p>
+          <a:p>
+            <a:pPr lvl="1">
+              <a:spcAft>
+                <a:spcPts val="600"/>
+              </a:spcAft>
+            </a:pPr>
+            <a:r>
+              <a:rPr sz="1500" b="1">
+                <a:solidFill>
+                  <a:srgbClr val="444444"/>
+                </a:solidFill>
+              </a:rPr>
+              <a:t>S2 — Rationalise the supplier base to rebuild buying leverage</a:t>
+            </a:r>
+          </a:p>
+          <a:p>
+            <a:pPr lvl="1">
+              <a:spcAft>
+                <a:spcPts val="600"/>
+              </a:spcAft>
+            </a:pPr>
+            <a:r>
+              <a:rPr sz="1500" b="1">
+                <a:solidFill>
+                  <a:srgbClr val="444444"/>
+                </a:solidFill>
+              </a:rPr>
+              <a:t>R2 — Move the 59 units toward one operating model / shared services</a:t>
             </a:r>
           </a:p>
           <a:p>
@@ -3602,87 +3643,12 @@
               </a:spcAft>
             </a:pPr>
             <a:r>
-              <a:rPr sz="1700" b="1">
-                <a:solidFill>
-                  <a:srgbClr val="1F3864"/>
-                </a:solidFill>
-              </a:rPr>
-              <a:t>Lack of executive support is itself the #1 dependency — the plan stalls without it</a:t>
-            </a:r>
-          </a:p>
-          <a:p>
-            <a:pPr>
-              <a:spcAft>
-                <a:spcPts val="600"/>
-              </a:spcAft>
-            </a:pPr>
-            <a:r>
-              <a:rPr sz="1700" b="0">
-                <a:solidFill>
-                  <a:srgbClr val="444444"/>
-                </a:solidFill>
-              </a:rPr>
-              <a:t>ERP consolidation carries cost, business-continuity and data-migration risk</a:t>
-            </a:r>
-          </a:p>
-          <a:p>
-            <a:pPr>
-              <a:spcAft>
-                <a:spcPts val="600"/>
-              </a:spcAft>
-            </a:pPr>
-            <a:r>
-              <a:rPr sz="1700" b="0">
-                <a:solidFill>
-                  <a:srgbClr val="444444"/>
-                </a:solidFill>
-              </a:rPr>
-              <a:t>Multinational complexity — local tax / statutory / regulatory rules limit a single standard</a:t>
-            </a:r>
-          </a:p>
-          <a:p>
-            <a:pPr>
-              <a:spcAft>
-                <a:spcPts val="600"/>
-              </a:spcAft>
-            </a:pPr>
-            <a:r>
-              <a:rPr sz="1700" b="0">
-                <a:solidFill>
-                  <a:srgbClr val="444444"/>
-                </a:solidFill>
-              </a:rPr>
-              <a:t>Low morale + thin Team 1 capacity — limited bandwidth to absorb change work</a:t>
-            </a:r>
-          </a:p>
-          <a:p>
-            <a:pPr>
-              <a:spcAft>
-                <a:spcPts val="600"/>
-              </a:spcAft>
-            </a:pPr>
-            <a:r>
-              <a:rPr sz="1700" b="0">
-                <a:solidFill>
-                  <a:srgbClr val="444444"/>
-                </a:solidFill>
-              </a:rPr>
-              <a:t>Ongoing M&amp;A may keep re-introducing fragmentation</a:t>
-            </a:r>
-          </a:p>
-          <a:p>
-            <a:pPr>
-              <a:spcAft>
-                <a:spcPts val="600"/>
-              </a:spcAft>
-            </a:pPr>
-            <a:r>
-              <a:rPr sz="1700" b="0">
-                <a:solidFill>
-                  <a:srgbClr val="444444"/>
-                </a:solidFill>
-              </a:rPr>
-              <a:t>Contractual lock-ins on systems and suppliers</a:t>
+              <a:rPr sz="1600" b="0" i="1">
+                <a:solidFill>
+                  <a:srgbClr val="C0392B"/>
+                </a:solidFill>
+              </a:rPr>
+              <a:t>Assumption: a full ERP consolidation is NOT assumed to be the right answer yet — it should be a business case decided on spend, cost-to-serve and lock-in data.</a:t>
             </a:r>
           </a:p>
         </p:txBody>
@@ -3733,7 +3699,7 @@
                   <a:srgbClr val="1F3864"/>
                 </a:solidFill>
               </a:rPr>
-              <a:t>Information needed before confirming priorities</a:t>
+              <a:t>Risks, dependencies &amp; organisational factors</a:t>
             </a:r>
           </a:p>
         </p:txBody>
@@ -3771,7 +3737,7 @@
                   <a:srgbClr val="444444"/>
                 </a:solidFill>
               </a:rPr>
-              <a:t>Spend cube — spend by unit / category / supplier, and supplier overlap across units</a:t>
+              <a:t>Cultural resistance from 59 autonomous units to giving up control</a:t>
             </a:r>
           </a:p>
           <a:p>
@@ -3781,12 +3747,27 @@
               </a:spcAft>
             </a:pPr>
             <a:r>
+              <a:rPr sz="1700" b="1">
+                <a:solidFill>
+                  <a:srgbClr val="1F3864"/>
+                </a:solidFill>
+              </a:rPr>
+              <a:t>Lack of executive support is itself the #1 dependency — the plan stalls without it</a:t>
+            </a:r>
+          </a:p>
+          <a:p>
+            <a:pPr>
+              <a:spcAft>
+                <a:spcPts val="600"/>
+              </a:spcAft>
+            </a:pPr>
+            <a:r>
               <a:rPr sz="1700" b="0">
                 <a:solidFill>
                   <a:srgbClr val="444444"/>
                 </a:solidFill>
               </a:rPr>
-              <a:t>Invoice volumes, cycle times, late-payment penalties, error / maverick-spend rates</a:t>
+              <a:t>ERP consolidation carries cost, business-continuity and data-migration risk</a:t>
             </a:r>
           </a:p>
           <a:p>
@@ -3801,7 +3782,7 @@
                   <a:srgbClr val="444444"/>
                 </a:solidFill>
               </a:rPr>
-              <a:t>Cost of running the three ERPs (licences + support)</a:t>
+              <a:t>Multinational complexity — local tax / statutory / regulatory rules limit a single standard</a:t>
             </a:r>
           </a:p>
           <a:p>
@@ -3816,7 +3797,7 @@
                   <a:srgbClr val="444444"/>
                 </a:solidFill>
               </a:rPr>
-              <a:t>Share of the 1.8M daily transactions that is low-value/tail vs strategic, and cost-to-process per order</a:t>
+              <a:t>Low morale + thin Team 1 capacity — limited bandwidth to absorb change work</a:t>
             </a:r>
           </a:p>
           <a:p>
@@ -3831,7 +3812,7 @@
                   <a:srgbClr val="444444"/>
                 </a:solidFill>
               </a:rPr>
-              <a:t>Number of catalogue items and contracts; contractual lock-ins</a:t>
+              <a:t>Ongoing M&amp;A may keep re-introducing fragmentation</a:t>
             </a:r>
           </a:p>
           <a:p>
@@ -3846,7 +3827,7 @@
                   <a:srgbClr val="444444"/>
                 </a:solidFill>
               </a:rPr>
-              <a:t>Budget, timeline and genuine executive appetite for change</a:t>
+              <a:t>Contractual lock-ins on systems and suppliers</a:t>
             </a:r>
           </a:p>
         </p:txBody>
@@ -3897,17 +3878,7 @@
                   <a:srgbClr val="1F3864"/>
                 </a:solidFill>
               </a:rPr>
-              <a:t>Assumptions we have made</a:t>
-            </a:r>
-          </a:p>
-          <a:p>
-            <a:r>
-              <a:rPr sz="1500" i="1">
-                <a:solidFill>
-                  <a:srgbClr val="C0392B"/>
-                </a:solidFill>
-              </a:rPr>
-              <a:t>To be confirmed with the client</a:t>
+              <a:t>Information needed before confirming priorities</a:t>
             </a:r>
           </a:p>
         </p:txBody>
@@ -3940,12 +3911,12 @@
               </a:spcAft>
             </a:pPr>
             <a:r>
-              <a:rPr sz="1600" b="0" i="1">
-                <a:solidFill>
-                  <a:srgbClr val="C0392B"/>
-                </a:solidFill>
-              </a:rPr>
-              <a:t>Assumption: protracted payables are causing real cost (penalties, lost discounts) — not yet quantified.</a:t>
+              <a:rPr sz="1700" b="0">
+                <a:solidFill>
+                  <a:srgbClr val="444444"/>
+                </a:solidFill>
+              </a:rPr>
+              <a:t>Spend cube — spend by unit / category / supplier, and supplier overlap across units</a:t>
             </a:r>
           </a:p>
           <a:p>
@@ -3955,12 +3926,12 @@
               </a:spcAft>
             </a:pPr>
             <a:r>
-              <a:rPr sz="1600" b="0" i="1">
-                <a:solidFill>
-                  <a:srgbClr val="C0392B"/>
-                </a:solidFill>
-              </a:rPr>
-              <a:t>Assumption: fragmented spend is losing meaningful volume discounts across the 59 units.</a:t>
+              <a:rPr sz="1700" b="0">
+                <a:solidFill>
+                  <a:srgbClr val="444444"/>
+                </a:solidFill>
+              </a:rPr>
+              <a:t>Invoice volumes, cycle times, late-payment penalties, error / maverick-spend rates</a:t>
             </a:r>
           </a:p>
           <a:p>
@@ -3970,12 +3941,12 @@
               </a:spcAft>
             </a:pPr>
             <a:r>
-              <a:rPr sz="1600" b="0" i="1">
-                <a:solidFill>
-                  <a:srgbClr val="C0392B"/>
-                </a:solidFill>
-              </a:rPr>
-              <a:t>Assumption: a large share of the 1.8M daily transactions is low-value/tail spend that can be consolidated.</a:t>
+              <a:rPr sz="1700" b="0">
+                <a:solidFill>
+                  <a:srgbClr val="444444"/>
+                </a:solidFill>
+              </a:rPr>
+              <a:t>Cost of running the three ERPs (licences + support)</a:t>
             </a:r>
           </a:p>
           <a:p>
@@ -3985,12 +3956,12 @@
               </a:spcAft>
             </a:pPr>
             <a:r>
-              <a:rPr sz="1600" b="0" i="1">
-                <a:solidFill>
-                  <a:srgbClr val="C0392B"/>
-                </a:solidFill>
-              </a:rPr>
-              <a:t>Assumption: executive sponsorship is currently absent rather than present-but-ignored.</a:t>
+              <a:rPr sz="1700" b="0">
+                <a:solidFill>
+                  <a:srgbClr val="444444"/>
+                </a:solidFill>
+              </a:rPr>
+              <a:t>Share of the 1.8M daily transactions that is low-value/tail vs strategic, and cost-to-process per order</a:t>
             </a:r>
           </a:p>
           <a:p>
@@ -4000,12 +3971,12 @@
               </a:spcAft>
             </a:pPr>
             <a:r>
-              <a:rPr sz="1600" b="0" i="1">
-                <a:solidFill>
-                  <a:srgbClr val="C0392B"/>
-                </a:solidFill>
-              </a:rPr>
-              <a:t>Assumption: the three named ERPs are the main systems; there may be more across 59 units.</a:t>
+              <a:rPr sz="1700" b="0">
+                <a:solidFill>
+                  <a:srgbClr val="444444"/>
+                </a:solidFill>
+              </a:rPr>
+              <a:t>Number of catalogue items and contracts; contractual lock-ins</a:t>
             </a:r>
           </a:p>
           <a:p>
@@ -4015,12 +3986,12 @@
               </a:spcAft>
             </a:pPr>
             <a:r>
-              <a:rPr sz="1600" b="0" i="1">
-                <a:solidFill>
-                  <a:srgbClr val="C0392B"/>
-                </a:solidFill>
-              </a:rPr>
-              <a:t>Assumption: standardising process and catalogue delivers most of the benefit before any system replacement.</a:t>
+              <a:rPr sz="1700" b="0">
+                <a:solidFill>
+                  <a:srgbClr val="444444"/>
+                </a:solidFill>
+              </a:rPr>
+              <a:t>Budget, timeline and genuine executive appetite for change</a:t>
             </a:r>
           </a:p>
         </p:txBody>
@@ -4071,6 +4042,180 @@
                   <a:srgbClr val="1F3864"/>
                 </a:solidFill>
               </a:rPr>
+              <a:t>Assumptions we have made</a:t>
+            </a:r>
+          </a:p>
+          <a:p>
+            <a:r>
+              <a:rPr sz="1500" i="1">
+                <a:solidFill>
+                  <a:srgbClr val="C0392B"/>
+                </a:solidFill>
+              </a:rPr>
+              <a:t>To be confirmed with the client</a:t>
+            </a:r>
+          </a:p>
+        </p:txBody>
+      </p:sp>
+      <p:sp>
+        <p:nvSpPr>
+          <p:cNvPr id="3" name="TextBox 2"/>
+          <p:cNvSpPr txBox="1"/>
+          <p:nvPr/>
+        </p:nvSpPr>
+        <p:spPr>
+          <a:xfrm>
+            <a:off x="548640" y="1371600"/>
+            <a:ext cx="11064240" cy="5029200"/>
+          </a:xfrm>
+          <a:prstGeom prst="rect">
+            <a:avLst/>
+          </a:prstGeom>
+          <a:noFill/>
+        </p:spPr>
+        <p:txBody>
+          <a:bodyPr wrap="square">
+            <a:spAutoFit/>
+          </a:bodyPr>
+          <a:lstStyle/>
+          <a:p>
+            <a:pPr>
+              <a:spcAft>
+                <a:spcPts val="600"/>
+              </a:spcAft>
+            </a:pPr>
+            <a:r>
+              <a:rPr sz="1600" b="0" i="1">
+                <a:solidFill>
+                  <a:srgbClr val="C0392B"/>
+                </a:solidFill>
+              </a:rPr>
+              <a:t>Assumption: protracted payables are causing real cost (penalties, lost discounts) — not yet quantified.</a:t>
+            </a:r>
+          </a:p>
+          <a:p>
+            <a:pPr>
+              <a:spcAft>
+                <a:spcPts val="600"/>
+              </a:spcAft>
+            </a:pPr>
+            <a:r>
+              <a:rPr sz="1600" b="0" i="1">
+                <a:solidFill>
+                  <a:srgbClr val="C0392B"/>
+                </a:solidFill>
+              </a:rPr>
+              <a:t>Assumption: fragmented spend is losing meaningful volume discounts across the 59 units.</a:t>
+            </a:r>
+          </a:p>
+          <a:p>
+            <a:pPr>
+              <a:spcAft>
+                <a:spcPts val="600"/>
+              </a:spcAft>
+            </a:pPr>
+            <a:r>
+              <a:rPr sz="1600" b="0" i="1">
+                <a:solidFill>
+                  <a:srgbClr val="C0392B"/>
+                </a:solidFill>
+              </a:rPr>
+              <a:t>Assumption: a large share of the 1.8M daily transactions is low-value/tail spend that can be consolidated.</a:t>
+            </a:r>
+          </a:p>
+          <a:p>
+            <a:pPr>
+              <a:spcAft>
+                <a:spcPts val="600"/>
+              </a:spcAft>
+            </a:pPr>
+            <a:r>
+              <a:rPr sz="1600" b="0" i="1">
+                <a:solidFill>
+                  <a:srgbClr val="C0392B"/>
+                </a:solidFill>
+              </a:rPr>
+              <a:t>Assumption: executive sponsorship is currently absent rather than present-but-ignored.</a:t>
+            </a:r>
+          </a:p>
+          <a:p>
+            <a:pPr>
+              <a:spcAft>
+                <a:spcPts val="600"/>
+              </a:spcAft>
+            </a:pPr>
+            <a:r>
+              <a:rPr sz="1600" b="0" i="1">
+                <a:solidFill>
+                  <a:srgbClr val="C0392B"/>
+                </a:solidFill>
+              </a:rPr>
+              <a:t>Assumption: the three named ERPs are the main systems; there may be more across 59 units.</a:t>
+            </a:r>
+          </a:p>
+          <a:p>
+            <a:pPr>
+              <a:spcAft>
+                <a:spcPts val="600"/>
+              </a:spcAft>
+            </a:pPr>
+            <a:r>
+              <a:rPr sz="1600" b="0" i="1">
+                <a:solidFill>
+                  <a:srgbClr val="C0392B"/>
+                </a:solidFill>
+              </a:rPr>
+              <a:t>Assumption: standardising process and catalogue delivers most of the benefit before any system replacement.</a:t>
+            </a:r>
+          </a:p>
+        </p:txBody>
+      </p:sp>
+    </p:spTree>
+  </p:cSld>
+  <p:clrMapOvr>
+    <a:masterClrMapping/>
+  </p:clrMapOvr>
+</p:sld>
+</file>
+
+<file path=ppt/slides/slide16.xml><?xml version="1.0" encoding="utf-8"?>
+<p:sld xmlns:a="http://schemas.openxmlformats.org/drawingml/2006/main" xmlns:p="http://schemas.openxmlformats.org/presentationml/2006/main" xmlns:r="http://schemas.openxmlformats.org/officeDocument/2006/relationships">
+  <p:cSld>
+    <p:spTree>
+      <p:nvGrpSpPr>
+        <p:cNvPr id="1" name=""/>
+        <p:cNvGrpSpPr/>
+        <p:nvPr/>
+      </p:nvGrpSpPr>
+      <p:grpSpPr/>
+      <p:sp>
+        <p:nvSpPr>
+          <p:cNvPr id="2" name="TextBox 1"/>
+          <p:cNvSpPr txBox="1"/>
+          <p:nvPr/>
+        </p:nvSpPr>
+        <p:spPr>
+          <a:xfrm>
+            <a:off x="457200" y="274320"/>
+            <a:ext cx="11247120" cy="1005840"/>
+          </a:xfrm>
+          <a:prstGeom prst="rect">
+            <a:avLst/>
+          </a:prstGeom>
+          <a:noFill/>
+        </p:spPr>
+        <p:txBody>
+          <a:bodyPr wrap="square">
+            <a:spAutoFit/>
+          </a:bodyPr>
+          <a:lstStyle/>
+          <a:p>
+            <a:r>
+              <a:rPr sz="3000" b="1">
+                <a:solidFill>
+                  <a:srgbClr val="1F3864"/>
+                </a:solidFill>
+              </a:rPr>
               <a:t>3.  Five questions for the client</a:t>
             </a:r>
           </a:p>
@@ -5523,17 +5668,7 @@
                   <a:srgbClr val="1F3864"/>
                 </a:solidFill>
               </a:rPr>
-              <a:t>Which issue matters most?</a:t>
-            </a:r>
-          </a:p>
-          <a:p>
-            <a:r>
-              <a:rPr sz="1500" i="1">
-                <a:solidFill>
-                  <a:srgbClr val="C0392B"/>
-                </a:solidFill>
-              </a:rPr>
-              <a:t>Our view</a:t>
+              <a:t>Evidence: supplier base is fragmenting, not consolidating</a:t>
             </a:r>
           </a:p>
         </p:txBody>
@@ -5546,7 +5681,7 @@
         </p:nvSpPr>
         <p:spPr>
           <a:xfrm>
-            <a:off x="548640" y="1463040"/>
+            <a:off x="548640" y="1280160"/>
             <a:ext cx="11064240" cy="5029200"/>
           </a:xfrm>
           <a:prstGeom prst="rect">
@@ -5566,12 +5701,27 @@
               </a:spcAft>
             </a:pPr>
             <a:r>
-              <a:rPr sz="1800" b="1">
+              <a:rPr sz="1600" b="1">
                 <a:solidFill>
                   <a:srgbClr val="1F3864"/>
                 </a:solidFill>
               </a:rPr>
-              <a:t>Most important = R1: secure executive sponsorship and a governance mandate.</a:t>
+              <a:t>2023:  224 suppliers  |  $900M spend</a:t>
+            </a:r>
+          </a:p>
+          <a:p>
+            <a:pPr>
+              <a:spcAft>
+                <a:spcPts val="600"/>
+              </a:spcAft>
+            </a:pPr>
+            <a:r>
+              <a:rPr sz="1600" b="1">
+                <a:solidFill>
+                  <a:srgbClr val="1F3864"/>
+                </a:solidFill>
+              </a:rPr>
+              <a:t>2024:  264 suppliers  |  $1,045M spend</a:t>
             </a:r>
           </a:p>
           <a:p>
@@ -5581,12 +5731,12 @@
               </a:spcAft>
             </a:pPr>
             <a:r>
-              <a:rPr sz="1700" b="0">
+              <a:rPr sz="1500" b="0">
                 <a:solidFill>
                   <a:srgbClr val="444444"/>
                 </a:solidFill>
               </a:rPr>
-              <a:t>It is not the most expensive problem, but it is the dependency that unblocks everything else.</a:t>
+              <a:t>Suppliers grew +40 (+18%); spend grew +$145M (+16%).</a:t>
             </a:r>
           </a:p>
           <a:p>
@@ -5596,12 +5746,27 @@
               </a:spcAft>
             </a:pPr>
             <a:r>
-              <a:rPr sz="1700" b="0">
+              <a:rPr sz="1500" b="0">
                 <a:solidFill>
                   <a:srgbClr val="444444"/>
                 </a:solidFill>
               </a:rPr>
-              <a:t>With 59 autonomous units, you cannot standardise processes, consolidate systems or rationalise suppliers unless leadership mandates compliance.</a:t>
+              <a:t>Average spend per supplier FELL: $4.02M (2023) -&gt; $3.96M (2024).</a:t>
+            </a:r>
+          </a:p>
+          <a:p>
+            <a:pPr>
+              <a:spcAft>
+                <a:spcPts val="600"/>
+              </a:spcAft>
+            </a:pPr>
+            <a:r>
+              <a:rPr sz="1600" b="1">
+                <a:solidFill>
+                  <a:srgbClr val="1F3864"/>
+                </a:solidFill>
+              </a:rPr>
+              <a:t>What this tells us:</a:t>
             </a:r>
           </a:p>
           <a:p>
@@ -5611,12 +5776,42 @@
               </a:spcAft>
             </a:pPr>
             <a:r>
-              <a:rPr sz="1700" b="0">
+              <a:rPr sz="1500" b="0">
                 <a:solidFill>
                   <a:srgbClr val="444444"/>
                 </a:solidFill>
               </a:rPr>
-              <a:t>Low cost, high leverage — fix it first.</a:t>
+              <a:t>The company is adding suppliers faster than it consolidates them — so rising spend is NOT translating into better buying leverage.</a:t>
+            </a:r>
+          </a:p>
+          <a:p>
+            <a:pPr lvl="1">
+              <a:spcAft>
+                <a:spcPts val="600"/>
+              </a:spcAft>
+            </a:pPr>
+            <a:r>
+              <a:rPr sz="1500" b="0">
+                <a:solidFill>
+                  <a:srgbClr val="444444"/>
+                </a:solidFill>
+              </a:rPr>
+              <a:t>This is direct evidence for S2 (lost economies of scale) and the fragmented supplier base (R2).</a:t>
+            </a:r>
+          </a:p>
+          <a:p>
+            <a:pPr>
+              <a:spcAft>
+                <a:spcPts val="600"/>
+              </a:spcAft>
+            </a:pPr>
+            <a:r>
+              <a:rPr sz="1600" b="0" i="1">
+                <a:solidFill>
+                  <a:srgbClr val="C0392B"/>
+                </a:solidFill>
+              </a:rPr>
+              <a:t>Assumption: these figures are group-wide across the 59 units; a per-unit / per-category split would sharpen the consolidation opportunity.</a:t>
             </a:r>
           </a:p>
         </p:txBody>

</xml_diff>

<commit_message>
Tighten deck to 12 high-impact slides
Consolidate root causes and symptoms, keep the supplier-trend evidence, and add a closing summary while covering all required elements.

https://claude.ai/code/session_014EpSpf3QcBHWNPw4UskYmj
</commit_message>
<xml_diff>
--- a/NextTech_Procurement_Analysis.pptx
+++ b/NextTech_Procurement_Analysis.pptx
@@ -17,10 +17,6 @@
     <p:sldId id="265" r:id="rId16"/>
     <p:sldId id="266" r:id="rId17"/>
     <p:sldId id="267" r:id="rId18"/>
-    <p:sldId id="268" r:id="rId19"/>
-    <p:sldId id="269" r:id="rId20"/>
-    <p:sldId id="270" r:id="rId21"/>
-    <p:sldId id="271" r:id="rId22"/>
   </p:sldIdLst>
   <p:sldSz cx="12191695" cy="6858000" type="screen4x3"/>
   <p:notesSz cx="6858000" cy="9144000"/>
@@ -3111,8 +3107,8 @@
         </p:nvSpPr>
         <p:spPr>
           <a:xfrm>
-            <a:off x="731520" y="2377440"/>
-            <a:ext cx="10698480" cy="2286000"/>
+            <a:off x="731520" y="2286000"/>
+            <a:ext cx="10698480" cy="2377440"/>
           </a:xfrm>
           <a:prstGeom prst="rect">
             <a:avLst/>
@@ -3131,7 +3127,7 @@
                   <a:srgbClr val="1F3864"/>
                 </a:solidFill>
               </a:rPr>
-              <a:t>Procurement Transformation — Problem Analysis &amp; Prioritisation</a:t>
+              <a:t>Procurement Problem Analysis &amp; Prioritisation</a:t>
             </a:r>
           </a:p>
           <a:p>
@@ -3141,7 +3137,7 @@
                   <a:srgbClr val="444444"/>
                 </a:solidFill>
               </a:rPr>
-              <a:t>Client: Multinational Semiconductor Major  |  Prepared for the Manager's internal review</a:t>
+              <a:t>Client: Multinational Semiconductor Major  |  Manager's internal review</a:t>
             </a:r>
           </a:p>
           <a:p>
@@ -3151,7 +3147,7 @@
                   <a:srgbClr val="C0392B"/>
                 </a:solidFill>
               </a:rPr>
-              <a:t>1. The issues   2. Prioritisation   3. Questions for the client</a:t>
+              <a:t>1. The issues, evidence &amp; impact   2. Prioritisation   3. Questions for the client</a:t>
             </a:r>
           </a:p>
         </p:txBody>
@@ -3197,22 +3193,12 @@
           <a:lstStyle/>
           <a:p>
             <a:r>
-              <a:rPr sz="3000" b="1">
+              <a:rPr sz="2800" b="1">
                 <a:solidFill>
                   <a:srgbClr val="1F3864"/>
                 </a:solidFill>
               </a:rPr>
-              <a:t>Which issue matters most?</a:t>
-            </a:r>
-          </a:p>
-          <a:p>
-            <a:r>
-              <a:rPr sz="1500" i="1">
-                <a:solidFill>
-                  <a:srgbClr val="C0392B"/>
-                </a:solidFill>
-              </a:rPr>
-              <a:t>Our view</a:t>
+              <a:t>Information needed before confirming priorities</a:t>
             </a:r>
           </a:p>
         </p:txBody>
@@ -3225,8 +3211,8 @@
         </p:nvSpPr>
         <p:spPr>
           <a:xfrm>
-            <a:off x="548640" y="1463040"/>
-            <a:ext cx="11064240" cy="5029200"/>
+            <a:off x="548640" y="1371600"/>
+            <a:ext cx="11064240" cy="5120640"/>
           </a:xfrm>
           <a:prstGeom prst="rect">
             <a:avLst/>
@@ -3241,22 +3227,7 @@
           <a:p>
             <a:pPr>
               <a:spcAft>
-                <a:spcPts val="600"/>
-              </a:spcAft>
-            </a:pPr>
-            <a:r>
-              <a:rPr sz="1800" b="1">
-                <a:solidFill>
-                  <a:srgbClr val="1F3864"/>
-                </a:solidFill>
-              </a:rPr>
-              <a:t>Most important = R1: secure executive sponsorship and a governance mandate.</a:t>
-            </a:r>
-          </a:p>
-          <a:p>
-            <a:pPr lvl="1">
-              <a:spcAft>
-                <a:spcPts val="600"/>
+                <a:spcPts val="500"/>
               </a:spcAft>
             </a:pPr>
             <a:r>
@@ -3265,13 +3236,13 @@
                   <a:srgbClr val="444444"/>
                 </a:solidFill>
               </a:rPr>
-              <a:t>It is not the most expensive problem, but it is the dependency that unblocks everything else.</a:t>
-            </a:r>
-          </a:p>
-          <a:p>
-            <a:pPr lvl="1">
-              <a:spcAft>
-                <a:spcPts val="600"/>
+              <a:t>Spend by unit / category / supplier, and supplier overlap across units.</a:t>
+            </a:r>
+          </a:p>
+          <a:p>
+            <a:pPr>
+              <a:spcAft>
+                <a:spcPts val="500"/>
               </a:spcAft>
             </a:pPr>
             <a:r>
@@ -3280,13 +3251,13 @@
                   <a:srgbClr val="444444"/>
                 </a:solidFill>
               </a:rPr>
-              <a:t>With 59 autonomous units, you cannot standardise processes, consolidate systems or rationalise suppliers unless leadership mandates compliance.</a:t>
-            </a:r>
-          </a:p>
-          <a:p>
-            <a:pPr lvl="1">
-              <a:spcAft>
-                <a:spcPts val="600"/>
+              <a:t>Invoice volumes, cycle times, late-payment penalties and maverick-spend rates.</a:t>
+            </a:r>
+          </a:p>
+          <a:p>
+            <a:pPr>
+              <a:spcAft>
+                <a:spcPts val="500"/>
               </a:spcAft>
             </a:pPr>
             <a:r>
@@ -3295,7 +3266,52 @@
                   <a:srgbClr val="444444"/>
                 </a:solidFill>
               </a:rPr>
-              <a:t>Low cost, high leverage — fix it first.</a:t>
+              <a:t>Cost of running the three ERPs (licences + support).</a:t>
+            </a:r>
+          </a:p>
+          <a:p>
+            <a:pPr>
+              <a:spcAft>
+                <a:spcPts val="500"/>
+              </a:spcAft>
+            </a:pPr>
+            <a:r>
+              <a:rPr sz="1700" b="0">
+                <a:solidFill>
+                  <a:srgbClr val="444444"/>
+                </a:solidFill>
+              </a:rPr>
+              <a:t>Share of the 1.8M daily transactions that is low-value/tail vs strategic, and cost-to-process per order.</a:t>
+            </a:r>
+          </a:p>
+          <a:p>
+            <a:pPr>
+              <a:spcAft>
+                <a:spcPts val="500"/>
+              </a:spcAft>
+            </a:pPr>
+            <a:r>
+              <a:rPr sz="1700" b="0">
+                <a:solidFill>
+                  <a:srgbClr val="444444"/>
+                </a:solidFill>
+              </a:rPr>
+              <a:t>Number of catalogue items and contracts; contractual lock-ins.</a:t>
+            </a:r>
+          </a:p>
+          <a:p>
+            <a:pPr>
+              <a:spcAft>
+                <a:spcPts val="500"/>
+              </a:spcAft>
+            </a:pPr>
+            <a:r>
+              <a:rPr sz="1700" b="0">
+                <a:solidFill>
+                  <a:srgbClr val="444444"/>
+                </a:solidFill>
+              </a:rPr>
+              <a:t>Budget, timeline and genuine executive appetite for change.</a:t>
             </a:r>
           </a:p>
         </p:txBody>
@@ -3341,12 +3357,12 @@
           <a:lstStyle/>
           <a:p>
             <a:r>
-              <a:rPr sz="3000" b="1">
+              <a:rPr sz="2800" b="1">
                 <a:solidFill>
                   <a:srgbClr val="1F3864"/>
                 </a:solidFill>
               </a:rPr>
-              <a:t>2.  Prioritisation</a:t>
+              <a:t>3. Five questions for the client</a:t>
             </a:r>
           </a:p>
           <a:p>
@@ -3356,7 +3372,7 @@
                   <a:srgbClr val="C0392B"/>
                 </a:solidFill>
               </a:rPr>
-              <a:t>Three high-impact moves first — not a full redesign</a:t>
+              <a:t>To better inform our work</a:t>
             </a:r>
           </a:p>
         </p:txBody>
@@ -3370,7 +3386,7 @@
         <p:spPr>
           <a:xfrm>
             <a:off x="548640" y="1280160"/>
-            <a:ext cx="11064240" cy="5029200"/>
+            <a:ext cx="11064240" cy="5120640"/>
           </a:xfrm>
           <a:prstGeom prst="rect">
             <a:avLst/>
@@ -3385,121 +3401,76 @@
           <a:p>
             <a:pPr>
               <a:spcAft>
-                <a:spcPts val="600"/>
-              </a:spcAft>
-            </a:pPr>
-            <a:r>
-              <a:rPr sz="1500" b="0">
-                <a:solidFill>
-                  <a:srgbClr val="444444"/>
-                </a:solidFill>
-              </a:rPr>
-              <a:t>We deliberately focus on a few high-impact, low-disruption actions rather than a multi-year transformation:</a:t>
-            </a:r>
-          </a:p>
-          <a:p>
-            <a:pPr lvl="1">
-              <a:spcAft>
-                <a:spcPts val="600"/>
-              </a:spcAft>
-            </a:pPr>
-            <a:r>
-              <a:rPr sz="1400" b="1">
-                <a:solidFill>
-                  <a:srgbClr val="444444"/>
-                </a:solidFill>
-              </a:rPr>
-              <a:t>1.  R1 — Secure executive sponsorship &amp; a compliance mandate</a:t>
-            </a:r>
-          </a:p>
-          <a:p>
-            <a:pPr lvl="2">
-              <a:spcAft>
-                <a:spcPts val="600"/>
-              </a:spcAft>
-            </a:pPr>
-            <a:r>
-              <a:rPr sz="1300" b="0">
-                <a:solidFill>
-                  <a:srgbClr val="444444"/>
-                </a:solidFill>
-              </a:rPr>
-              <a:t>Low cost, fast, and unlocks every other fix. Highest leverage move available.</a:t>
-            </a:r>
-          </a:p>
-          <a:p>
-            <a:pPr lvl="1">
-              <a:spcAft>
-                <a:spcPts val="600"/>
-              </a:spcAft>
-            </a:pPr>
-            <a:r>
-              <a:rPr sz="1400" b="1">
-                <a:solidFill>
-                  <a:srgbClr val="444444"/>
-                </a:solidFill>
-              </a:rPr>
-              <a:t>2.  R3 + S3 — Standardise the procure-to-pay process &amp; rationalise catalogue / tail spend</a:t>
-            </a:r>
-          </a:p>
-          <a:p>
-            <a:pPr lvl="2">
-              <a:spcAft>
-                <a:spcPts val="600"/>
-              </a:spcAft>
-            </a:pPr>
-            <a:r>
-              <a:rPr sz="1300" b="0">
-                <a:solidFill>
-                  <a:srgbClr val="444444"/>
-                </a:solidFill>
-              </a:rPr>
-              <a:t>Biggest near-term efficiency gain at 1.8M txns/day — achievable WITHOUT replacing systems.</a:t>
-            </a:r>
-          </a:p>
-          <a:p>
-            <a:pPr lvl="1">
-              <a:spcAft>
-                <a:spcPts val="600"/>
-              </a:spcAft>
-            </a:pPr>
-            <a:r>
-              <a:rPr sz="1400" b="1">
-                <a:solidFill>
-                  <a:srgbClr val="444444"/>
-                </a:solidFill>
-              </a:rPr>
-              <a:t>3.  S4 — Rebalance the two central teams (fill Team 1 vacancies / shift workload)</a:t>
-            </a:r>
-          </a:p>
-          <a:p>
-            <a:pPr lvl="2">
-              <a:spcAft>
-                <a:spcPts val="600"/>
-              </a:spcAft>
-            </a:pPr>
-            <a:r>
-              <a:rPr sz="1300" b="0">
-                <a:solidFill>
-                  <a:srgbClr val="444444"/>
-                </a:solidFill>
-              </a:rPr>
-              <a:t>Fast operational win that lifts throughput and morale.</a:t>
+                <a:spcPts val="500"/>
+              </a:spcAft>
+            </a:pPr>
+            <a:r>
+              <a:rPr sz="1500" b="1">
+                <a:solidFill>
+                  <a:srgbClr val="1F3864"/>
+                </a:solidFill>
+              </a:rPr>
+              <a:t>1.  Spend &amp; suppliers — total spend, split across the 59 units, and how much supplier overlap exists between them?</a:t>
             </a:r>
           </a:p>
           <a:p>
             <a:pPr>
               <a:spcAft>
-                <a:spcPts val="600"/>
-              </a:spcAft>
-            </a:pPr>
-            <a:r>
-              <a:rPr sz="1500" b="0" i="1">
-                <a:solidFill>
-                  <a:srgbClr val="C0392B"/>
-                </a:solidFill>
-              </a:rPr>
-              <a:t>Assumption: these three deliver most of the benefit; bigger structural changes are deferred until data justifies them.</a:t>
+                <a:spcPts val="500"/>
+              </a:spcAft>
+            </a:pPr>
+            <a:r>
+              <a:rPr sz="1500" b="1">
+                <a:solidFill>
+                  <a:srgbClr val="1F3864"/>
+                </a:solidFill>
+              </a:rPr>
+              <a:t>2.  Governance — is there executive appetite to mandate a single, compliant operating model, and who would sponsor it?</a:t>
+            </a:r>
+          </a:p>
+          <a:p>
+            <a:pPr>
+              <a:spcAft>
+                <a:spcPts val="500"/>
+              </a:spcAft>
+            </a:pPr>
+            <a:r>
+              <a:rPr sz="1500" b="1">
+                <a:solidFill>
+                  <a:srgbClr val="1F3864"/>
+                </a:solidFill>
+              </a:rPr>
+              <a:t>3.  Transaction mix — of the 1.8M daily transactions, what share is low-value/tail, and what does one order cost to process today?</a:t>
+            </a:r>
+          </a:p>
+          <a:p>
+            <a:pPr>
+              <a:spcAft>
+                <a:spcPts val="500"/>
+              </a:spcAft>
+            </a:pPr>
+            <a:r>
+              <a:rPr sz="1500" b="1">
+                <a:solidFill>
+                  <a:srgbClr val="1F3864"/>
+                </a:solidFill>
+              </a:rPr>
+              <a:t>4.  Systems — is ERP consolidation on the table, what lock-ins exist, and is the target shared services or continued unit autonomy?</a:t>
+            </a:r>
+          </a:p>
+          <a:p>
+            <a:pPr>
+              <a:spcAft>
+                <a:spcPts val="500"/>
+              </a:spcAft>
+            </a:pPr>
+            <a:r>
+              <a:rPr sz="1500" b="1">
+                <a:solidFill>
+                  <a:srgbClr val="1F3864"/>
+                </a:solidFill>
+              </a:rPr>
+              <a:t>5.  People — what's driving low morale, are Team 1's vacancies funded, and can resource move between the two teams?</a:t>
             </a:r>
           </a:p>
         </p:txBody>
@@ -3545,12 +3516,12 @@
           <a:lstStyle/>
           <a:p>
             <a:r>
-              <a:rPr sz="3000" b="1">
+              <a:rPr sz="2800" b="1">
                 <a:solidFill>
                   <a:srgbClr val="1F3864"/>
                 </a:solidFill>
               </a:rPr>
-              <a:t>Longer-term — only if the data justifies it</a:t>
+              <a:t>In summary</a:t>
             </a:r>
           </a:p>
         </p:txBody>
@@ -3563,8 +3534,8 @@
         </p:nvSpPr>
         <p:spPr>
           <a:xfrm>
-            <a:off x="548640" y="1371600"/>
-            <a:ext cx="11064240" cy="5029200"/>
+            <a:off x="548640" y="1463040"/>
+            <a:ext cx="11064240" cy="5120640"/>
           </a:xfrm>
           <a:prstGeom prst="rect">
             <a:avLst/>
@@ -3579,752 +3550,76 @@
           <a:p>
             <a:pPr>
               <a:spcAft>
-                <a:spcPts val="600"/>
-              </a:spcAft>
-            </a:pPr>
-            <a:r>
-              <a:rPr sz="1600" b="0">
+                <a:spcPts val="500"/>
+              </a:spcAft>
+            </a:pPr>
+            <a:r>
+              <a:rPr sz="1700" b="1">
+                <a:solidFill>
+                  <a:srgbClr val="1F3864"/>
+                </a:solidFill>
+              </a:rPr>
+              <a:t>The real problem: one company is run as 59, so spend, suppliers and systems keep fragmenting.</a:t>
+            </a:r>
+          </a:p>
+          <a:p>
+            <a:pPr>
+              <a:spcAft>
+                <a:spcPts val="500"/>
+              </a:spcAft>
+            </a:pPr>
+            <a:r>
+              <a:rPr sz="1700" b="1">
+                <a:solidFill>
+                  <a:srgbClr val="1F3864"/>
+                </a:solidFill>
+              </a:rPr>
+              <a:t>Most important issue: no executive mandate to enforce standardisation (R1) — it blocks everything else.</a:t>
+            </a:r>
+          </a:p>
+          <a:p>
+            <a:pPr>
+              <a:spcAft>
+                <a:spcPts val="500"/>
+              </a:spcAft>
+            </a:pPr>
+            <a:r>
+              <a:rPr sz="1700" b="1">
+                <a:solidFill>
+                  <a:srgbClr val="1F3864"/>
+                </a:solidFill>
+              </a:rPr>
+              <a:t>Recommended now: 1) get exec sponsorship, 2) standardise P2P + tail spend, 3) rebalance the teams.</a:t>
+            </a:r>
+          </a:p>
+          <a:p>
+            <a:pPr>
+              <a:spcAft>
+                <a:spcPts val="500"/>
+              </a:spcAft>
+            </a:pPr>
+            <a:r>
+              <a:rPr sz="1700" b="0">
                 <a:solidFill>
                   <a:srgbClr val="444444"/>
                 </a:solidFill>
               </a:rPr>
-              <a:t>These are higher cost / higher risk, so treat as later-stage options, not day-one commitments:</a:t>
-            </a:r>
-          </a:p>
-          <a:p>
-            <a:pPr lvl="1">
-              <a:spcAft>
-                <a:spcPts val="600"/>
-              </a:spcAft>
-            </a:pPr>
-            <a:r>
-              <a:rPr sz="1500" b="1">
+              <a:t>Later, only if the data supports it: ERP consolidation, supplier rationalisation, shared services.</a:t>
+            </a:r>
+          </a:p>
+          <a:p>
+            <a:pPr>
+              <a:spcAft>
+                <a:spcPts val="500"/>
+              </a:spcAft>
+            </a:pPr>
+            <a:r>
+              <a:rPr sz="1700" b="0">
                 <a:solidFill>
                   <a:srgbClr val="444444"/>
                 </a:solidFill>
               </a:rPr>
-              <a:t>R4 — Consolidate / better integrate the ERPs (Oracle, SAP, PeopleSoft)</a:t>
-            </a:r>
-          </a:p>
-          <a:p>
-            <a:pPr lvl="1">
-              <a:spcAft>
-                <a:spcPts val="600"/>
-              </a:spcAft>
-            </a:pPr>
-            <a:r>
-              <a:rPr sz="1500" b="1">
-                <a:solidFill>
-                  <a:srgbClr val="444444"/>
-                </a:solidFill>
-              </a:rPr>
-              <a:t>S2 — Rationalise the supplier base to rebuild buying leverage</a:t>
-            </a:r>
-          </a:p>
-          <a:p>
-            <a:pPr lvl="1">
-              <a:spcAft>
-                <a:spcPts val="600"/>
-              </a:spcAft>
-            </a:pPr>
-            <a:r>
-              <a:rPr sz="1500" b="1">
-                <a:solidFill>
-                  <a:srgbClr val="444444"/>
-                </a:solidFill>
-              </a:rPr>
-              <a:t>R2 — Move the 59 units toward one operating model / shared services</a:t>
-            </a:r>
-          </a:p>
-          <a:p>
-            <a:pPr>
-              <a:spcAft>
-                <a:spcPts val="600"/>
-              </a:spcAft>
-            </a:pPr>
-            <a:r>
-              <a:rPr sz="1600" b="0" i="1">
-                <a:solidFill>
-                  <a:srgbClr val="C0392B"/>
-                </a:solidFill>
-              </a:rPr>
-              <a:t>Assumption: a full ERP consolidation is NOT assumed to be the right answer yet — it should be a business case decided on spend, cost-to-serve and lock-in data.</a:t>
-            </a:r>
-          </a:p>
-        </p:txBody>
-      </p:sp>
-    </p:spTree>
-  </p:cSld>
-  <p:clrMapOvr>
-    <a:masterClrMapping/>
-  </p:clrMapOvr>
-</p:sld>
-</file>
-
-<file path=ppt/slides/slide13.xml><?xml version="1.0" encoding="utf-8"?>
-<p:sld xmlns:a="http://schemas.openxmlformats.org/drawingml/2006/main" xmlns:p="http://schemas.openxmlformats.org/presentationml/2006/main" xmlns:r="http://schemas.openxmlformats.org/officeDocument/2006/relationships">
-  <p:cSld>
-    <p:spTree>
-      <p:nvGrpSpPr>
-        <p:cNvPr id="1" name=""/>
-        <p:cNvGrpSpPr/>
-        <p:nvPr/>
-      </p:nvGrpSpPr>
-      <p:grpSpPr/>
-      <p:sp>
-        <p:nvSpPr>
-          <p:cNvPr id="2" name="TextBox 1"/>
-          <p:cNvSpPr txBox="1"/>
-          <p:nvPr/>
-        </p:nvSpPr>
-        <p:spPr>
-          <a:xfrm>
-            <a:off x="457200" y="274320"/>
-            <a:ext cx="11247120" cy="1005840"/>
-          </a:xfrm>
-          <a:prstGeom prst="rect">
-            <a:avLst/>
-          </a:prstGeom>
-          <a:noFill/>
-        </p:spPr>
-        <p:txBody>
-          <a:bodyPr wrap="square">
-            <a:spAutoFit/>
-          </a:bodyPr>
-          <a:lstStyle/>
-          <a:p>
-            <a:r>
-              <a:rPr sz="3000" b="1">
-                <a:solidFill>
-                  <a:srgbClr val="1F3864"/>
-                </a:solidFill>
-              </a:rPr>
-              <a:t>Risks, dependencies &amp; organisational factors</a:t>
-            </a:r>
-          </a:p>
-        </p:txBody>
-      </p:sp>
-      <p:sp>
-        <p:nvSpPr>
-          <p:cNvPr id="3" name="TextBox 2"/>
-          <p:cNvSpPr txBox="1"/>
-          <p:nvPr/>
-        </p:nvSpPr>
-        <p:spPr>
-          <a:xfrm>
-            <a:off x="548640" y="1371600"/>
-            <a:ext cx="11064240" cy="5029200"/>
-          </a:xfrm>
-          <a:prstGeom prst="rect">
-            <a:avLst/>
-          </a:prstGeom>
-          <a:noFill/>
-        </p:spPr>
-        <p:txBody>
-          <a:bodyPr wrap="square">
-            <a:spAutoFit/>
-          </a:bodyPr>
-          <a:lstStyle/>
-          <a:p>
-            <a:pPr>
-              <a:spcAft>
-                <a:spcPts val="600"/>
-              </a:spcAft>
-            </a:pPr>
-            <a:r>
-              <a:rPr sz="1700" b="0">
-                <a:solidFill>
-                  <a:srgbClr val="444444"/>
-                </a:solidFill>
-              </a:rPr>
-              <a:t>Cultural resistance from 59 autonomous units to giving up control</a:t>
-            </a:r>
-          </a:p>
-          <a:p>
-            <a:pPr>
-              <a:spcAft>
-                <a:spcPts val="600"/>
-              </a:spcAft>
-            </a:pPr>
-            <a:r>
-              <a:rPr sz="1700" b="1">
-                <a:solidFill>
-                  <a:srgbClr val="1F3864"/>
-                </a:solidFill>
-              </a:rPr>
-              <a:t>Lack of executive support is itself the #1 dependency — the plan stalls without it</a:t>
-            </a:r>
-          </a:p>
-          <a:p>
-            <a:pPr>
-              <a:spcAft>
-                <a:spcPts val="600"/>
-              </a:spcAft>
-            </a:pPr>
-            <a:r>
-              <a:rPr sz="1700" b="0">
-                <a:solidFill>
-                  <a:srgbClr val="444444"/>
-                </a:solidFill>
-              </a:rPr>
-              <a:t>ERP consolidation carries cost, business-continuity and data-migration risk</a:t>
-            </a:r>
-          </a:p>
-          <a:p>
-            <a:pPr>
-              <a:spcAft>
-                <a:spcPts val="600"/>
-              </a:spcAft>
-            </a:pPr>
-            <a:r>
-              <a:rPr sz="1700" b="0">
-                <a:solidFill>
-                  <a:srgbClr val="444444"/>
-                </a:solidFill>
-              </a:rPr>
-              <a:t>Multinational complexity — local tax / statutory / regulatory rules limit a single standard</a:t>
-            </a:r>
-          </a:p>
-          <a:p>
-            <a:pPr>
-              <a:spcAft>
-                <a:spcPts val="600"/>
-              </a:spcAft>
-            </a:pPr>
-            <a:r>
-              <a:rPr sz="1700" b="0">
-                <a:solidFill>
-                  <a:srgbClr val="444444"/>
-                </a:solidFill>
-              </a:rPr>
-              <a:t>Low morale + thin Team 1 capacity — limited bandwidth to absorb change work</a:t>
-            </a:r>
-          </a:p>
-          <a:p>
-            <a:pPr>
-              <a:spcAft>
-                <a:spcPts val="600"/>
-              </a:spcAft>
-            </a:pPr>
-            <a:r>
-              <a:rPr sz="1700" b="0">
-                <a:solidFill>
-                  <a:srgbClr val="444444"/>
-                </a:solidFill>
-              </a:rPr>
-              <a:t>Ongoing M&amp;A may keep re-introducing fragmentation</a:t>
-            </a:r>
-          </a:p>
-          <a:p>
-            <a:pPr>
-              <a:spcAft>
-                <a:spcPts val="600"/>
-              </a:spcAft>
-            </a:pPr>
-            <a:r>
-              <a:rPr sz="1700" b="0">
-                <a:solidFill>
-                  <a:srgbClr val="444444"/>
-                </a:solidFill>
-              </a:rPr>
-              <a:t>Contractual lock-ins on systems and suppliers</a:t>
-            </a:r>
-          </a:p>
-        </p:txBody>
-      </p:sp>
-    </p:spTree>
-  </p:cSld>
-  <p:clrMapOvr>
-    <a:masterClrMapping/>
-  </p:clrMapOvr>
-</p:sld>
-</file>
-
-<file path=ppt/slides/slide14.xml><?xml version="1.0" encoding="utf-8"?>
-<p:sld xmlns:a="http://schemas.openxmlformats.org/drawingml/2006/main" xmlns:p="http://schemas.openxmlformats.org/presentationml/2006/main" xmlns:r="http://schemas.openxmlformats.org/officeDocument/2006/relationships">
-  <p:cSld>
-    <p:spTree>
-      <p:nvGrpSpPr>
-        <p:cNvPr id="1" name=""/>
-        <p:cNvGrpSpPr/>
-        <p:nvPr/>
-      </p:nvGrpSpPr>
-      <p:grpSpPr/>
-      <p:sp>
-        <p:nvSpPr>
-          <p:cNvPr id="2" name="TextBox 1"/>
-          <p:cNvSpPr txBox="1"/>
-          <p:nvPr/>
-        </p:nvSpPr>
-        <p:spPr>
-          <a:xfrm>
-            <a:off x="457200" y="274320"/>
-            <a:ext cx="11247120" cy="1005840"/>
-          </a:xfrm>
-          <a:prstGeom prst="rect">
-            <a:avLst/>
-          </a:prstGeom>
-          <a:noFill/>
-        </p:spPr>
-        <p:txBody>
-          <a:bodyPr wrap="square">
-            <a:spAutoFit/>
-          </a:bodyPr>
-          <a:lstStyle/>
-          <a:p>
-            <a:r>
-              <a:rPr sz="3000" b="1">
-                <a:solidFill>
-                  <a:srgbClr val="1F3864"/>
-                </a:solidFill>
-              </a:rPr>
-              <a:t>Information needed before confirming priorities</a:t>
-            </a:r>
-          </a:p>
-        </p:txBody>
-      </p:sp>
-      <p:sp>
-        <p:nvSpPr>
-          <p:cNvPr id="3" name="TextBox 2"/>
-          <p:cNvSpPr txBox="1"/>
-          <p:nvPr/>
-        </p:nvSpPr>
-        <p:spPr>
-          <a:xfrm>
-            <a:off x="548640" y="1371600"/>
-            <a:ext cx="11064240" cy="5029200"/>
-          </a:xfrm>
-          <a:prstGeom prst="rect">
-            <a:avLst/>
-          </a:prstGeom>
-          <a:noFill/>
-        </p:spPr>
-        <p:txBody>
-          <a:bodyPr wrap="square">
-            <a:spAutoFit/>
-          </a:bodyPr>
-          <a:lstStyle/>
-          <a:p>
-            <a:pPr>
-              <a:spcAft>
-                <a:spcPts val="600"/>
-              </a:spcAft>
-            </a:pPr>
-            <a:r>
-              <a:rPr sz="1700" b="0">
-                <a:solidFill>
-                  <a:srgbClr val="444444"/>
-                </a:solidFill>
-              </a:rPr>
-              <a:t>Spend cube — spend by unit / category / supplier, and supplier overlap across units</a:t>
-            </a:r>
-          </a:p>
-          <a:p>
-            <a:pPr>
-              <a:spcAft>
-                <a:spcPts val="600"/>
-              </a:spcAft>
-            </a:pPr>
-            <a:r>
-              <a:rPr sz="1700" b="0">
-                <a:solidFill>
-                  <a:srgbClr val="444444"/>
-                </a:solidFill>
-              </a:rPr>
-              <a:t>Invoice volumes, cycle times, late-payment penalties, error / maverick-spend rates</a:t>
-            </a:r>
-          </a:p>
-          <a:p>
-            <a:pPr>
-              <a:spcAft>
-                <a:spcPts val="600"/>
-              </a:spcAft>
-            </a:pPr>
-            <a:r>
-              <a:rPr sz="1700" b="0">
-                <a:solidFill>
-                  <a:srgbClr val="444444"/>
-                </a:solidFill>
-              </a:rPr>
-              <a:t>Cost of running the three ERPs (licences + support)</a:t>
-            </a:r>
-          </a:p>
-          <a:p>
-            <a:pPr>
-              <a:spcAft>
-                <a:spcPts val="600"/>
-              </a:spcAft>
-            </a:pPr>
-            <a:r>
-              <a:rPr sz="1700" b="0">
-                <a:solidFill>
-                  <a:srgbClr val="444444"/>
-                </a:solidFill>
-              </a:rPr>
-              <a:t>Share of the 1.8M daily transactions that is low-value/tail vs strategic, and cost-to-process per order</a:t>
-            </a:r>
-          </a:p>
-          <a:p>
-            <a:pPr>
-              <a:spcAft>
-                <a:spcPts val="600"/>
-              </a:spcAft>
-            </a:pPr>
-            <a:r>
-              <a:rPr sz="1700" b="0">
-                <a:solidFill>
-                  <a:srgbClr val="444444"/>
-                </a:solidFill>
-              </a:rPr>
-              <a:t>Number of catalogue items and contracts; contractual lock-ins</a:t>
-            </a:r>
-          </a:p>
-          <a:p>
-            <a:pPr>
-              <a:spcAft>
-                <a:spcPts val="600"/>
-              </a:spcAft>
-            </a:pPr>
-            <a:r>
-              <a:rPr sz="1700" b="0">
-                <a:solidFill>
-                  <a:srgbClr val="444444"/>
-                </a:solidFill>
-              </a:rPr>
-              <a:t>Budget, timeline and genuine executive appetite for change</a:t>
-            </a:r>
-          </a:p>
-        </p:txBody>
-      </p:sp>
-    </p:spTree>
-  </p:cSld>
-  <p:clrMapOvr>
-    <a:masterClrMapping/>
-  </p:clrMapOvr>
-</p:sld>
-</file>
-
-<file path=ppt/slides/slide15.xml><?xml version="1.0" encoding="utf-8"?>
-<p:sld xmlns:a="http://schemas.openxmlformats.org/drawingml/2006/main" xmlns:p="http://schemas.openxmlformats.org/presentationml/2006/main" xmlns:r="http://schemas.openxmlformats.org/officeDocument/2006/relationships">
-  <p:cSld>
-    <p:spTree>
-      <p:nvGrpSpPr>
-        <p:cNvPr id="1" name=""/>
-        <p:cNvGrpSpPr/>
-        <p:nvPr/>
-      </p:nvGrpSpPr>
-      <p:grpSpPr/>
-      <p:sp>
-        <p:nvSpPr>
-          <p:cNvPr id="2" name="TextBox 1"/>
-          <p:cNvSpPr txBox="1"/>
-          <p:nvPr/>
-        </p:nvSpPr>
-        <p:spPr>
-          <a:xfrm>
-            <a:off x="457200" y="274320"/>
-            <a:ext cx="11247120" cy="1005840"/>
-          </a:xfrm>
-          <a:prstGeom prst="rect">
-            <a:avLst/>
-          </a:prstGeom>
-          <a:noFill/>
-        </p:spPr>
-        <p:txBody>
-          <a:bodyPr wrap="square">
-            <a:spAutoFit/>
-          </a:bodyPr>
-          <a:lstStyle/>
-          <a:p>
-            <a:r>
-              <a:rPr sz="3000" b="1">
-                <a:solidFill>
-                  <a:srgbClr val="1F3864"/>
-                </a:solidFill>
-              </a:rPr>
-              <a:t>Assumptions we have made</a:t>
-            </a:r>
-          </a:p>
-          <a:p>
-            <a:r>
-              <a:rPr sz="1500" i="1">
-                <a:solidFill>
-                  <a:srgbClr val="C0392B"/>
-                </a:solidFill>
-              </a:rPr>
-              <a:t>To be confirmed with the client</a:t>
-            </a:r>
-          </a:p>
-        </p:txBody>
-      </p:sp>
-      <p:sp>
-        <p:nvSpPr>
-          <p:cNvPr id="3" name="TextBox 2"/>
-          <p:cNvSpPr txBox="1"/>
-          <p:nvPr/>
-        </p:nvSpPr>
-        <p:spPr>
-          <a:xfrm>
-            <a:off x="548640" y="1371600"/>
-            <a:ext cx="11064240" cy="5029200"/>
-          </a:xfrm>
-          <a:prstGeom prst="rect">
-            <a:avLst/>
-          </a:prstGeom>
-          <a:noFill/>
-        </p:spPr>
-        <p:txBody>
-          <a:bodyPr wrap="square">
-            <a:spAutoFit/>
-          </a:bodyPr>
-          <a:lstStyle/>
-          <a:p>
-            <a:pPr>
-              <a:spcAft>
-                <a:spcPts val="600"/>
-              </a:spcAft>
-            </a:pPr>
-            <a:r>
-              <a:rPr sz="1600" b="0" i="1">
-                <a:solidFill>
-                  <a:srgbClr val="C0392B"/>
-                </a:solidFill>
-              </a:rPr>
-              <a:t>Assumption: protracted payables are causing real cost (penalties, lost discounts) — not yet quantified.</a:t>
-            </a:r>
-          </a:p>
-          <a:p>
-            <a:pPr>
-              <a:spcAft>
-                <a:spcPts val="600"/>
-              </a:spcAft>
-            </a:pPr>
-            <a:r>
-              <a:rPr sz="1600" b="0" i="1">
-                <a:solidFill>
-                  <a:srgbClr val="C0392B"/>
-                </a:solidFill>
-              </a:rPr>
-              <a:t>Assumption: fragmented spend is losing meaningful volume discounts across the 59 units.</a:t>
-            </a:r>
-          </a:p>
-          <a:p>
-            <a:pPr>
-              <a:spcAft>
-                <a:spcPts val="600"/>
-              </a:spcAft>
-            </a:pPr>
-            <a:r>
-              <a:rPr sz="1600" b="0" i="1">
-                <a:solidFill>
-                  <a:srgbClr val="C0392B"/>
-                </a:solidFill>
-              </a:rPr>
-              <a:t>Assumption: a large share of the 1.8M daily transactions is low-value/tail spend that can be consolidated.</a:t>
-            </a:r>
-          </a:p>
-          <a:p>
-            <a:pPr>
-              <a:spcAft>
-                <a:spcPts val="600"/>
-              </a:spcAft>
-            </a:pPr>
-            <a:r>
-              <a:rPr sz="1600" b="0" i="1">
-                <a:solidFill>
-                  <a:srgbClr val="C0392B"/>
-                </a:solidFill>
-              </a:rPr>
-              <a:t>Assumption: executive sponsorship is currently absent rather than present-but-ignored.</a:t>
-            </a:r>
-          </a:p>
-          <a:p>
-            <a:pPr>
-              <a:spcAft>
-                <a:spcPts val="600"/>
-              </a:spcAft>
-            </a:pPr>
-            <a:r>
-              <a:rPr sz="1600" b="0" i="1">
-                <a:solidFill>
-                  <a:srgbClr val="C0392B"/>
-                </a:solidFill>
-              </a:rPr>
-              <a:t>Assumption: the three named ERPs are the main systems; there may be more across 59 units.</a:t>
-            </a:r>
-          </a:p>
-          <a:p>
-            <a:pPr>
-              <a:spcAft>
-                <a:spcPts val="600"/>
-              </a:spcAft>
-            </a:pPr>
-            <a:r>
-              <a:rPr sz="1600" b="0" i="1">
-                <a:solidFill>
-                  <a:srgbClr val="C0392B"/>
-                </a:solidFill>
-              </a:rPr>
-              <a:t>Assumption: standardising process and catalogue delivers most of the benefit before any system replacement.</a:t>
-            </a:r>
-          </a:p>
-        </p:txBody>
-      </p:sp>
-    </p:spTree>
-  </p:cSld>
-  <p:clrMapOvr>
-    <a:masterClrMapping/>
-  </p:clrMapOvr>
-</p:sld>
-</file>
-
-<file path=ppt/slides/slide16.xml><?xml version="1.0" encoding="utf-8"?>
-<p:sld xmlns:a="http://schemas.openxmlformats.org/drawingml/2006/main" xmlns:p="http://schemas.openxmlformats.org/presentationml/2006/main" xmlns:r="http://schemas.openxmlformats.org/officeDocument/2006/relationships">
-  <p:cSld>
-    <p:spTree>
-      <p:nvGrpSpPr>
-        <p:cNvPr id="1" name=""/>
-        <p:cNvGrpSpPr/>
-        <p:nvPr/>
-      </p:nvGrpSpPr>
-      <p:grpSpPr/>
-      <p:sp>
-        <p:nvSpPr>
-          <p:cNvPr id="2" name="TextBox 1"/>
-          <p:cNvSpPr txBox="1"/>
-          <p:nvPr/>
-        </p:nvSpPr>
-        <p:spPr>
-          <a:xfrm>
-            <a:off x="457200" y="274320"/>
-            <a:ext cx="11247120" cy="1005840"/>
-          </a:xfrm>
-          <a:prstGeom prst="rect">
-            <a:avLst/>
-          </a:prstGeom>
-          <a:noFill/>
-        </p:spPr>
-        <p:txBody>
-          <a:bodyPr wrap="square">
-            <a:spAutoFit/>
-          </a:bodyPr>
-          <a:lstStyle/>
-          <a:p>
-            <a:r>
-              <a:rPr sz="3000" b="1">
-                <a:solidFill>
-                  <a:srgbClr val="1F3864"/>
-                </a:solidFill>
-              </a:rPr>
-              <a:t>3.  Five questions for the client</a:t>
-            </a:r>
-          </a:p>
-          <a:p>
-            <a:r>
-              <a:rPr sz="1500" i="1">
-                <a:solidFill>
-                  <a:srgbClr val="C0392B"/>
-                </a:solidFill>
-              </a:rPr>
-              <a:t>To better inform our work</a:t>
-            </a:r>
-          </a:p>
-        </p:txBody>
-      </p:sp>
-      <p:sp>
-        <p:nvSpPr>
-          <p:cNvPr id="3" name="TextBox 2"/>
-          <p:cNvSpPr txBox="1"/>
-          <p:nvPr/>
-        </p:nvSpPr>
-        <p:spPr>
-          <a:xfrm>
-            <a:off x="548640" y="1280160"/>
-            <a:ext cx="11064240" cy="5029200"/>
-          </a:xfrm>
-          <a:prstGeom prst="rect">
-            <a:avLst/>
-          </a:prstGeom>
-          <a:noFill/>
-        </p:spPr>
-        <p:txBody>
-          <a:bodyPr wrap="square">
-            <a:spAutoFit/>
-          </a:bodyPr>
-          <a:lstStyle/>
-          <a:p>
-            <a:pPr>
-              <a:spcAft>
-                <a:spcPts val="600"/>
-              </a:spcAft>
-            </a:pPr>
-            <a:r>
-              <a:rPr sz="1500" b="1">
-                <a:solidFill>
-                  <a:srgbClr val="1F3864"/>
-                </a:solidFill>
-              </a:rPr>
-              <a:t>1.  Spend &amp; suppliers — What is total procurement spend, how does it split across the 59 units, and how much supplier overlap exists between them?</a:t>
-            </a:r>
-          </a:p>
-          <a:p>
-            <a:pPr>
-              <a:spcAft>
-                <a:spcPts val="600"/>
-              </a:spcAft>
-            </a:pPr>
-            <a:r>
-              <a:rPr sz="1500" b="1">
-                <a:solidFill>
-                  <a:srgbClr val="1F3864"/>
-                </a:solidFill>
-              </a:rPr>
-              <a:t>2.  Governance — Is there executive appetite to mandate a single, compliant operating model, and who would sponsor it?</a:t>
-            </a:r>
-          </a:p>
-          <a:p>
-            <a:pPr>
-              <a:spcAft>
-                <a:spcPts val="600"/>
-              </a:spcAft>
-            </a:pPr>
-            <a:r>
-              <a:rPr sz="1500" b="1">
-                <a:solidFill>
-                  <a:srgbClr val="1F3864"/>
-                </a:solidFill>
-              </a:rPr>
-              <a:t>3.  Transaction mix — Of the 1.8M daily transactions, what share is low-value/tail spend, and what does it cost to process one order today?</a:t>
-            </a:r>
-          </a:p>
-          <a:p>
-            <a:pPr>
-              <a:spcAft>
-                <a:spcPts val="600"/>
-              </a:spcAft>
-            </a:pPr>
-            <a:r>
-              <a:rPr sz="1500" b="1">
-                <a:solidFill>
-                  <a:srgbClr val="1F3864"/>
-                </a:solidFill>
-              </a:rPr>
-              <a:t>4.  Systems — Is ERP consolidation on the table, what contractual lock-ins exist, and is the target a shared-services model or continued unit autonomy?</a:t>
-            </a:r>
-          </a:p>
-          <a:p>
-            <a:pPr>
-              <a:spcAft>
-                <a:spcPts val="600"/>
-              </a:spcAft>
-            </a:pPr>
-            <a:r>
-              <a:rPr sz="1500" b="1">
-                <a:solidFill>
-                  <a:srgbClr val="1F3864"/>
-                </a:solidFill>
-              </a:rPr>
-              <a:t>5.  People — What is driving the low morale, are Team 1's vacancies funded, and can resource move between the two central teams?</a:t>
+              <a:t>Next step: get the spend/transaction data and answers to the five questions to confirm the plan.</a:t>
             </a:r>
           </a:p>
         </p:txBody>
@@ -4370,7 +3665,7 @@
           <a:lstStyle/>
           <a:p>
             <a:r>
-              <a:rPr sz="3000" b="1">
+              <a:rPr sz="2800" b="1">
                 <a:solidFill>
                   <a:srgbClr val="1F3864"/>
                 </a:solidFill>
@@ -4389,7 +3684,7 @@
         <p:spPr>
           <a:xfrm>
             <a:off x="548640" y="1371600"/>
-            <a:ext cx="11064240" cy="5029200"/>
+            <a:ext cx="11064240" cy="5120640"/>
           </a:xfrm>
           <a:prstGeom prst="rect">
             <a:avLst/>
@@ -4404,11 +3699,11 @@
           <a:p>
             <a:pPr>
               <a:spcAft>
-                <a:spcPts val="600"/>
-              </a:spcAft>
-            </a:pPr>
-            <a:r>
-              <a:rPr sz="1600" b="1">
+                <a:spcPts val="500"/>
+              </a:spcAft>
+            </a:pPr>
+            <a:r>
+              <a:rPr sz="1700" b="1">
                 <a:solidFill>
                   <a:srgbClr val="1F3864"/>
                 </a:solidFill>
@@ -4419,106 +3714,61 @@
           <a:p>
             <a:pPr>
               <a:spcAft>
-                <a:spcPts val="600"/>
-              </a:spcAft>
-            </a:pPr>
-            <a:r>
-              <a:rPr sz="1600" b="1">
+                <a:spcPts val="500"/>
+              </a:spcAft>
+            </a:pPr>
+            <a:r>
+              <a:rPr sz="1700" b="0">
+                <a:solidFill>
+                  <a:srgbClr val="444444"/>
+                </a:solidFill>
+              </a:rPr>
+              <a:t>59 operating locations run as independent organisations, each with its own procurement processes, supplier community and back-end systems (Oracle, SAP, PeopleSoft).</a:t>
+            </a:r>
+          </a:p>
+          <a:p>
+            <a:pPr>
+              <a:spcAft>
+                <a:spcPts val="500"/>
+              </a:spcAft>
+            </a:pPr>
+            <a:r>
+              <a:rPr sz="1700" b="0">
+                <a:solidFill>
+                  <a:srgbClr val="444444"/>
+                </a:solidFill>
+              </a:rPr>
+              <a:t>Two central procurement teams are accountable for end-to-end process across all 59 locations.</a:t>
+            </a:r>
+          </a:p>
+          <a:p>
+            <a:pPr>
+              <a:spcAft>
+                <a:spcPts val="500"/>
+              </a:spcAft>
+            </a:pPr>
+            <a:r>
+              <a:rPr sz="1700" b="1">
                 <a:solidFill>
                   <a:srgbClr val="1F3864"/>
                 </a:solidFill>
               </a:rPr>
-              <a:t>59 operating locations run as independent organisations, each with its own:</a:t>
-            </a:r>
-          </a:p>
-          <a:p>
-            <a:pPr lvl="1">
-              <a:spcAft>
-                <a:spcPts val="600"/>
-              </a:spcAft>
-            </a:pPr>
-            <a:r>
-              <a:rPr sz="1500" b="0">
+              <a:t>Scale: ~1.8 million procurement transactions every day — so every inefficiency is multiplied massively.</a:t>
+            </a:r>
+          </a:p>
+          <a:p>
+            <a:pPr>
+              <a:spcAft>
+                <a:spcPts val="500"/>
+              </a:spcAft>
+            </a:pPr>
+            <a:r>
+              <a:rPr sz="1700" b="0">
                 <a:solidFill>
                   <a:srgbClr val="444444"/>
                 </a:solidFill>
               </a:rPr>
-              <a:t>Procurement processes and process design</a:t>
-            </a:r>
-          </a:p>
-          <a:p>
-            <a:pPr lvl="1">
-              <a:spcAft>
-                <a:spcPts val="600"/>
-              </a:spcAft>
-            </a:pPr>
-            <a:r>
-              <a:rPr sz="1500" b="0">
-                <a:solidFill>
-                  <a:srgbClr val="444444"/>
-                </a:solidFill>
-              </a:rPr>
-              <a:t>Supplier community</a:t>
-            </a:r>
-          </a:p>
-          <a:p>
-            <a:pPr lvl="1">
-              <a:spcAft>
-                <a:spcPts val="600"/>
-              </a:spcAft>
-            </a:pPr>
-            <a:r>
-              <a:rPr sz="1500" b="0">
-                <a:solidFill>
-                  <a:srgbClr val="444444"/>
-                </a:solidFill>
-              </a:rPr>
-              <a:t>Back-end systems (Oracle, SAP, PeopleSoft)</a:t>
-            </a:r>
-          </a:p>
-          <a:p>
-            <a:pPr>
-              <a:spcAft>
-                <a:spcPts val="600"/>
-              </a:spcAft>
-            </a:pPr>
-            <a:r>
-              <a:rPr sz="1600" b="1">
-                <a:solidFill>
-                  <a:srgbClr val="1F3864"/>
-                </a:solidFill>
-              </a:rPr>
-              <a:t>Two central procurement teams are accountable for end-to-end process across all 59 locations.</a:t>
-            </a:r>
-          </a:p>
-          <a:p>
-            <a:pPr>
-              <a:spcAft>
-                <a:spcPts val="600"/>
-              </a:spcAft>
-            </a:pPr>
-            <a:r>
-              <a:rPr sz="1600" b="1">
-                <a:solidFill>
-                  <a:srgbClr val="1F3864"/>
-                </a:solidFill>
-              </a:rPr>
-              <a:t>Scale: ~1.8 million procurement transactions every day — so every inefficiency is multiplied massively.</a:t>
-            </a:r>
-          </a:p>
-          <a:p>
-            <a:pPr>
-              <a:spcAft>
-                <a:spcPts val="600"/>
-              </a:spcAft>
-            </a:pPr>
-            <a:r>
-              <a:rPr sz="1600" b="0">
-                <a:solidFill>
-                  <a:srgbClr val="444444"/>
-                </a:solidFill>
-              </a:rPr>
-              <a:t>An internal analysis by the manager surfaced the issues on the following slides.</a:t>
+              <a:t>A manager's internal analysis surfaced the issues that follow.</a:t>
             </a:r>
           </a:p>
         </p:txBody>
@@ -4564,12 +3814,12 @@
           <a:lstStyle/>
           <a:p>
             <a:r>
-              <a:rPr sz="3000" b="1">
+              <a:rPr sz="2800" b="1">
                 <a:solidFill>
                   <a:srgbClr val="1F3864"/>
                 </a:solidFill>
               </a:rPr>
-              <a:t>1.  The Issues</a:t>
+              <a:t>1. The issues — root causes (the drivers)</a:t>
             </a:r>
           </a:p>
           <a:p>
@@ -4579,7 +3829,7 @@
                   <a:srgbClr val="C0392B"/>
                 </a:solidFill>
               </a:rPr>
-              <a:t>Problem statement | Evidence | Business impact</a:t>
+              <a:t>Problem | evidence | business impact</a:t>
             </a:r>
           </a:p>
         </p:txBody>
@@ -4593,7 +3843,7 @@
         <p:spPr>
           <a:xfrm>
             <a:off x="548640" y="1371600"/>
-            <a:ext cx="11064240" cy="5029200"/>
+            <a:ext cx="11064240" cy="5120640"/>
           </a:xfrm>
           <a:prstGeom prst="rect">
             <a:avLst/>
@@ -4608,7 +3858,7 @@
           <a:p>
             <a:pPr>
               <a:spcAft>
-                <a:spcPts val="600"/>
+                <a:spcPts val="500"/>
               </a:spcAft>
             </a:pPr>
             <a:r>
@@ -4617,13 +3867,28 @@
                   <a:srgbClr val="1F3864"/>
                 </a:solidFill>
               </a:rPr>
-              <a:t>We have grouped the findings into ROOT CAUSES (the drivers) and SYMPTOMS (what hurts day to day).</a:t>
+              <a:t>R1  No executive sponsorship to enforce compliance</a:t>
+            </a:r>
+          </a:p>
+          <a:p>
+            <a:pPr lvl="1">
+              <a:spcAft>
+                <a:spcPts val="500"/>
+              </a:spcAft>
+            </a:pPr>
+            <a:r>
+              <a:rPr sz="1500" b="0">
+                <a:solidFill>
+                  <a:srgbClr val="444444"/>
+                </a:solidFill>
+              </a:rPr>
+              <a:t>Teams are accountable but have no mandate; 'control of all 59 is a huge challenge' -&gt; nothing can be standardised. The keystone issue.</a:t>
             </a:r>
           </a:p>
           <a:p>
             <a:pPr>
               <a:spcAft>
-                <a:spcPts val="600"/>
+                <a:spcPts val="500"/>
               </a:spcAft>
             </a:pPr>
             <a:r>
@@ -4632,13 +3897,13 @@
                   <a:srgbClr val="1F3864"/>
                 </a:solidFill>
               </a:rPr>
-              <a:t>Root causes:</a:t>
+              <a:t>R2  59 independent units from M&amp;A, never integrated</a:t>
             </a:r>
           </a:p>
           <a:p>
             <a:pPr lvl="1">
               <a:spcAft>
-                <a:spcPts val="600"/>
+                <a:spcPts val="500"/>
               </a:spcAft>
             </a:pPr>
             <a:r>
@@ -4647,13 +3912,28 @@
                   <a:srgbClr val="444444"/>
                 </a:solidFill>
               </a:rPr>
-              <a:t>R1 — No executive sponsorship / governance to enforce compliance</a:t>
+              <a:t>Own processes, suppliers and systems -&gt; duplication, no single source of truth, no buying leverage.</a:t>
+            </a:r>
+          </a:p>
+          <a:p>
+            <a:pPr>
+              <a:spcAft>
+                <a:spcPts val="500"/>
+              </a:spcAft>
+            </a:pPr>
+            <a:r>
+              <a:rPr sz="1600" b="1">
+                <a:solidFill>
+                  <a:srgbClr val="1F3864"/>
+                </a:solidFill>
+              </a:rPr>
+              <a:t>R3  No standardised process design</a:t>
             </a:r>
           </a:p>
           <a:p>
             <a:pPr lvl="1">
               <a:spcAft>
-                <a:spcPts val="600"/>
+                <a:spcPts val="500"/>
               </a:spcAft>
             </a:pPr>
             <a:r>
@@ -4662,13 +3942,28 @@
                   <a:srgbClr val="444444"/>
                 </a:solidFill>
               </a:rPr>
-              <a:t>R2 — Fragmented operating model: 59 independent units from M&amp;A</a:t>
+              <a:t>Staff upskilled to process invoices many different ways -&gt; errors, slow cycles, no end-to-end visibility.</a:t>
+            </a:r>
+          </a:p>
+          <a:p>
+            <a:pPr>
+              <a:spcAft>
+                <a:spcPts val="500"/>
+              </a:spcAft>
+            </a:pPr>
+            <a:r>
+              <a:rPr sz="1600" b="1">
+                <a:solidFill>
+                  <a:srgbClr val="1F3864"/>
+                </a:solidFill>
+              </a:rPr>
+              <a:t>R4  Fragmented, poorly integrated systems (Oracle / SAP / PeopleSoft)</a:t>
             </a:r>
           </a:p>
           <a:p>
             <a:pPr lvl="1">
               <a:spcAft>
-                <a:spcPts val="600"/>
+                <a:spcPts val="500"/>
               </a:spcAft>
             </a:pPr>
             <a:r>
@@ -4677,67 +3972,7 @@
                   <a:srgbClr val="444444"/>
                 </a:solidFill>
               </a:rPr>
-              <a:t>R3 — No standardised process design</a:t>
-            </a:r>
-          </a:p>
-          <a:p>
-            <a:pPr lvl="1">
-              <a:spcAft>
-                <a:spcPts val="600"/>
-              </a:spcAft>
-            </a:pPr>
-            <a:r>
-              <a:rPr sz="1500" b="0">
-                <a:solidFill>
-                  <a:srgbClr val="444444"/>
-                </a:solidFill>
-              </a:rPr>
-              <a:t>R4 — Fragmented, poorly integrated systems (Oracle / SAP / PeopleSoft)</a:t>
-            </a:r>
-          </a:p>
-          <a:p>
-            <a:pPr>
-              <a:spcAft>
-                <a:spcPts val="600"/>
-              </a:spcAft>
-            </a:pPr>
-            <a:r>
-              <a:rPr sz="1600" b="1">
-                <a:solidFill>
-                  <a:srgbClr val="1F3864"/>
-                </a:solidFill>
-              </a:rPr>
-              <a:t>Symptoms:</a:t>
-            </a:r>
-          </a:p>
-          <a:p>
-            <a:pPr lvl="1">
-              <a:spcAft>
-                <a:spcPts val="600"/>
-              </a:spcAft>
-            </a:pPr>
-            <a:r>
-              <a:rPr sz="1500" b="0">
-                <a:solidFill>
-                  <a:srgbClr val="444444"/>
-                </a:solidFill>
-              </a:rPr>
-              <a:t>S1 — Protracted payables    S2 — Lost economies of scale</a:t>
-            </a:r>
-          </a:p>
-          <a:p>
-            <a:pPr lvl="1">
-              <a:spcAft>
-                <a:spcPts val="600"/>
-              </a:spcAft>
-            </a:pPr>
-            <a:r>
-              <a:rPr sz="1500" b="0">
-                <a:solidFill>
-                  <a:srgbClr val="444444"/>
-                </a:solidFill>
-              </a:rPr>
-              <a:t>S3 — Catalogue proliferation &amp; tail spend    S4 — Resourcing imbalance    S5 — Low morale</a:t>
+              <a:t>'Not well integrated', 'a lot of manual processes' -&gt; rework, high IT/training cost, no consolidated spend data.</a:t>
             </a:r>
           </a:p>
         </p:txBody>
@@ -4783,12 +4018,12 @@
           <a:lstStyle/>
           <a:p>
             <a:r>
-              <a:rPr sz="3000" b="1">
+              <a:rPr sz="2800" b="1">
                 <a:solidFill>
                   <a:srgbClr val="1F3864"/>
                 </a:solidFill>
               </a:rPr>
-              <a:t>R1 — No executive sponsorship / governance</a:t>
+              <a:t>1. The issues — symptoms (what hurts day to day)</a:t>
             </a:r>
           </a:p>
         </p:txBody>
@@ -4802,7 +4037,7 @@
         <p:spPr>
           <a:xfrm>
             <a:off x="548640" y="1280160"/>
-            <a:ext cx="11064240" cy="5029200"/>
+            <a:ext cx="11064240" cy="5120640"/>
           </a:xfrm>
           <a:prstGeom prst="rect">
             <a:avLst/>
@@ -4817,91 +4052,151 @@
           <a:p>
             <a:pPr>
               <a:spcAft>
-                <a:spcPts val="600"/>
-              </a:spcAft>
-            </a:pPr>
-            <a:r>
-              <a:rPr sz="1700" b="1">
+                <a:spcPts val="500"/>
+              </a:spcAft>
+            </a:pPr>
+            <a:r>
+              <a:rPr sz="1500" b="1">
                 <a:solidFill>
                   <a:srgbClr val="1F3864"/>
                 </a:solidFill>
               </a:rPr>
-              <a:t>Problem statement</a:t>
+              <a:t>S1  Protracted payables (stated)</a:t>
             </a:r>
           </a:p>
           <a:p>
             <a:pPr lvl="1">
               <a:spcAft>
-                <a:spcPts val="600"/>
-              </a:spcAft>
-            </a:pPr>
-            <a:r>
-              <a:rPr sz="1600" b="0">
+                <a:spcPts val="500"/>
+              </a:spcAft>
+            </a:pPr>
+            <a:r>
+              <a:rPr sz="1400" b="0" i="1">
+                <a:solidFill>
+                  <a:srgbClr val="C0392B"/>
+                </a:solidFill>
+              </a:rPr>
+              <a:t>Assumption: drives late-payment penalties, lost early-payment discounts and strained supplier relationships.</a:t>
+            </a:r>
+          </a:p>
+          <a:p>
+            <a:pPr>
+              <a:spcAft>
+                <a:spcPts val="500"/>
+              </a:spcAft>
+            </a:pPr>
+            <a:r>
+              <a:rPr sz="1500" b="1">
+                <a:solidFill>
+                  <a:srgbClr val="1F3864"/>
+                </a:solidFill>
+              </a:rPr>
+              <a:t>S2  Lost economies of scale (stated)</a:t>
+            </a:r>
+          </a:p>
+          <a:p>
+            <a:pPr lvl="1">
+              <a:spcAft>
+                <a:spcPts val="500"/>
+              </a:spcAft>
+            </a:pPr>
+            <a:r>
+              <a:rPr sz="1400" b="0">
                 <a:solidFill>
                   <a:srgbClr val="444444"/>
                 </a:solidFill>
               </a:rPr>
-              <a:t>The two central teams are accountable for end-to-end process but have no executive mandate to enforce compliance across the 59 units.</a:t>
+              <a:t>Fragmented spend -&gt; higher prices and duplicate contracts (see supplier evidence next).</a:t>
             </a:r>
           </a:p>
           <a:p>
             <a:pPr>
               <a:spcAft>
-                <a:spcPts val="600"/>
-              </a:spcAft>
-            </a:pPr>
-            <a:r>
-              <a:rPr sz="1700" b="1">
+                <a:spcPts val="500"/>
+              </a:spcAft>
+            </a:pPr>
+            <a:r>
+              <a:rPr sz="1500" b="1">
                 <a:solidFill>
                   <a:srgbClr val="1F3864"/>
                 </a:solidFill>
               </a:rPr>
-              <a:t>Evidence</a:t>
+              <a:t>S3  Catalogue proliferation &amp; tail spend (stated)</a:t>
             </a:r>
           </a:p>
           <a:p>
             <a:pPr lvl="1">
               <a:spcAft>
-                <a:spcPts val="600"/>
-              </a:spcAft>
-            </a:pPr>
-            <a:r>
-              <a:rPr sz="1600" b="0">
+                <a:spcPts val="500"/>
+              </a:spcAft>
+            </a:pPr>
+            <a:r>
+              <a:rPr sz="1400" b="0">
                 <a:solidFill>
                   <a:srgbClr val="444444"/>
                 </a:solidFill>
               </a:rPr>
-              <a:t>Internal analysis: 'lack of executive support to drive compliance'; 'keeping control of all 59 is a huge challenge'.</a:t>
+              <a:t>Low-value items need multiple orders to different suppliers — costly at 1.8M txns/day.</a:t>
             </a:r>
           </a:p>
           <a:p>
             <a:pPr>
               <a:spcAft>
-                <a:spcPts val="600"/>
-              </a:spcAft>
-            </a:pPr>
-            <a:r>
-              <a:rPr sz="1700" b="1">
+                <a:spcPts val="500"/>
+              </a:spcAft>
+            </a:pPr>
+            <a:r>
+              <a:rPr sz="1500" b="1">
                 <a:solidFill>
                   <a:srgbClr val="1F3864"/>
                 </a:solidFill>
               </a:rPr>
-              <a:t>Impact on the business</a:t>
+              <a:t>S4  Resourcing imbalance (stated)</a:t>
             </a:r>
           </a:p>
           <a:p>
             <a:pPr lvl="1">
               <a:spcAft>
-                <a:spcPts val="600"/>
-              </a:spcAft>
-            </a:pPr>
-            <a:r>
-              <a:rPr sz="1600" b="0">
+                <a:spcPts val="500"/>
+              </a:spcAft>
+            </a:pPr>
+            <a:r>
+              <a:rPr sz="1400" b="0">
                 <a:solidFill>
                   <a:srgbClr val="444444"/>
                 </a:solidFill>
               </a:rPr>
-              <a:t>Standardisation cannot be enforced. Every other fix stalls without this — it is the keystone issue.</a:t>
+              <a:t>Team 1: 2 FTE + part-timers + 2 vacancies (slow).  Team 2: 7 + 2 seniors (fast).</a:t>
+            </a:r>
+          </a:p>
+          <a:p>
+            <a:pPr>
+              <a:spcAft>
+                <a:spcPts val="500"/>
+              </a:spcAft>
+            </a:pPr>
+            <a:r>
+              <a:rPr sz="1500" b="1">
+                <a:solidFill>
+                  <a:srgbClr val="1F3864"/>
+                </a:solidFill>
+              </a:rPr>
+              <a:t>S5  Low morale — procurement seen as low-value back-office work (stated)</a:t>
+            </a:r>
+          </a:p>
+          <a:p>
+            <a:pPr lvl="1">
+              <a:spcAft>
+                <a:spcPts val="500"/>
+              </a:spcAft>
+            </a:pPr>
+            <a:r>
+              <a:rPr sz="1400" b="0" i="1">
+                <a:solidFill>
+                  <a:srgbClr val="C0392B"/>
+                </a:solidFill>
+              </a:rPr>
+              <a:t>Assumption: creates attrition risk and change fatigue.</a:t>
             </a:r>
           </a:p>
         </p:txBody>
@@ -4947,12 +4242,12 @@
           <a:lstStyle/>
           <a:p>
             <a:r>
-              <a:rPr sz="3000" b="1">
+              <a:rPr sz="2800" b="1">
                 <a:solidFill>
                   <a:srgbClr val="1F3864"/>
                 </a:solidFill>
               </a:rPr>
-              <a:t>R2 — Fragmented operating model (59 independent units)</a:t>
+              <a:t>Evidence: the supplier base is fragmenting, not consolidating</a:t>
             </a:r>
           </a:p>
         </p:txBody>
@@ -4965,8 +4260,8 @@
         </p:nvSpPr>
         <p:spPr>
           <a:xfrm>
-            <a:off x="548640" y="1280160"/>
-            <a:ext cx="11064240" cy="5029200"/>
+            <a:off x="548640" y="1371600"/>
+            <a:ext cx="11064240" cy="5120640"/>
           </a:xfrm>
           <a:prstGeom prst="rect">
             <a:avLst/>
@@ -4981,91 +4276,106 @@
           <a:p>
             <a:pPr>
               <a:spcAft>
-                <a:spcPts val="600"/>
-              </a:spcAft>
-            </a:pPr>
-            <a:r>
-              <a:rPr sz="1700" b="1">
+                <a:spcPts val="500"/>
+              </a:spcAft>
+            </a:pPr>
+            <a:r>
+              <a:rPr sz="1600" b="1">
                 <a:solidFill>
                   <a:srgbClr val="1F3864"/>
                 </a:solidFill>
               </a:rPr>
-              <a:t>Problem statement</a:t>
+              <a:t>2023:  224 suppliers  |  $900M spend</a:t>
+            </a:r>
+          </a:p>
+          <a:p>
+            <a:pPr>
+              <a:spcAft>
+                <a:spcPts val="500"/>
+              </a:spcAft>
+            </a:pPr>
+            <a:r>
+              <a:rPr sz="1600" b="1">
+                <a:solidFill>
+                  <a:srgbClr val="1F3864"/>
+                </a:solidFill>
+              </a:rPr>
+              <a:t>2024:  264 suppliers  |  $1,045M spend</a:t>
             </a:r>
           </a:p>
           <a:p>
             <a:pPr lvl="1">
               <a:spcAft>
-                <a:spcPts val="600"/>
-              </a:spcAft>
-            </a:pPr>
-            <a:r>
-              <a:rPr sz="1600" b="0">
+                <a:spcPts val="500"/>
+              </a:spcAft>
+            </a:pPr>
+            <a:r>
+              <a:rPr sz="1500" b="0">
                 <a:solidFill>
                   <a:srgbClr val="444444"/>
                 </a:solidFill>
               </a:rPr>
-              <a:t>M&amp;A bolted businesses together but never integrated them; each unit runs its own procurement, suppliers and systems.</a:t>
+              <a:t>Suppliers +40 (+18%); spend +$145M (+16%).</a:t>
+            </a:r>
+          </a:p>
+          <a:p>
+            <a:pPr lvl="1">
+              <a:spcAft>
+                <a:spcPts val="500"/>
+              </a:spcAft>
+            </a:pPr>
+            <a:r>
+              <a:rPr sz="1500" b="0">
+                <a:solidFill>
+                  <a:srgbClr val="444444"/>
+                </a:solidFill>
+              </a:rPr>
+              <a:t>Average spend per supplier FELL: $4.02M -&gt; $3.96M.</a:t>
             </a:r>
           </a:p>
           <a:p>
             <a:pPr>
               <a:spcAft>
-                <a:spcPts val="600"/>
-              </a:spcAft>
-            </a:pPr>
-            <a:r>
-              <a:rPr sz="1700" b="1">
+                <a:spcPts val="500"/>
+              </a:spcAft>
+            </a:pPr>
+            <a:r>
+              <a:rPr sz="1600" b="1">
                 <a:solidFill>
                   <a:srgbClr val="1F3864"/>
                 </a:solidFill>
               </a:rPr>
-              <a:t>Evidence</a:t>
+              <a:t>So spend is rising but buying leverage per supplier is falling — adding suppliers faster than consolidating them.</a:t>
             </a:r>
           </a:p>
           <a:p>
             <a:pPr lvl="1">
               <a:spcAft>
-                <a:spcPts val="600"/>
-              </a:spcAft>
-            </a:pPr>
-            <a:r>
-              <a:rPr sz="1600" b="0">
+                <a:spcPts val="500"/>
+              </a:spcAft>
+            </a:pPr>
+            <a:r>
+              <a:rPr sz="1500" b="0">
                 <a:solidFill>
                   <a:srgbClr val="444444"/>
                 </a:solidFill>
               </a:rPr>
-              <a:t>59 locations operating as independent organisations with different supplier communities and back-end processes.</a:t>
+              <a:t>Direct evidence for S2 (lost economies of scale) and R2 (fragmented, un-integrated units).</a:t>
             </a:r>
           </a:p>
           <a:p>
             <a:pPr>
               <a:spcAft>
-                <a:spcPts val="600"/>
-              </a:spcAft>
-            </a:pPr>
-            <a:r>
-              <a:rPr sz="1700" b="1">
-                <a:solidFill>
-                  <a:srgbClr val="1F3864"/>
-                </a:solidFill>
-              </a:rPr>
-              <a:t>Impact on the business</a:t>
-            </a:r>
-          </a:p>
-          <a:p>
-            <a:pPr lvl="1">
-              <a:spcAft>
-                <a:spcPts val="600"/>
-              </a:spcAft>
-            </a:pPr>
-            <a:r>
-              <a:rPr sz="1600" b="0">
-                <a:solidFill>
-                  <a:srgbClr val="444444"/>
-                </a:solidFill>
-              </a:rPr>
-              <a:t>Duplication of effort and contracts, no single source of truth, and no aggregated buying leverage.</a:t>
+                <a:spcPts val="500"/>
+              </a:spcAft>
+            </a:pPr>
+            <a:r>
+              <a:rPr sz="1600" b="0" i="1">
+                <a:solidFill>
+                  <a:srgbClr val="C0392B"/>
+                </a:solidFill>
+              </a:rPr>
+              <a:t>Assumption: figures are group-wide; a per-unit / per-category split would size the consolidation opportunity.</a:t>
             </a:r>
           </a:p>
         </p:txBody>
@@ -5111,12 +4421,22 @@
           <a:lstStyle/>
           <a:p>
             <a:r>
-              <a:rPr sz="3000" b="1">
+              <a:rPr sz="2800" b="1">
                 <a:solidFill>
                   <a:srgbClr val="1F3864"/>
                 </a:solidFill>
               </a:rPr>
-              <a:t>R3 — No standardised process design</a:t>
+              <a:t>Which issue matters most?</a:t>
+            </a:r>
+          </a:p>
+          <a:p>
+            <a:r>
+              <a:rPr sz="1500" i="1">
+                <a:solidFill>
+                  <a:srgbClr val="C0392B"/>
+                </a:solidFill>
+              </a:rPr>
+              <a:t>Our view</a:t>
             </a:r>
           </a:p>
         </p:txBody>
@@ -5129,8 +4449,8 @@
         </p:nvSpPr>
         <p:spPr>
           <a:xfrm>
-            <a:off x="548640" y="1280160"/>
-            <a:ext cx="11064240" cy="5029200"/>
+            <a:off x="548640" y="1554480"/>
+            <a:ext cx="11064240" cy="5120640"/>
           </a:xfrm>
           <a:prstGeom prst="rect">
             <a:avLst/>
@@ -5145,91 +4465,61 @@
           <a:p>
             <a:pPr>
               <a:spcAft>
-                <a:spcPts val="600"/>
-              </a:spcAft>
-            </a:pPr>
-            <a:r>
-              <a:rPr sz="1700" b="1">
+                <a:spcPts val="500"/>
+              </a:spcAft>
+            </a:pPr>
+            <a:r>
+              <a:rPr sz="1800" b="1">
                 <a:solidFill>
                   <a:srgbClr val="1F3864"/>
                 </a:solidFill>
               </a:rPr>
-              <a:t>Problem statement</a:t>
+              <a:t>Most important = R1: secure executive sponsorship and a compliance mandate.</a:t>
             </a:r>
           </a:p>
           <a:p>
             <a:pPr lvl="1">
               <a:spcAft>
-                <a:spcPts val="600"/>
-              </a:spcAft>
-            </a:pPr>
-            <a:r>
-              <a:rPr sz="1600" b="0">
+                <a:spcPts val="500"/>
+              </a:spcAft>
+            </a:pPr>
+            <a:r>
+              <a:rPr sz="1700" b="0">
                 <a:solidFill>
                   <a:srgbClr val="444444"/>
                 </a:solidFill>
               </a:rPr>
-              <a:t>There is no common procure-to-pay process; each unit invoices and buys its own way.</a:t>
-            </a:r>
-          </a:p>
-          <a:p>
-            <a:pPr>
-              <a:spcAft>
-                <a:spcPts val="600"/>
-              </a:spcAft>
-            </a:pPr>
-            <a:r>
-              <a:rPr sz="1700" b="1">
-                <a:solidFill>
-                  <a:srgbClr val="1F3864"/>
-                </a:solidFill>
-              </a:rPr>
-              <a:t>Evidence</a:t>
+              <a:t>Not the most expensive problem, but the dependency that unblocks everything else.</a:t>
             </a:r>
           </a:p>
           <a:p>
             <a:pPr lvl="1">
               <a:spcAft>
-                <a:spcPts val="600"/>
-              </a:spcAft>
-            </a:pPr>
-            <a:r>
-              <a:rPr sz="1600" b="0">
+                <a:spcPts val="500"/>
+              </a:spcAft>
+            </a:pPr>
+            <a:r>
+              <a:rPr sz="1700" b="0">
                 <a:solidFill>
                   <a:srgbClr val="444444"/>
                 </a:solidFill>
               </a:rPr>
-              <a:t>Internal analysis: 'lack of standard process design'; staff must be upskilled to process invoices many different ways.</a:t>
-            </a:r>
-          </a:p>
-          <a:p>
-            <a:pPr>
-              <a:spcAft>
-                <a:spcPts val="600"/>
-              </a:spcAft>
-            </a:pPr>
-            <a:r>
-              <a:rPr sz="1700" b="1">
-                <a:solidFill>
-                  <a:srgbClr val="1F3864"/>
-                </a:solidFill>
-              </a:rPr>
-              <a:t>Impact on the business</a:t>
+              <a:t>With 59 autonomous units, you cannot standardise processes, consolidate systems or rationalise suppliers unless leadership mandates it.</a:t>
             </a:r>
           </a:p>
           <a:p>
             <a:pPr lvl="1">
               <a:spcAft>
-                <a:spcPts val="600"/>
-              </a:spcAft>
-            </a:pPr>
-            <a:r>
-              <a:rPr sz="1600" b="0">
+                <a:spcPts val="500"/>
+              </a:spcAft>
+            </a:pPr>
+            <a:r>
+              <a:rPr sz="1700" b="0">
                 <a:solidFill>
                   <a:srgbClr val="444444"/>
                 </a:solidFill>
               </a:rPr>
-              <a:t>Errors, slow cycle times, high training burden, and no end-to-end control or visibility.</a:t>
+              <a:t>Business impact: without it, spend and the supplier base keep fragmenting (as 2023-&gt;2024 shows). Low cost, high leverage — fix it first.</a:t>
             </a:r>
           </a:p>
         </p:txBody>
@@ -5275,12 +4565,22 @@
           <a:lstStyle/>
           <a:p>
             <a:r>
-              <a:rPr sz="3000" b="1">
+              <a:rPr sz="2800" b="1">
                 <a:solidFill>
                   <a:srgbClr val="1F3864"/>
                 </a:solidFill>
               </a:rPr>
-              <a:t>R4 — Fragmented, poorly integrated systems</a:t>
+              <a:t>2. Prioritisation — three high-impact moves</a:t>
+            </a:r>
+          </a:p>
+          <a:p>
+            <a:r>
+              <a:rPr sz="1500" i="1">
+                <a:solidFill>
+                  <a:srgbClr val="C0392B"/>
+                </a:solidFill>
+              </a:rPr>
+              <a:t>Prioritised issue and why — not a full redesign</a:t>
             </a:r>
           </a:p>
         </p:txBody>
@@ -5293,8 +4593,8 @@
         </p:nvSpPr>
         <p:spPr>
           <a:xfrm>
-            <a:off x="548640" y="1280160"/>
-            <a:ext cx="11064240" cy="5029200"/>
+            <a:off x="548640" y="1371600"/>
+            <a:ext cx="11064240" cy="5120640"/>
           </a:xfrm>
           <a:prstGeom prst="rect">
             <a:avLst/>
@@ -5307,93 +4607,108 @@
           </a:bodyPr>
           <a:lstStyle/>
           <a:p>
+            <a:pPr lvl="1">
+              <a:spcAft>
+                <a:spcPts val="500"/>
+              </a:spcAft>
+            </a:pPr>
+            <a:r>
+              <a:rPr sz="1500" b="1">
+                <a:solidFill>
+                  <a:srgbClr val="444444"/>
+                </a:solidFill>
+              </a:rPr>
+              <a:t>1.  R1 — Secure executive sponsorship &amp; a compliance mandate</a:t>
+            </a:r>
+          </a:p>
+          <a:p>
+            <a:pPr lvl="2">
+              <a:spcAft>
+                <a:spcPts val="500"/>
+              </a:spcAft>
+            </a:pPr>
+            <a:r>
+              <a:rPr sz="1400" b="0">
+                <a:solidFill>
+                  <a:srgbClr val="444444"/>
+                </a:solidFill>
+              </a:rPr>
+              <a:t>Low cost, fast, unlocks every other fix. Highest leverage move available.</a:t>
+            </a:r>
+          </a:p>
+          <a:p>
+            <a:pPr lvl="1">
+              <a:spcAft>
+                <a:spcPts val="500"/>
+              </a:spcAft>
+            </a:pPr>
+            <a:r>
+              <a:rPr sz="1500" b="1">
+                <a:solidFill>
+                  <a:srgbClr val="444444"/>
+                </a:solidFill>
+              </a:rPr>
+              <a:t>2.  R3 + S3 — Standardise procure-to-pay &amp; rationalise catalogue / tail spend</a:t>
+            </a:r>
+          </a:p>
+          <a:p>
+            <a:pPr lvl="2">
+              <a:spcAft>
+                <a:spcPts val="500"/>
+              </a:spcAft>
+            </a:pPr>
+            <a:r>
+              <a:rPr sz="1400" b="0">
+                <a:solidFill>
+                  <a:srgbClr val="444444"/>
+                </a:solidFill>
+              </a:rPr>
+              <a:t>Biggest near-term efficiency gain at 1.8M txns/day — achievable WITHOUT replacing systems.</a:t>
+            </a:r>
+          </a:p>
+          <a:p>
+            <a:pPr lvl="1">
+              <a:spcAft>
+                <a:spcPts val="500"/>
+              </a:spcAft>
+            </a:pPr>
+            <a:r>
+              <a:rPr sz="1500" b="1">
+                <a:solidFill>
+                  <a:srgbClr val="444444"/>
+                </a:solidFill>
+              </a:rPr>
+              <a:t>3.  S4 — Rebalance the two central teams (fill Team 1 vacancies / shift workload)</a:t>
+            </a:r>
+          </a:p>
+          <a:p>
+            <a:pPr lvl="2">
+              <a:spcAft>
+                <a:spcPts val="500"/>
+              </a:spcAft>
+            </a:pPr>
+            <a:r>
+              <a:rPr sz="1400" b="0">
+                <a:solidFill>
+                  <a:srgbClr val="444444"/>
+                </a:solidFill>
+              </a:rPr>
+              <a:t>Fast operational win that lifts throughput and morale.</a:t>
+            </a:r>
+          </a:p>
+          <a:p>
             <a:pPr>
               <a:spcAft>
-                <a:spcPts val="600"/>
-              </a:spcAft>
-            </a:pPr>
-            <a:r>
-              <a:rPr sz="1700" b="1">
-                <a:solidFill>
-                  <a:srgbClr val="1F3864"/>
-                </a:solidFill>
-              </a:rPr>
-              <a:t>Problem statement</a:t>
-            </a:r>
-          </a:p>
-          <a:p>
-            <a:pPr lvl="1">
-              <a:spcAft>
-                <a:spcPts val="600"/>
-              </a:spcAft>
-            </a:pPr>
-            <a:r>
-              <a:rPr sz="1600" b="0">
-                <a:solidFill>
-                  <a:srgbClr val="444444"/>
-                </a:solidFill>
-              </a:rPr>
-              <a:t>Three or more ERPs (Oracle, SAP, PeopleSoft) operate in parallel with weak integration, forcing manual workarounds.</a:t>
-            </a:r>
-          </a:p>
-          <a:p>
-            <a:pPr>
-              <a:spcAft>
-                <a:spcPts val="600"/>
-              </a:spcAft>
-            </a:pPr>
-            <a:r>
-              <a:rPr sz="1700" b="1">
-                <a:solidFill>
-                  <a:srgbClr val="1F3864"/>
-                </a:solidFill>
-              </a:rPr>
-              <a:t>Evidence</a:t>
-            </a:r>
-          </a:p>
-          <a:p>
-            <a:pPr lvl="1">
-              <a:spcAft>
-                <a:spcPts val="600"/>
-              </a:spcAft>
-            </a:pPr>
-            <a:r>
-              <a:rPr sz="1600" b="0">
-                <a:solidFill>
-                  <a:srgbClr val="444444"/>
-                </a:solidFill>
-              </a:rPr>
-              <a:t>Internal analysis: systems 'not well integrated', 'a lot of manual processes' needed; staff upskilled across many systems.</a:t>
-            </a:r>
-          </a:p>
-          <a:p>
-            <a:pPr>
-              <a:spcAft>
-                <a:spcPts val="600"/>
-              </a:spcAft>
-            </a:pPr>
-            <a:r>
-              <a:rPr sz="1700" b="1">
-                <a:solidFill>
-                  <a:srgbClr val="1F3864"/>
-                </a:solidFill>
-              </a:rPr>
-              <a:t>Impact on the business</a:t>
-            </a:r>
-          </a:p>
-          <a:p>
-            <a:pPr lvl="1">
-              <a:spcAft>
-                <a:spcPts val="600"/>
-              </a:spcAft>
-            </a:pPr>
-            <a:r>
-              <a:rPr sz="1600" b="0">
-                <a:solidFill>
-                  <a:srgbClr val="444444"/>
-                </a:solidFill>
-              </a:rPr>
-              <a:t>Manual rework, reconciliation pain, high IT/training cost, and no consolidated spend data.</a:t>
+                <a:spcPts val="500"/>
+              </a:spcAft>
+            </a:pPr>
+            <a:r>
+              <a:rPr sz="1600" b="0" i="1">
+                <a:solidFill>
+                  <a:srgbClr val="C0392B"/>
+                </a:solidFill>
+              </a:rPr>
+              <a:t>Assumption: these three deliver most of the benefit; structural changes are deferred until data justifies them.</a:t>
             </a:r>
           </a:p>
         </p:txBody>
@@ -5439,12 +4754,22 @@
           <a:lstStyle/>
           <a:p>
             <a:r>
-              <a:rPr sz="3000" b="1">
+              <a:rPr sz="2800" b="1">
                 <a:solidFill>
                   <a:srgbClr val="1F3864"/>
                 </a:solidFill>
               </a:rPr>
-              <a:t>Symptoms — what these root causes produce</a:t>
+              <a:t>Related issues — longer-term focus</a:t>
+            </a:r>
+          </a:p>
+          <a:p>
+            <a:r>
+              <a:rPr sz="1500" i="1">
+                <a:solidFill>
+                  <a:srgbClr val="C0392B"/>
+                </a:solidFill>
+              </a:rPr>
+              <a:t>Higher cost / risk: later-stage, data-led decisions</a:t>
             </a:r>
           </a:p>
         </p:txBody>
@@ -5457,8 +4782,8 @@
         </p:nvSpPr>
         <p:spPr>
           <a:xfrm>
-            <a:off x="548640" y="1280160"/>
-            <a:ext cx="11064240" cy="5029200"/>
+            <a:off x="548640" y="1463040"/>
+            <a:ext cx="11064240" cy="5120640"/>
           </a:xfrm>
           <a:prstGeom prst="rect">
             <a:avLst/>
@@ -5473,151 +4798,61 @@
           <a:p>
             <a:pPr>
               <a:spcAft>
-                <a:spcPts val="600"/>
-              </a:spcAft>
-            </a:pPr>
-            <a:r>
-              <a:rPr sz="1500" b="1">
+                <a:spcPts val="500"/>
+              </a:spcAft>
+            </a:pPr>
+            <a:r>
+              <a:rPr sz="1700" b="1">
                 <a:solidFill>
                   <a:srgbClr val="1F3864"/>
                 </a:solidFill>
               </a:rPr>
-              <a:t>S1  Protracted payables (stated in the analysis)</a:t>
-            </a:r>
-          </a:p>
-          <a:p>
-            <a:pPr lvl="1">
-              <a:spcAft>
-                <a:spcPts val="600"/>
-              </a:spcAft>
-            </a:pPr>
-            <a:r>
-              <a:rPr sz="1400" b="0" i="1">
+              <a:t>R4 — Consolidate / better integrate the ERPs (Oracle, SAP, PeopleSoft)</a:t>
+            </a:r>
+          </a:p>
+          <a:p>
+            <a:pPr>
+              <a:spcAft>
+                <a:spcPts val="500"/>
+              </a:spcAft>
+            </a:pPr>
+            <a:r>
+              <a:rPr sz="1700" b="1">
+                <a:solidFill>
+                  <a:srgbClr val="1F3864"/>
+                </a:solidFill>
+              </a:rPr>
+              <a:t>S2 — Rationalise the supplier base to rebuild buying leverage</a:t>
+            </a:r>
+          </a:p>
+          <a:p>
+            <a:pPr>
+              <a:spcAft>
+                <a:spcPts val="500"/>
+              </a:spcAft>
+            </a:pPr>
+            <a:r>
+              <a:rPr sz="1700" b="1">
+                <a:solidFill>
+                  <a:srgbClr val="1F3864"/>
+                </a:solidFill>
+              </a:rPr>
+              <a:t>R2 — Move the 59 units toward one operating model / shared services</a:t>
+            </a:r>
+          </a:p>
+          <a:p>
+            <a:pPr>
+              <a:spcAft>
+                <a:spcPts val="500"/>
+              </a:spcAft>
+            </a:pPr>
+            <a:r>
+              <a:rPr sz="1700" b="0" i="1">
                 <a:solidFill>
                   <a:srgbClr val="C0392B"/>
                 </a:solidFill>
               </a:rPr>
-              <a:t>Assumption: this drives late-payment penalties, strained supplier relationships and lost early-payment discounts.</a:t>
-            </a:r>
-          </a:p>
-          <a:p>
-            <a:pPr>
-              <a:spcAft>
-                <a:spcPts val="600"/>
-              </a:spcAft>
-            </a:pPr>
-            <a:r>
-              <a:rPr sz="1500" b="1">
-                <a:solidFill>
-                  <a:srgbClr val="1F3864"/>
-                </a:solidFill>
-              </a:rPr>
-              <a:t>S2  Lost economies of scale (stated)</a:t>
-            </a:r>
-          </a:p>
-          <a:p>
-            <a:pPr lvl="1">
-              <a:spcAft>
-                <a:spcPts val="600"/>
-              </a:spcAft>
-            </a:pPr>
-            <a:r>
-              <a:rPr sz="1400" b="0" i="1">
-                <a:solidFill>
-                  <a:srgbClr val="C0392B"/>
-                </a:solidFill>
-              </a:rPr>
-              <a:t>Assumption: fragmented spend means higher unit prices, duplicate contracts and no volume discounts.</a:t>
-            </a:r>
-          </a:p>
-          <a:p>
-            <a:pPr>
-              <a:spcAft>
-                <a:spcPts val="600"/>
-              </a:spcAft>
-            </a:pPr>
-            <a:r>
-              <a:rPr sz="1500" b="1">
-                <a:solidFill>
-                  <a:srgbClr val="1F3864"/>
-                </a:solidFill>
-              </a:rPr>
-              <a:t>S3  Catalogue proliferation &amp; tail spend (stated)</a:t>
-            </a:r>
-          </a:p>
-          <a:p>
-            <a:pPr lvl="1">
-              <a:spcAft>
-                <a:spcPts val="600"/>
-              </a:spcAft>
-            </a:pPr>
-            <a:r>
-              <a:rPr sz="1400" b="0">
-                <a:solidFill>
-                  <a:srgbClr val="444444"/>
-                </a:solidFill>
-              </a:rPr>
-              <a:t>Low-value items require multiple orders to different suppliers — costly at 1.8M txns/day.</a:t>
-            </a:r>
-          </a:p>
-          <a:p>
-            <a:pPr>
-              <a:spcAft>
-                <a:spcPts val="600"/>
-              </a:spcAft>
-            </a:pPr>
-            <a:r>
-              <a:rPr sz="1500" b="1">
-                <a:solidFill>
-                  <a:srgbClr val="1F3864"/>
-                </a:solidFill>
-              </a:rPr>
-              <a:t>S4  Resourcing imbalance (stated)</a:t>
-            </a:r>
-          </a:p>
-          <a:p>
-            <a:pPr lvl="1">
-              <a:spcAft>
-                <a:spcPts val="600"/>
-              </a:spcAft>
-            </a:pPr>
-            <a:r>
-              <a:rPr sz="1400" b="0">
-                <a:solidFill>
-                  <a:srgbClr val="444444"/>
-                </a:solidFill>
-              </a:rPr>
-              <a:t>Team 1: 2 FTE + part-timers + 2 vacancies (slow).  Team 2: 7 + 2 seniors (fast). Inconsistent service.</a:t>
-            </a:r>
-          </a:p>
-          <a:p>
-            <a:pPr>
-              <a:spcAft>
-                <a:spcPts val="600"/>
-              </a:spcAft>
-            </a:pPr>
-            <a:r>
-              <a:rPr sz="1500" b="1">
-                <a:solidFill>
-                  <a:srgbClr val="1F3864"/>
-                </a:solidFill>
-              </a:rPr>
-              <a:t>S5  Low morale / perception (stated)</a:t>
-            </a:r>
-          </a:p>
-          <a:p>
-            <a:pPr lvl="1">
-              <a:spcAft>
-                <a:spcPts val="600"/>
-              </a:spcAft>
-            </a:pPr>
-            <a:r>
-              <a:rPr sz="1400" b="0" i="1">
-                <a:solidFill>
-                  <a:srgbClr val="C0392B"/>
-                </a:solidFill>
-              </a:rPr>
-              <a:t>Assumption: this creates attrition risk and change fatigue.</a:t>
+              <a:t>Assumption: a full ERP consolidation is NOT assumed to be the right answer yet — it should be a business case decided on spend, cost-to-serve and lock-in data.</a:t>
             </a:r>
           </a:p>
         </p:txBody>
@@ -5663,12 +4898,12 @@
           <a:lstStyle/>
           <a:p>
             <a:r>
-              <a:rPr sz="3000" b="1">
+              <a:rPr sz="2800" b="1">
                 <a:solidFill>
                   <a:srgbClr val="1F3864"/>
                 </a:solidFill>
               </a:rPr>
-              <a:t>Evidence: supplier base is fragmenting, not consolidating</a:t>
+              <a:t>Organisational factors, risks &amp; dependencies</a:t>
             </a:r>
           </a:p>
         </p:txBody>
@@ -5681,8 +4916,8 @@
         </p:nvSpPr>
         <p:spPr>
           <a:xfrm>
-            <a:off x="548640" y="1280160"/>
-            <a:ext cx="11064240" cy="5029200"/>
+            <a:off x="548640" y="1371600"/>
+            <a:ext cx="11064240" cy="5120640"/>
           </a:xfrm>
           <a:prstGeom prst="rect">
             <a:avLst/>
@@ -5697,121 +4932,91 @@
           <a:p>
             <a:pPr>
               <a:spcAft>
-                <a:spcPts val="600"/>
-              </a:spcAft>
-            </a:pPr>
-            <a:r>
-              <a:rPr sz="1600" b="1">
+                <a:spcPts val="500"/>
+              </a:spcAft>
+            </a:pPr>
+            <a:r>
+              <a:rPr sz="1700" b="1">
                 <a:solidFill>
                   <a:srgbClr val="1F3864"/>
                 </a:solidFill>
               </a:rPr>
-              <a:t>2023:  224 suppliers  |  $900M spend</a:t>
+              <a:t>Lack of executive support is itself the #1 dependency — the plan stalls without it.</a:t>
             </a:r>
           </a:p>
           <a:p>
             <a:pPr>
               <a:spcAft>
-                <a:spcPts val="600"/>
-              </a:spcAft>
-            </a:pPr>
-            <a:r>
-              <a:rPr sz="1600" b="1">
-                <a:solidFill>
-                  <a:srgbClr val="1F3864"/>
-                </a:solidFill>
-              </a:rPr>
-              <a:t>2024:  264 suppliers  |  $1,045M spend</a:t>
-            </a:r>
-          </a:p>
-          <a:p>
-            <a:pPr lvl="1">
-              <a:spcAft>
-                <a:spcPts val="600"/>
-              </a:spcAft>
-            </a:pPr>
-            <a:r>
-              <a:rPr sz="1500" b="0">
+                <a:spcPts val="500"/>
+              </a:spcAft>
+            </a:pPr>
+            <a:r>
+              <a:rPr sz="1700" b="0">
                 <a:solidFill>
                   <a:srgbClr val="444444"/>
                 </a:solidFill>
               </a:rPr>
-              <a:t>Suppliers grew +40 (+18%); spend grew +$145M (+16%).</a:t>
-            </a:r>
-          </a:p>
-          <a:p>
-            <a:pPr lvl="1">
-              <a:spcAft>
-                <a:spcPts val="600"/>
-              </a:spcAft>
-            </a:pPr>
-            <a:r>
-              <a:rPr sz="1500" b="0">
+              <a:t>Cultural resistance from 59 autonomous units to giving up control.</a:t>
+            </a:r>
+          </a:p>
+          <a:p>
+            <a:pPr>
+              <a:spcAft>
+                <a:spcPts val="500"/>
+              </a:spcAft>
+            </a:pPr>
+            <a:r>
+              <a:rPr sz="1700" b="0">
                 <a:solidFill>
                   <a:srgbClr val="444444"/>
                 </a:solidFill>
               </a:rPr>
-              <a:t>Average spend per supplier FELL: $4.02M (2023) -&gt; $3.96M (2024).</a:t>
+              <a:t>Multinational complexity — local tax / statutory / regulatory rules limit a single standard.</a:t>
             </a:r>
           </a:p>
           <a:p>
             <a:pPr>
               <a:spcAft>
-                <a:spcPts val="600"/>
-              </a:spcAft>
-            </a:pPr>
-            <a:r>
-              <a:rPr sz="1600" b="1">
-                <a:solidFill>
-                  <a:srgbClr val="1F3864"/>
-                </a:solidFill>
-              </a:rPr>
-              <a:t>What this tells us:</a:t>
-            </a:r>
-          </a:p>
-          <a:p>
-            <a:pPr lvl="1">
-              <a:spcAft>
-                <a:spcPts val="600"/>
-              </a:spcAft>
-            </a:pPr>
-            <a:r>
-              <a:rPr sz="1500" b="0">
+                <a:spcPts val="500"/>
+              </a:spcAft>
+            </a:pPr>
+            <a:r>
+              <a:rPr sz="1700" b="0">
                 <a:solidFill>
                   <a:srgbClr val="444444"/>
                 </a:solidFill>
               </a:rPr>
-              <a:t>The company is adding suppliers faster than it consolidates them — so rising spend is NOT translating into better buying leverage.</a:t>
-            </a:r>
-          </a:p>
-          <a:p>
-            <a:pPr lvl="1">
-              <a:spcAft>
-                <a:spcPts val="600"/>
-              </a:spcAft>
-            </a:pPr>
-            <a:r>
-              <a:rPr sz="1500" b="0">
+              <a:t>Low morale + thin Team 1 capacity — limited bandwidth to absorb change.</a:t>
+            </a:r>
+          </a:p>
+          <a:p>
+            <a:pPr>
+              <a:spcAft>
+                <a:spcPts val="500"/>
+              </a:spcAft>
+            </a:pPr>
+            <a:r>
+              <a:rPr sz="1700" b="0">
                 <a:solidFill>
                   <a:srgbClr val="444444"/>
                 </a:solidFill>
               </a:rPr>
-              <a:t>This is direct evidence for S2 (lost economies of scale) and the fragmented supplier base (R2).</a:t>
+              <a:t>ERP consolidation carries cost, business-continuity and data-migration risk.</a:t>
             </a:r>
           </a:p>
           <a:p>
             <a:pPr>
               <a:spcAft>
-                <a:spcPts val="600"/>
-              </a:spcAft>
-            </a:pPr>
-            <a:r>
-              <a:rPr sz="1600" b="0" i="1">
-                <a:solidFill>
-                  <a:srgbClr val="C0392B"/>
-                </a:solidFill>
-              </a:rPr>
-              <a:t>Assumption: these figures are group-wide across the 59 units; a per-unit / per-category split would sharpen the consolidation opportunity.</a:t>
+                <a:spcPts val="500"/>
+              </a:spcAft>
+            </a:pPr>
+            <a:r>
+              <a:rPr sz="1700" b="0">
+                <a:solidFill>
+                  <a:srgbClr val="444444"/>
+                </a:solidFill>
+              </a:rPr>
+              <a:t>Ongoing M&amp;A may keep re-introducing fragmentation; contractual lock-ins on systems/suppliers.</a:t>
             </a:r>
           </a:p>
         </p:txBody>

</xml_diff>

<commit_message>
Frame organisational factors by People/Process/Governance/Systems and split out risks
Recommendation now explains why the issues are a priority across the four organisational lenses, with a dedicated risks/constraints/dependencies slide; dropped the summary to stay at 12.

https://claude.ai/code/session_014EpSpf3QcBHWNPw4UskYmj
</commit_message>
<xml_diff>
--- a/NextTech_Procurement_Analysis.pptx
+++ b/NextTech_Procurement_Analysis.pptx
@@ -3198,7 +3198,7 @@
                   <a:srgbClr val="1F3864"/>
                 </a:solidFill>
               </a:rPr>
-              <a:t>Information needed before confirming priorities</a:t>
+              <a:t>Key risks, constraints &amp; dependencies affecting prioritisation</a:t>
             </a:r>
           </a:p>
         </p:txBody>
@@ -3231,12 +3231,27 @@
               </a:spcAft>
             </a:pPr>
             <a:r>
-              <a:rPr sz="1700" b="0">
+              <a:rPr sz="1600" b="1">
+                <a:solidFill>
+                  <a:srgbClr val="1F3864"/>
+                </a:solidFill>
+              </a:rPr>
+              <a:t>Dependency: executive sponsorship is the gating dependency — the plan stalls without it.</a:t>
+            </a:r>
+          </a:p>
+          <a:p>
+            <a:pPr>
+              <a:spcAft>
+                <a:spcPts val="500"/>
+              </a:spcAft>
+            </a:pPr>
+            <a:r>
+              <a:rPr sz="1600" b="0">
                 <a:solidFill>
                   <a:srgbClr val="444444"/>
                 </a:solidFill>
               </a:rPr>
-              <a:t>Spend by unit / category / supplier, and supplier overlap across units.</a:t>
+              <a:t>Constraint: 59 autonomous units will resist giving up control (cultural).</a:t>
             </a:r>
           </a:p>
           <a:p>
@@ -3246,12 +3261,12 @@
               </a:spcAft>
             </a:pPr>
             <a:r>
-              <a:rPr sz="1700" b="0">
+              <a:rPr sz="1600" b="0">
                 <a:solidFill>
                   <a:srgbClr val="444444"/>
                 </a:solidFill>
               </a:rPr>
-              <a:t>Invoice volumes, cycle times, late-payment penalties and maverick-spend rates.</a:t>
+              <a:t>Constraint: multinational tax / statutory / regulatory rules limit a single standard.</a:t>
             </a:r>
           </a:p>
           <a:p>
@@ -3261,12 +3276,12 @@
               </a:spcAft>
             </a:pPr>
             <a:r>
-              <a:rPr sz="1700" b="0">
+              <a:rPr sz="1600" b="0">
                 <a:solidFill>
                   <a:srgbClr val="444444"/>
                 </a:solidFill>
               </a:rPr>
-              <a:t>Cost of running the three ERPs (licences + support).</a:t>
+              <a:t>Constraint: thin Team 1 capacity + low morale limit bandwidth to absorb change.</a:t>
             </a:r>
           </a:p>
           <a:p>
@@ -3276,12 +3291,12 @@
               </a:spcAft>
             </a:pPr>
             <a:r>
-              <a:rPr sz="1700" b="0">
+              <a:rPr sz="1600" b="0">
                 <a:solidFill>
                   <a:srgbClr val="444444"/>
                 </a:solidFill>
               </a:rPr>
-              <a:t>Share of the 1.8M daily transactions that is low-value/tail vs strategic, and cost-to-process per order.</a:t>
+              <a:t>Risk: ERP consolidation carries cost, business-continuity and data-migration risk.</a:t>
             </a:r>
           </a:p>
           <a:p>
@@ -3291,27 +3306,12 @@
               </a:spcAft>
             </a:pPr>
             <a:r>
-              <a:rPr sz="1700" b="0">
+              <a:rPr sz="1600" b="0">
                 <a:solidFill>
                   <a:srgbClr val="444444"/>
                 </a:solidFill>
               </a:rPr>
-              <a:t>Number of catalogue items and contracts; contractual lock-ins.</a:t>
-            </a:r>
-          </a:p>
-          <a:p>
-            <a:pPr>
-              <a:spcAft>
-                <a:spcPts val="500"/>
-              </a:spcAft>
-            </a:pPr>
-            <a:r>
-              <a:rPr sz="1700" b="0">
-                <a:solidFill>
-                  <a:srgbClr val="444444"/>
-                </a:solidFill>
-              </a:rPr>
-              <a:t>Budget, timeline and genuine executive appetite for change.</a:t>
+              <a:t>Risk: ongoing M&amp;A may keep re-introducing fragmentation; contractual lock-ins on systems/suppliers.</a:t>
             </a:r>
           </a:p>
         </p:txBody>
@@ -3362,17 +3362,7 @@
                   <a:srgbClr val="1F3864"/>
                 </a:solidFill>
               </a:rPr>
-              <a:t>3. Five questions for the client</a:t>
-            </a:r>
-          </a:p>
-          <a:p>
-            <a:r>
-              <a:rPr sz="1500" i="1">
-                <a:solidFill>
-                  <a:srgbClr val="C0392B"/>
-                </a:solidFill>
-              </a:rPr>
-              <a:t>To better inform our work</a:t>
+              <a:t>Information needed before confirming priorities</a:t>
             </a:r>
           </a:p>
         </p:txBody>
@@ -3385,7 +3375,7 @@
         </p:nvSpPr>
         <p:spPr>
           <a:xfrm>
-            <a:off x="548640" y="1280160"/>
+            <a:off x="548640" y="1371600"/>
             <a:ext cx="11064240" cy="5120640"/>
           </a:xfrm>
           <a:prstGeom prst="rect">
@@ -3405,12 +3395,12 @@
               </a:spcAft>
             </a:pPr>
             <a:r>
-              <a:rPr sz="1500" b="1">
-                <a:solidFill>
-                  <a:srgbClr val="1F3864"/>
-                </a:solidFill>
-              </a:rPr>
-              <a:t>1.  Spend &amp; suppliers — total spend, split across the 59 units, and how much supplier overlap exists between them?</a:t>
+              <a:rPr sz="1700" b="0">
+                <a:solidFill>
+                  <a:srgbClr val="444444"/>
+                </a:solidFill>
+              </a:rPr>
+              <a:t>Spend by unit / category / supplier, and supplier overlap across units.</a:t>
             </a:r>
           </a:p>
           <a:p>
@@ -3420,12 +3410,12 @@
               </a:spcAft>
             </a:pPr>
             <a:r>
-              <a:rPr sz="1500" b="1">
-                <a:solidFill>
-                  <a:srgbClr val="1F3864"/>
-                </a:solidFill>
-              </a:rPr>
-              <a:t>2.  Governance — is there executive appetite to mandate a single, compliant operating model, and who would sponsor it?</a:t>
+              <a:rPr sz="1700" b="0">
+                <a:solidFill>
+                  <a:srgbClr val="444444"/>
+                </a:solidFill>
+              </a:rPr>
+              <a:t>Invoice volumes, cycle times, late-payment penalties and maverick-spend rates.</a:t>
             </a:r>
           </a:p>
           <a:p>
@@ -3435,12 +3425,12 @@
               </a:spcAft>
             </a:pPr>
             <a:r>
-              <a:rPr sz="1500" b="1">
-                <a:solidFill>
-                  <a:srgbClr val="1F3864"/>
-                </a:solidFill>
-              </a:rPr>
-              <a:t>3.  Transaction mix — of the 1.8M daily transactions, what share is low-value/tail, and what does one order cost to process today?</a:t>
+              <a:rPr sz="1700" b="0">
+                <a:solidFill>
+                  <a:srgbClr val="444444"/>
+                </a:solidFill>
+              </a:rPr>
+              <a:t>Cost of running the three ERPs (licences + support).</a:t>
             </a:r>
           </a:p>
           <a:p>
@@ -3450,12 +3440,12 @@
               </a:spcAft>
             </a:pPr>
             <a:r>
-              <a:rPr sz="1500" b="1">
-                <a:solidFill>
-                  <a:srgbClr val="1F3864"/>
-                </a:solidFill>
-              </a:rPr>
-              <a:t>4.  Systems — is ERP consolidation on the table, what lock-ins exist, and is the target shared services or continued unit autonomy?</a:t>
+              <a:rPr sz="1700" b="0">
+                <a:solidFill>
+                  <a:srgbClr val="444444"/>
+                </a:solidFill>
+              </a:rPr>
+              <a:t>Share of the 1.8M daily transactions that is low-value/tail vs strategic, and cost-to-process per order.</a:t>
             </a:r>
           </a:p>
           <a:p>
@@ -3465,12 +3455,27 @@
               </a:spcAft>
             </a:pPr>
             <a:r>
-              <a:rPr sz="1500" b="1">
-                <a:solidFill>
-                  <a:srgbClr val="1F3864"/>
-                </a:solidFill>
-              </a:rPr>
-              <a:t>5.  People — what's driving low morale, are Team 1's vacancies funded, and can resource move between the two teams?</a:t>
+              <a:rPr sz="1700" b="0">
+                <a:solidFill>
+                  <a:srgbClr val="444444"/>
+                </a:solidFill>
+              </a:rPr>
+              <a:t>Number of catalogue items and contracts; contractual lock-ins.</a:t>
+            </a:r>
+          </a:p>
+          <a:p>
+            <a:pPr>
+              <a:spcAft>
+                <a:spcPts val="500"/>
+              </a:spcAft>
+            </a:pPr>
+            <a:r>
+              <a:rPr sz="1700" b="0">
+                <a:solidFill>
+                  <a:srgbClr val="444444"/>
+                </a:solidFill>
+              </a:rPr>
+              <a:t>Budget, timeline and genuine executive appetite for change.</a:t>
             </a:r>
           </a:p>
         </p:txBody>
@@ -3521,7 +3526,17 @@
                   <a:srgbClr val="1F3864"/>
                 </a:solidFill>
               </a:rPr>
-              <a:t>In summary</a:t>
+              <a:t>3. Five questions for the client</a:t>
+            </a:r>
+          </a:p>
+          <a:p>
+            <a:r>
+              <a:rPr sz="1500" i="1">
+                <a:solidFill>
+                  <a:srgbClr val="C0392B"/>
+                </a:solidFill>
+              </a:rPr>
+              <a:t>To better inform our work</a:t>
             </a:r>
           </a:p>
         </p:txBody>
@@ -3534,7 +3549,7 @@
         </p:nvSpPr>
         <p:spPr>
           <a:xfrm>
-            <a:off x="548640" y="1463040"/>
+            <a:off x="548640" y="1280160"/>
             <a:ext cx="11064240" cy="5120640"/>
           </a:xfrm>
           <a:prstGeom prst="rect">
@@ -3554,12 +3569,12 @@
               </a:spcAft>
             </a:pPr>
             <a:r>
-              <a:rPr sz="1700" b="1">
+              <a:rPr sz="1500" b="1">
                 <a:solidFill>
                   <a:srgbClr val="1F3864"/>
                 </a:solidFill>
               </a:rPr>
-              <a:t>The real problem: one company is run as 59, so spend, suppliers and systems keep fragmenting.</a:t>
+              <a:t>1.  Spend &amp; suppliers — total spend, split across the 59 units, and how much supplier overlap exists between them?</a:t>
             </a:r>
           </a:p>
           <a:p>
@@ -3569,12 +3584,12 @@
               </a:spcAft>
             </a:pPr>
             <a:r>
-              <a:rPr sz="1700" b="1">
+              <a:rPr sz="1500" b="1">
                 <a:solidFill>
                   <a:srgbClr val="1F3864"/>
                 </a:solidFill>
               </a:rPr>
-              <a:t>Most important issue: no executive mandate to enforce standardisation (R1) — it blocks everything else.</a:t>
+              <a:t>2.  Governance — is there executive appetite to mandate a single, compliant operating model, and who would sponsor it?</a:t>
             </a:r>
           </a:p>
           <a:p>
@@ -3584,12 +3599,12 @@
               </a:spcAft>
             </a:pPr>
             <a:r>
-              <a:rPr sz="1700" b="1">
+              <a:rPr sz="1500" b="1">
                 <a:solidFill>
                   <a:srgbClr val="1F3864"/>
                 </a:solidFill>
               </a:rPr>
-              <a:t>Recommended now: 1) get exec sponsorship, 2) standardise P2P + tail spend, 3) rebalance the teams.</a:t>
+              <a:t>3.  Transaction mix — of the 1.8M daily transactions, what share is low-value/tail, and what does one order cost to process today?</a:t>
             </a:r>
           </a:p>
           <a:p>
@@ -3599,12 +3614,12 @@
               </a:spcAft>
             </a:pPr>
             <a:r>
-              <a:rPr sz="1700" b="0">
-                <a:solidFill>
-                  <a:srgbClr val="444444"/>
-                </a:solidFill>
-              </a:rPr>
-              <a:t>Later, only if the data supports it: ERP consolidation, supplier rationalisation, shared services.</a:t>
+              <a:rPr sz="1500" b="1">
+                <a:solidFill>
+                  <a:srgbClr val="1F3864"/>
+                </a:solidFill>
+              </a:rPr>
+              <a:t>4.  Systems — is ERP consolidation on the table, what lock-ins exist, and is the target shared services or continued unit autonomy?</a:t>
             </a:r>
           </a:p>
           <a:p>
@@ -3614,12 +3629,12 @@
               </a:spcAft>
             </a:pPr>
             <a:r>
-              <a:rPr sz="1700" b="0">
-                <a:solidFill>
-                  <a:srgbClr val="444444"/>
-                </a:solidFill>
-              </a:rPr>
-              <a:t>Next step: get the spend/transaction data and answers to the five questions to confirm the plan.</a:t>
+              <a:rPr sz="1500" b="1">
+                <a:solidFill>
+                  <a:srgbClr val="1F3864"/>
+                </a:solidFill>
+              </a:rPr>
+              <a:t>5.  People — what's driving low morale, are Team 1's vacancies funded, and can resource move between the two teams?</a:t>
             </a:r>
           </a:p>
         </p:txBody>
@@ -4903,7 +4918,17 @@
                   <a:srgbClr val="1F3864"/>
                 </a:solidFill>
               </a:rPr>
-              <a:t>Organisational factors, risks &amp; dependencies</a:t>
+              <a:t>Why this is a priority — organisational factors</a:t>
+            </a:r>
+          </a:p>
+          <a:p>
+            <a:r>
+              <a:rPr sz="1500" i="1">
+                <a:solidFill>
+                  <a:srgbClr val="C0392B"/>
+                </a:solidFill>
+              </a:rPr>
+              <a:t>People · Process · Governance · Systems</a:t>
             </a:r>
           </a:p>
         </p:txBody>
@@ -4916,7 +4941,7 @@
         </p:nvSpPr>
         <p:spPr>
           <a:xfrm>
-            <a:off x="548640" y="1371600"/>
+            <a:off x="548640" y="1280160"/>
             <a:ext cx="11064240" cy="5120640"/>
           </a:xfrm>
           <a:prstGeom prst="rect">
@@ -4936,12 +4961,27 @@
               </a:spcAft>
             </a:pPr>
             <a:r>
-              <a:rPr sz="1700" b="1">
+              <a:rPr sz="1500" b="1">
                 <a:solidFill>
                   <a:srgbClr val="1F3864"/>
                 </a:solidFill>
               </a:rPr>
-              <a:t>Lack of executive support is itself the #1 dependency — the plan stalls without it.</a:t>
+              <a:t>People</a:t>
+            </a:r>
+          </a:p>
+          <a:p>
+            <a:pPr lvl="1">
+              <a:spcAft>
+                <a:spcPts val="500"/>
+              </a:spcAft>
+            </a:pPr>
+            <a:r>
+              <a:rPr sz="1400" b="0">
+                <a:solidFill>
+                  <a:srgbClr val="444444"/>
+                </a:solidFill>
+              </a:rPr>
+              <a:t>Imbalanced teams (Team 1 understaffed, 2 vacancies, part-timers) + low morale + 'low-value' perception = limited capacity and appetite to deliver change.</a:t>
             </a:r>
           </a:p>
           <a:p>
@@ -4951,12 +4991,27 @@
               </a:spcAft>
             </a:pPr>
             <a:r>
-              <a:rPr sz="1700" b="0">
+              <a:rPr sz="1500" b="1">
+                <a:solidFill>
+                  <a:srgbClr val="1F3864"/>
+                </a:solidFill>
+              </a:rPr>
+              <a:t>Process</a:t>
+            </a:r>
+          </a:p>
+          <a:p>
+            <a:pPr lvl="1">
+              <a:spcAft>
+                <a:spcPts val="500"/>
+              </a:spcAft>
+            </a:pPr>
+            <a:r>
+              <a:rPr sz="1400" b="0">
                 <a:solidFill>
                   <a:srgbClr val="444444"/>
                 </a:solidFill>
               </a:rPr>
-              <a:t>Cultural resistance from 59 autonomous units to giving up control.</a:t>
+              <a:t>No standard P2P, manual processes, catalogue proliferation, multiple orders for low-value items — inefficiency scales to 1.8M txns/day.</a:t>
             </a:r>
           </a:p>
           <a:p>
@@ -4966,12 +5021,27 @@
               </a:spcAft>
             </a:pPr>
             <a:r>
-              <a:rPr sz="1700" b="0">
+              <a:rPr sz="1500" b="1">
+                <a:solidFill>
+                  <a:srgbClr val="1F3864"/>
+                </a:solidFill>
+              </a:rPr>
+              <a:t>Governance</a:t>
+            </a:r>
+          </a:p>
+          <a:p>
+            <a:pPr lvl="1">
+              <a:spcAft>
+                <a:spcPts val="500"/>
+              </a:spcAft>
+            </a:pPr>
+            <a:r>
+              <a:rPr sz="1400" b="0">
                 <a:solidFill>
                   <a:srgbClr val="444444"/>
                 </a:solidFill>
               </a:rPr>
-              <a:t>Multinational complexity — local tax / statutory / regulatory rules limit a single standard.</a:t>
+              <a:t>No executive mandate; teams accountable but cannot enforce compliance across 59 units — this is what elevates everything to a priority.</a:t>
             </a:r>
           </a:p>
           <a:p>
@@ -4981,42 +5051,27 @@
               </a:spcAft>
             </a:pPr>
             <a:r>
-              <a:rPr sz="1700" b="0">
+              <a:rPr sz="1500" b="1">
+                <a:solidFill>
+                  <a:srgbClr val="1F3864"/>
+                </a:solidFill>
+              </a:rPr>
+              <a:t>Systems</a:t>
+            </a:r>
+          </a:p>
+          <a:p>
+            <a:pPr lvl="1">
+              <a:spcAft>
+                <a:spcPts val="500"/>
+              </a:spcAft>
+            </a:pPr>
+            <a:r>
+              <a:rPr sz="1400" b="0">
                 <a:solidFill>
                   <a:srgbClr val="444444"/>
                 </a:solidFill>
               </a:rPr>
-              <a:t>Low morale + thin Team 1 capacity — limited bandwidth to absorb change.</a:t>
-            </a:r>
-          </a:p>
-          <a:p>
-            <a:pPr>
-              <a:spcAft>
-                <a:spcPts val="500"/>
-              </a:spcAft>
-            </a:pPr>
-            <a:r>
-              <a:rPr sz="1700" b="0">
-                <a:solidFill>
-                  <a:srgbClr val="444444"/>
-                </a:solidFill>
-              </a:rPr>
-              <a:t>ERP consolidation carries cost, business-continuity and data-migration risk.</a:t>
-            </a:r>
-          </a:p>
-          <a:p>
-            <a:pPr>
-              <a:spcAft>
-                <a:spcPts val="500"/>
-              </a:spcAft>
-            </a:pPr>
-            <a:r>
-              <a:rPr sz="1700" b="0">
-                <a:solidFill>
-                  <a:srgbClr val="444444"/>
-                </a:solidFill>
-              </a:rPr>
-              <a:t>Ongoing M&amp;A may keep re-introducing fragmentation; contractual lock-ins on systems/suppliers.</a:t>
+              <a:t>Three poorly integrated ERPs (Oracle/SAP/PeopleSoft) -&gt; manual rework, no consolidated spend data, high IT/training cost.</a:t>
             </a:r>
           </a:p>
         </p:txBody>

</xml_diff>

<commit_message>
Add speaker-notes script to every slide
Embed a natural presenter script in the notes of all 12 slides so the talk reads as a confident, well-understood case walkthrough.

https://claude.ai/code/session_014EpSpf3QcBHWNPw4UskYmj
</commit_message>
<xml_diff>
--- a/NextTech_Procurement_Analysis.pptx
+++ b/NextTech_Procurement_Analysis.pptx
@@ -116,6 +116,1196 @@
     </a:lvl9pPr>
   </p:defaultTextStyle>
 </p:presentation>
+</file>
+
+<file path=ppt/notesMasters/notesMaster1.xml><?xml version="1.0" encoding="utf-8"?>
+<p:notesMaster xmlns:a="http://schemas.openxmlformats.org/drawingml/2006/main" xmlns:p="http://schemas.openxmlformats.org/presentationml/2006/main" xmlns:r="http://schemas.openxmlformats.org/officeDocument/2006/relationships">
+  <p:cSld>
+    <p:bg>
+      <p:bgRef idx="1001">
+        <a:schemeClr val="bg1"/>
+      </p:bgRef>
+    </p:bg>
+    <p:spTree>
+      <p:nvGrpSpPr>
+        <p:cNvPr id="1" name=""/>
+        <p:cNvGrpSpPr/>
+        <p:nvPr/>
+      </p:nvGrpSpPr>
+      <p:grpSpPr>
+        <a:xfrm>
+          <a:off x="0" y="0"/>
+          <a:ext cx="0" cy="0"/>
+          <a:chOff x="0" y="0"/>
+          <a:chExt cx="0" cy="0"/>
+        </a:xfrm>
+      </p:grpSpPr>
+      <p:sp>
+        <p:nvSpPr>
+          <p:cNvPr id="2" name="Header Placeholder 1"/>
+          <p:cNvSpPr>
+            <a:spLocks noGrp="1"/>
+          </p:cNvSpPr>
+          <p:nvPr>
+            <p:ph type="hdr" sz="quarter"/>
+          </p:nvPr>
+        </p:nvSpPr>
+        <p:spPr>
+          <a:xfrm>
+            <a:off x="0" y="0"/>
+            <a:ext cx="2971800" cy="457200"/>
+          </a:xfrm>
+          <a:prstGeom prst="rect">
+            <a:avLst/>
+          </a:prstGeom>
+        </p:spPr>
+        <p:txBody>
+          <a:bodyPr vert="horz" lIns="91440" tIns="45720" rIns="91440" bIns="45720" rtlCol="0"/>
+          <a:lstStyle>
+            <a:lvl1pPr algn="l">
+              <a:defRPr sz="1200"/>
+            </a:lvl1pPr>
+          </a:lstStyle>
+          <a:p>
+            <a:endParaRPr lang="en-US"/>
+          </a:p>
+        </p:txBody>
+      </p:sp>
+      <p:sp>
+        <p:nvSpPr>
+          <p:cNvPr id="3" name="Date Placeholder 2"/>
+          <p:cNvSpPr>
+            <a:spLocks noGrp="1"/>
+          </p:cNvSpPr>
+          <p:nvPr>
+            <p:ph type="dt" idx="1"/>
+          </p:nvPr>
+        </p:nvSpPr>
+        <p:spPr>
+          <a:xfrm>
+            <a:off x="3884613" y="0"/>
+            <a:ext cx="2971800" cy="457200"/>
+          </a:xfrm>
+          <a:prstGeom prst="rect">
+            <a:avLst/>
+          </a:prstGeom>
+        </p:spPr>
+        <p:txBody>
+          <a:bodyPr vert="horz" lIns="91440" tIns="45720" rIns="91440" bIns="45720" rtlCol="0"/>
+          <a:lstStyle>
+            <a:lvl1pPr algn="r">
+              <a:defRPr sz="1200"/>
+            </a:lvl1pPr>
+          </a:lstStyle>
+          <a:p>
+            <a:fld id="{0F89C1C7-3DCD-1040-A9CF-14679D8B5DDD}" type="datetimeFigureOut">
+              <a:rPr lang="en-US" smtClean="0"/>
+              <a:t>10/17/16</a:t>
+            </a:fld>
+            <a:endParaRPr lang="en-US"/>
+          </a:p>
+        </p:txBody>
+      </p:sp>
+      <p:sp>
+        <p:nvSpPr>
+          <p:cNvPr id="4" name="Slide Image Placeholder 3"/>
+          <p:cNvSpPr>
+            <a:spLocks noGrp="1" noRot="1" noChangeAspect="1"/>
+          </p:cNvSpPr>
+          <p:nvPr>
+            <p:ph type="sldImg" idx="2"/>
+          </p:nvPr>
+        </p:nvSpPr>
+        <p:spPr>
+          <a:xfrm>
+            <a:off x="1143000" y="685800"/>
+            <a:ext cx="4572000" cy="3429000"/>
+          </a:xfrm>
+          <a:prstGeom prst="rect">
+            <a:avLst/>
+          </a:prstGeom>
+          <a:noFill/>
+          <a:ln w="12700">
+            <a:solidFill>
+              <a:prstClr val="black"/>
+            </a:solidFill>
+          </a:ln>
+        </p:spPr>
+        <p:txBody>
+          <a:bodyPr vert="horz" lIns="91440" tIns="45720" rIns="91440" bIns="45720" rtlCol="0" anchor="ctr"/>
+          <a:lstStyle/>
+          <a:p>
+            <a:endParaRPr lang="en-US"/>
+          </a:p>
+        </p:txBody>
+      </p:sp>
+      <p:sp>
+        <p:nvSpPr>
+          <p:cNvPr id="5" name="Notes Placeholder 4"/>
+          <p:cNvSpPr>
+            <a:spLocks noGrp="1"/>
+          </p:cNvSpPr>
+          <p:nvPr>
+            <p:ph type="body" sz="quarter" idx="3"/>
+          </p:nvPr>
+        </p:nvSpPr>
+        <p:spPr>
+          <a:xfrm>
+            <a:off x="685800" y="4343400"/>
+            <a:ext cx="5486400" cy="4114800"/>
+          </a:xfrm>
+          <a:prstGeom prst="rect">
+            <a:avLst/>
+          </a:prstGeom>
+        </p:spPr>
+        <p:txBody>
+          <a:bodyPr vert="horz" lIns="91440" tIns="45720" rIns="91440" bIns="45720" rtlCol="0"/>
+          <a:lstStyle/>
+          <a:p>
+            <a:pPr lvl="0"/>
+            <a:r>
+              <a:rPr lang="en-US" smtClean="0"/>
+              <a:t>Click to edit Master text styles</a:t>
+            </a:r>
+          </a:p>
+          <a:p>
+            <a:pPr lvl="1"/>
+            <a:r>
+              <a:rPr lang="en-US" smtClean="0"/>
+              <a:t>Second level</a:t>
+            </a:r>
+          </a:p>
+          <a:p>
+            <a:pPr lvl="2"/>
+            <a:r>
+              <a:rPr lang="en-US" smtClean="0"/>
+              <a:t>Third level</a:t>
+            </a:r>
+          </a:p>
+          <a:p>
+            <a:pPr lvl="3"/>
+            <a:r>
+              <a:rPr lang="en-US" smtClean="0"/>
+              <a:t>Fourth level</a:t>
+            </a:r>
+          </a:p>
+          <a:p>
+            <a:pPr lvl="4"/>
+            <a:r>
+              <a:rPr lang="en-US" smtClean="0"/>
+              <a:t>Fifth level</a:t>
+            </a:r>
+            <a:endParaRPr lang="en-US"/>
+          </a:p>
+        </p:txBody>
+      </p:sp>
+      <p:sp>
+        <p:nvSpPr>
+          <p:cNvPr id="6" name="Footer Placeholder 5"/>
+          <p:cNvSpPr>
+            <a:spLocks noGrp="1"/>
+          </p:cNvSpPr>
+          <p:nvPr>
+            <p:ph type="ftr" sz="quarter" idx="4"/>
+          </p:nvPr>
+        </p:nvSpPr>
+        <p:spPr>
+          <a:xfrm>
+            <a:off x="0" y="8685213"/>
+            <a:ext cx="2971800" cy="457200"/>
+          </a:xfrm>
+          <a:prstGeom prst="rect">
+            <a:avLst/>
+          </a:prstGeom>
+        </p:spPr>
+        <p:txBody>
+          <a:bodyPr vert="horz" lIns="91440" tIns="45720" rIns="91440" bIns="45720" rtlCol="0" anchor="b"/>
+          <a:lstStyle>
+            <a:lvl1pPr algn="l">
+              <a:defRPr sz="1200"/>
+            </a:lvl1pPr>
+          </a:lstStyle>
+          <a:p>
+            <a:endParaRPr lang="en-US"/>
+          </a:p>
+        </p:txBody>
+      </p:sp>
+      <p:sp>
+        <p:nvSpPr>
+          <p:cNvPr id="7" name="Slide Number Placeholder 6"/>
+          <p:cNvSpPr>
+            <a:spLocks noGrp="1"/>
+          </p:cNvSpPr>
+          <p:nvPr>
+            <p:ph type="sldNum" sz="quarter" idx="5"/>
+          </p:nvPr>
+        </p:nvSpPr>
+        <p:spPr>
+          <a:xfrm>
+            <a:off x="3884613" y="8685213"/>
+            <a:ext cx="2971800" cy="457200"/>
+          </a:xfrm>
+          <a:prstGeom prst="rect">
+            <a:avLst/>
+          </a:prstGeom>
+        </p:spPr>
+        <p:txBody>
+          <a:bodyPr vert="horz" lIns="91440" tIns="45720" rIns="91440" bIns="45720" rtlCol="0" anchor="b"/>
+          <a:lstStyle>
+            <a:lvl1pPr algn="r">
+              <a:defRPr sz="1200"/>
+            </a:lvl1pPr>
+          </a:lstStyle>
+          <a:p>
+            <a:fld id="{BB5E49A5-4136-284D-997B-48E1D791AD67}" type="slidenum">
+              <a:rPr lang="en-US" smtClean="0"/>
+              <a:t>‹#›</a:t>
+            </a:fld>
+            <a:endParaRPr lang="en-US"/>
+          </a:p>
+        </p:txBody>
+      </p:sp>
+    </p:spTree>
+    <p:extLst>
+      <p:ext uri="{BB962C8B-B14F-4D97-AF65-F5344CB8AC3E}">
+        <p14:creationId xmlns:p14="http://schemas.microsoft.com/office/powerpoint/2010/main" val="2623252185"/>
+      </p:ext>
+    </p:extLst>
+  </p:cSld>
+  <p:clrMap bg1="lt1" tx1="dk1" bg2="lt2" tx2="dk2" accent1="accent1" accent2="accent2" accent3="accent3" accent4="accent4" accent5="accent5" accent6="accent6" hlink="hlink" folHlink="folHlink"/>
+  <p:notesStyle>
+    <a:lvl1pPr marL="0" algn="l" defTabSz="457200" rtl="0" eaLnBrk="1" latinLnBrk="0" hangingPunct="1">
+      <a:defRPr sz="1200" kern="1200">
+        <a:solidFill>
+          <a:schemeClr val="tx1"/>
+        </a:solidFill>
+        <a:latin typeface="+mn-lt"/>
+        <a:ea typeface="+mn-ea"/>
+        <a:cs typeface="+mn-cs"/>
+      </a:defRPr>
+    </a:lvl1pPr>
+    <a:lvl2pPr marL="457200" algn="l" defTabSz="457200" rtl="0" eaLnBrk="1" latinLnBrk="0" hangingPunct="1">
+      <a:defRPr sz="1200" kern="1200">
+        <a:solidFill>
+          <a:schemeClr val="tx1"/>
+        </a:solidFill>
+        <a:latin typeface="+mn-lt"/>
+        <a:ea typeface="+mn-ea"/>
+        <a:cs typeface="+mn-cs"/>
+      </a:defRPr>
+    </a:lvl2pPr>
+    <a:lvl3pPr marL="914400" algn="l" defTabSz="457200" rtl="0" eaLnBrk="1" latinLnBrk="0" hangingPunct="1">
+      <a:defRPr sz="1200" kern="1200">
+        <a:solidFill>
+          <a:schemeClr val="tx1"/>
+        </a:solidFill>
+        <a:latin typeface="+mn-lt"/>
+        <a:ea typeface="+mn-ea"/>
+        <a:cs typeface="+mn-cs"/>
+      </a:defRPr>
+    </a:lvl3pPr>
+    <a:lvl4pPr marL="1371600" algn="l" defTabSz="457200" rtl="0" eaLnBrk="1" latinLnBrk="0" hangingPunct="1">
+      <a:defRPr sz="1200" kern="1200">
+        <a:solidFill>
+          <a:schemeClr val="tx1"/>
+        </a:solidFill>
+        <a:latin typeface="+mn-lt"/>
+        <a:ea typeface="+mn-ea"/>
+        <a:cs typeface="+mn-cs"/>
+      </a:defRPr>
+    </a:lvl4pPr>
+    <a:lvl5pPr marL="1828800" algn="l" defTabSz="457200" rtl="0" eaLnBrk="1" latinLnBrk="0" hangingPunct="1">
+      <a:defRPr sz="1200" kern="1200">
+        <a:solidFill>
+          <a:schemeClr val="tx1"/>
+        </a:solidFill>
+        <a:latin typeface="+mn-lt"/>
+        <a:ea typeface="+mn-ea"/>
+        <a:cs typeface="+mn-cs"/>
+      </a:defRPr>
+    </a:lvl5pPr>
+    <a:lvl6pPr marL="2286000" algn="l" defTabSz="457200" rtl="0" eaLnBrk="1" latinLnBrk="0" hangingPunct="1">
+      <a:defRPr sz="1200" kern="1200">
+        <a:solidFill>
+          <a:schemeClr val="tx1"/>
+        </a:solidFill>
+        <a:latin typeface="+mn-lt"/>
+        <a:ea typeface="+mn-ea"/>
+        <a:cs typeface="+mn-cs"/>
+      </a:defRPr>
+    </a:lvl6pPr>
+    <a:lvl7pPr marL="2743200" algn="l" defTabSz="457200" rtl="0" eaLnBrk="1" latinLnBrk="0" hangingPunct="1">
+      <a:defRPr sz="1200" kern="1200">
+        <a:solidFill>
+          <a:schemeClr val="tx1"/>
+        </a:solidFill>
+        <a:latin typeface="+mn-lt"/>
+        <a:ea typeface="+mn-ea"/>
+        <a:cs typeface="+mn-cs"/>
+      </a:defRPr>
+    </a:lvl7pPr>
+    <a:lvl8pPr marL="3200400" algn="l" defTabSz="457200" rtl="0" eaLnBrk="1" latinLnBrk="0" hangingPunct="1">
+      <a:defRPr sz="1200" kern="1200">
+        <a:solidFill>
+          <a:schemeClr val="tx1"/>
+        </a:solidFill>
+        <a:latin typeface="+mn-lt"/>
+        <a:ea typeface="+mn-ea"/>
+        <a:cs typeface="+mn-cs"/>
+      </a:defRPr>
+    </a:lvl8pPr>
+    <a:lvl9pPr marL="3657600" algn="l" defTabSz="457200" rtl="0" eaLnBrk="1" latinLnBrk="0" hangingPunct="1">
+      <a:defRPr sz="1200" kern="1200">
+        <a:solidFill>
+          <a:schemeClr val="tx1"/>
+        </a:solidFill>
+        <a:latin typeface="+mn-lt"/>
+        <a:ea typeface="+mn-ea"/>
+        <a:cs typeface="+mn-cs"/>
+      </a:defRPr>
+    </a:lvl9pPr>
+  </p:notesStyle>
+</p:notesMaster>
+</file>
+
+<file path=ppt/notesSlides/notesSlide1.xml><?xml version="1.0" encoding="utf-8"?>
+<p:notes xmlns:a="http://schemas.openxmlformats.org/drawingml/2006/main" xmlns:p="http://schemas.openxmlformats.org/presentationml/2006/main" xmlns:r="http://schemas.openxmlformats.org/officeDocument/2006/relationships">
+  <p:cSld>
+    <p:spTree>
+      <p:nvGrpSpPr>
+        <p:cNvPr id="1" name=""/>
+        <p:cNvGrpSpPr/>
+        <p:nvPr/>
+      </p:nvGrpSpPr>
+      <p:grpSpPr>
+        <a:xfrm>
+          <a:off x="0" y="0"/>
+          <a:ext cx="0" cy="0"/>
+          <a:chOff x="0" y="0"/>
+          <a:chExt cx="0" cy="0"/>
+        </a:xfrm>
+      </p:grpSpPr>
+      <p:sp>
+        <p:nvSpPr>
+          <p:cNvPr id="2" name="Slide Image Placeholder 1"/>
+          <p:cNvSpPr>
+            <a:spLocks noGrp="1"/>
+          </p:cNvSpPr>
+          <p:nvPr>
+            <p:ph type="sldImg" idx="2"/>
+          </p:nvPr>
+        </p:nvSpPr>
+        <p:spPr/>
+      </p:sp>
+      <p:sp>
+        <p:nvSpPr>
+          <p:cNvPr id="3" name="Notes Placeholder 2"/>
+          <p:cNvSpPr>
+            <a:spLocks noGrp="1"/>
+          </p:cNvSpPr>
+          <p:nvPr>
+            <p:ph type="body" idx="3" sz="quarter"/>
+          </p:nvPr>
+        </p:nvSpPr>
+        <p:spPr/>
+        <p:txBody>
+          <a:bodyPr/>
+          <a:lstStyle/>
+          <a:p>
+            <a:r>
+              <a:t>Thanks everyone. Over the next few minutes I'll walk through three things: first the procurement issues we've identified and the impact they're having; second what we'd prioritise and why; and third the questions we'd put back to the client. I'll flag where we've made assumptions, because some of this needs data to confirm.</a:t>
+            </a:r>
+          </a:p>
+        </p:txBody>
+      </p:sp>
+      <p:sp>
+        <p:nvSpPr>
+          <p:cNvPr id="4" name="Slide Number Placeholder 3"/>
+          <p:cNvSpPr>
+            <a:spLocks noGrp="1"/>
+          </p:cNvSpPr>
+          <p:nvPr>
+            <p:ph type="sldNum" idx="5" sz="quarter"/>
+          </p:nvPr>
+        </p:nvSpPr>
+        <p:spPr/>
+      </p:sp>
+    </p:spTree>
+  </p:cSld>
+  <p:clrMapOvr>
+    <a:masterClrMapping/>
+  </p:clrMapOvr>
+</p:notes>
+</file>
+
+<file path=ppt/notesSlides/notesSlide10.xml><?xml version="1.0" encoding="utf-8"?>
+<p:notes xmlns:a="http://schemas.openxmlformats.org/drawingml/2006/main" xmlns:p="http://schemas.openxmlformats.org/presentationml/2006/main" xmlns:r="http://schemas.openxmlformats.org/officeDocument/2006/relationships">
+  <p:cSld>
+    <p:spTree>
+      <p:nvGrpSpPr>
+        <p:cNvPr id="1" name=""/>
+        <p:cNvGrpSpPr/>
+        <p:nvPr/>
+      </p:nvGrpSpPr>
+      <p:grpSpPr>
+        <a:xfrm>
+          <a:off x="0" y="0"/>
+          <a:ext cx="0" cy="0"/>
+          <a:chOff x="0" y="0"/>
+          <a:chExt cx="0" cy="0"/>
+        </a:xfrm>
+      </p:grpSpPr>
+      <p:sp>
+        <p:nvSpPr>
+          <p:cNvPr id="2" name="Slide Image Placeholder 1"/>
+          <p:cNvSpPr>
+            <a:spLocks noGrp="1"/>
+          </p:cNvSpPr>
+          <p:nvPr>
+            <p:ph type="sldImg" idx="2"/>
+          </p:nvPr>
+        </p:nvSpPr>
+        <p:spPr/>
+      </p:sp>
+      <p:sp>
+        <p:nvSpPr>
+          <p:cNvPr id="3" name="Notes Placeholder 2"/>
+          <p:cNvSpPr>
+            <a:spLocks noGrp="1"/>
+          </p:cNvSpPr>
+          <p:nvPr>
+            <p:ph type="body" idx="3" sz="quarter"/>
+          </p:nvPr>
+        </p:nvSpPr>
+        <p:spPr/>
+        <p:txBody>
+          <a:bodyPr/>
+          <a:lstStyle/>
+          <a:p>
+            <a:r>
+              <a:t>On risks and dependencies that could affect how we prioritise. The gating dependency is executive sponsorship — without it the plan stalls, full stop. We'd expect cultural resistance from 59 units used to autonomy. Being multinational, local tax and regulatory rules limit how far we can impose a single standard. Team 1's thin capacity limits how much change they can absorb. ERP consolidation carries real cost and business-continuity risk. And ongoing M&amp;A could keep re-introducing fragmentation, so this needs to be sustainable, not a one-off.</a:t>
+            </a:r>
+          </a:p>
+        </p:txBody>
+      </p:sp>
+      <p:sp>
+        <p:nvSpPr>
+          <p:cNvPr id="4" name="Slide Number Placeholder 3"/>
+          <p:cNvSpPr>
+            <a:spLocks noGrp="1"/>
+          </p:cNvSpPr>
+          <p:nvPr>
+            <p:ph type="sldNum" idx="5" sz="quarter"/>
+          </p:nvPr>
+        </p:nvSpPr>
+        <p:spPr/>
+      </p:sp>
+    </p:spTree>
+  </p:cSld>
+  <p:clrMapOvr>
+    <a:masterClrMapping/>
+  </p:clrMapOvr>
+</p:notes>
+</file>
+
+<file path=ppt/notesSlides/notesSlide11.xml><?xml version="1.0" encoding="utf-8"?>
+<p:notes xmlns:a="http://schemas.openxmlformats.org/drawingml/2006/main" xmlns:p="http://schemas.openxmlformats.org/presentationml/2006/main" xmlns:r="http://schemas.openxmlformats.org/officeDocument/2006/relationships">
+  <p:cSld>
+    <p:spTree>
+      <p:nvGrpSpPr>
+        <p:cNvPr id="1" name=""/>
+        <p:cNvGrpSpPr/>
+        <p:nvPr/>
+      </p:nvGrpSpPr>
+      <p:grpSpPr>
+        <a:xfrm>
+          <a:off x="0" y="0"/>
+          <a:ext cx="0" cy="0"/>
+          <a:chOff x="0" y="0"/>
+          <a:chExt cx="0" cy="0"/>
+        </a:xfrm>
+      </p:grpSpPr>
+      <p:sp>
+        <p:nvSpPr>
+          <p:cNvPr id="2" name="Slide Image Placeholder 1"/>
+          <p:cNvSpPr>
+            <a:spLocks noGrp="1"/>
+          </p:cNvSpPr>
+          <p:nvPr>
+            <p:ph type="sldImg" idx="2"/>
+          </p:nvPr>
+        </p:nvSpPr>
+        <p:spPr/>
+      </p:sp>
+      <p:sp>
+        <p:nvSpPr>
+          <p:cNvPr id="3" name="Notes Placeholder 2"/>
+          <p:cNvSpPr>
+            <a:spLocks noGrp="1"/>
+          </p:cNvSpPr>
+          <p:nvPr>
+            <p:ph type="body" idx="3" sz="quarter"/>
+          </p:nvPr>
+        </p:nvSpPr>
+        <p:spPr/>
+        <p:txBody>
+          <a:bodyPr/>
+          <a:lstStyle/>
+          <a:p>
+            <a:r>
+              <a:t>Before we commit to this prioritisation, there's information we'd want: spend by unit, category and supplier, and how much supplier overlap there is; invoice volumes, cycle times and any late-payment penalties; the cost of running the three ERPs; what share of the 1.8 million daily transactions is low-value tail spend and what one order costs to process; the number of catalogue items and contracts; and the budget, timeline and genuine executive appetite for change.</a:t>
+            </a:r>
+          </a:p>
+        </p:txBody>
+      </p:sp>
+      <p:sp>
+        <p:nvSpPr>
+          <p:cNvPr id="4" name="Slide Number Placeholder 3"/>
+          <p:cNvSpPr>
+            <a:spLocks noGrp="1"/>
+          </p:cNvSpPr>
+          <p:nvPr>
+            <p:ph type="sldNum" idx="5" sz="quarter"/>
+          </p:nvPr>
+        </p:nvSpPr>
+        <p:spPr/>
+      </p:sp>
+    </p:spTree>
+  </p:cSld>
+  <p:clrMapOvr>
+    <a:masterClrMapping/>
+  </p:clrMapOvr>
+</p:notes>
+</file>
+
+<file path=ppt/notesSlides/notesSlide12.xml><?xml version="1.0" encoding="utf-8"?>
+<p:notes xmlns:a="http://schemas.openxmlformats.org/drawingml/2006/main" xmlns:p="http://schemas.openxmlformats.org/presentationml/2006/main" xmlns:r="http://schemas.openxmlformats.org/officeDocument/2006/relationships">
+  <p:cSld>
+    <p:spTree>
+      <p:nvGrpSpPr>
+        <p:cNvPr id="1" name=""/>
+        <p:cNvGrpSpPr/>
+        <p:nvPr/>
+      </p:nvGrpSpPr>
+      <p:grpSpPr>
+        <a:xfrm>
+          <a:off x="0" y="0"/>
+          <a:ext cx="0" cy="0"/>
+          <a:chOff x="0" y="0"/>
+          <a:chExt cx="0" cy="0"/>
+        </a:xfrm>
+      </p:grpSpPr>
+      <p:sp>
+        <p:nvSpPr>
+          <p:cNvPr id="2" name="Slide Image Placeholder 1"/>
+          <p:cNvSpPr>
+            <a:spLocks noGrp="1"/>
+          </p:cNvSpPr>
+          <p:nvPr>
+            <p:ph type="sldImg" idx="2"/>
+          </p:nvPr>
+        </p:nvSpPr>
+        <p:spPr/>
+      </p:sp>
+      <p:sp>
+        <p:nvSpPr>
+          <p:cNvPr id="3" name="Notes Placeholder 2"/>
+          <p:cNvSpPr>
+            <a:spLocks noGrp="1"/>
+          </p:cNvSpPr>
+          <p:nvPr>
+            <p:ph type="body" idx="3" sz="quarter"/>
+          </p:nvPr>
+        </p:nvSpPr>
+        <p:spPr/>
+        <p:txBody>
+          <a:bodyPr/>
+          <a:lstStyle/>
+          <a:p>
+            <a:r>
+              <a:t>Which leads to the five questions we'd put to the client. One — spend and suppliers: total spend, how it splits across the 59 units, and the supplier overlap. Two — governance: is there appetite to mandate a single operating model, and who'd sponsor it. Three — transaction mix: how much of the 1.8 million is tail spend and what does an order cost to process. Four — systems: is ERP consolidation on the table, what's locked in, and is the target shared services or continued autonomy. And five — people: what's driving the low morale, are the vacancies funded, and can resource move between the teams. Those answers would let us confirm the plan. Happy to take questions.</a:t>
+            </a:r>
+          </a:p>
+        </p:txBody>
+      </p:sp>
+      <p:sp>
+        <p:nvSpPr>
+          <p:cNvPr id="4" name="Slide Number Placeholder 3"/>
+          <p:cNvSpPr>
+            <a:spLocks noGrp="1"/>
+          </p:cNvSpPr>
+          <p:nvPr>
+            <p:ph type="sldNum" idx="5" sz="quarter"/>
+          </p:nvPr>
+        </p:nvSpPr>
+        <p:spPr/>
+      </p:sp>
+    </p:spTree>
+  </p:cSld>
+  <p:clrMapOvr>
+    <a:masterClrMapping/>
+  </p:clrMapOvr>
+</p:notes>
+</file>
+
+<file path=ppt/notesSlides/notesSlide2.xml><?xml version="1.0" encoding="utf-8"?>
+<p:notes xmlns:a="http://schemas.openxmlformats.org/drawingml/2006/main" xmlns:p="http://schemas.openxmlformats.org/presentationml/2006/main" xmlns:r="http://schemas.openxmlformats.org/officeDocument/2006/relationships">
+  <p:cSld>
+    <p:spTree>
+      <p:nvGrpSpPr>
+        <p:cNvPr id="1" name=""/>
+        <p:cNvGrpSpPr/>
+        <p:nvPr/>
+      </p:nvGrpSpPr>
+      <p:grpSpPr>
+        <a:xfrm>
+          <a:off x="0" y="0"/>
+          <a:ext cx="0" cy="0"/>
+          <a:chOff x="0" y="0"/>
+          <a:chExt cx="0" cy="0"/>
+        </a:xfrm>
+      </p:grpSpPr>
+      <p:sp>
+        <p:nvSpPr>
+          <p:cNvPr id="2" name="Slide Image Placeholder 1"/>
+          <p:cNvSpPr>
+            <a:spLocks noGrp="1"/>
+          </p:cNvSpPr>
+          <p:nvPr>
+            <p:ph type="sldImg" idx="2"/>
+          </p:nvPr>
+        </p:nvSpPr>
+        <p:spPr/>
+      </p:sp>
+      <p:sp>
+        <p:nvSpPr>
+          <p:cNvPr id="3" name="Notes Placeholder 2"/>
+          <p:cNvSpPr>
+            <a:spLocks noGrp="1"/>
+          </p:cNvSpPr>
+          <p:nvPr>
+            <p:ph type="body" idx="3" sz="quarter"/>
+          </p:nvPr>
+        </p:nvSpPr>
+        <p:spPr/>
+        <p:txBody>
+          <a:bodyPr/>
+          <a:lstStyle/>
+          <a:p>
+            <a:r>
+              <a:t>The key thing to understand is that this isn't really 59 separate problems — it's one. The company grew by acquisition but never integrated those businesses, so today 59 sites run as independent organisations, each with their own processes, suppliers and back-end systems. Two central teams are accountable across all of them. And the scale matters: at roughly 1.8 million transactions a day, even a tiny inefficiency per transaction becomes enormous. Everything that follows comes from the manager's own internal analysis.</a:t>
+            </a:r>
+          </a:p>
+        </p:txBody>
+      </p:sp>
+      <p:sp>
+        <p:nvSpPr>
+          <p:cNvPr id="4" name="Slide Number Placeholder 3"/>
+          <p:cNvSpPr>
+            <a:spLocks noGrp="1"/>
+          </p:cNvSpPr>
+          <p:nvPr>
+            <p:ph type="sldNum" idx="5" sz="quarter"/>
+          </p:nvPr>
+        </p:nvSpPr>
+        <p:spPr/>
+      </p:sp>
+    </p:spTree>
+  </p:cSld>
+  <p:clrMapOvr>
+    <a:masterClrMapping/>
+  </p:clrMapOvr>
+</p:notes>
+</file>
+
+<file path=ppt/notesSlides/notesSlide3.xml><?xml version="1.0" encoding="utf-8"?>
+<p:notes xmlns:a="http://schemas.openxmlformats.org/drawingml/2006/main" xmlns:p="http://schemas.openxmlformats.org/presentationml/2006/main" xmlns:r="http://schemas.openxmlformats.org/officeDocument/2006/relationships">
+  <p:cSld>
+    <p:spTree>
+      <p:nvGrpSpPr>
+        <p:cNvPr id="1" name=""/>
+        <p:cNvGrpSpPr/>
+        <p:nvPr/>
+      </p:nvGrpSpPr>
+      <p:grpSpPr>
+        <a:xfrm>
+          <a:off x="0" y="0"/>
+          <a:ext cx="0" cy="0"/>
+          <a:chOff x="0" y="0"/>
+          <a:chExt cx="0" cy="0"/>
+        </a:xfrm>
+      </p:grpSpPr>
+      <p:sp>
+        <p:nvSpPr>
+          <p:cNvPr id="2" name="Slide Image Placeholder 1"/>
+          <p:cNvSpPr>
+            <a:spLocks noGrp="1"/>
+          </p:cNvSpPr>
+          <p:nvPr>
+            <p:ph type="sldImg" idx="2"/>
+          </p:nvPr>
+        </p:nvSpPr>
+        <p:spPr/>
+      </p:sp>
+      <p:sp>
+        <p:nvSpPr>
+          <p:cNvPr id="3" name="Notes Placeholder 2"/>
+          <p:cNvSpPr>
+            <a:spLocks noGrp="1"/>
+          </p:cNvSpPr>
+          <p:nvPr>
+            <p:ph type="body" idx="3" sz="quarter"/>
+          </p:nvPr>
+        </p:nvSpPr>
+        <p:spPr/>
+        <p:txBody>
+          <a:bodyPr/>
+          <a:lstStyle/>
+          <a:p>
+            <a:r>
+              <a:t>We've separated the findings into root causes — the drivers — and symptoms, because you fix the drivers, not the symptoms. There are four root causes. R1, and the most important, is that there's no executive mandate: the central teams are accountable but can't actually enforce compliance across 59 autonomous units. R2 is the fragmented operating model from M&amp;A. R3 is that there's no standard process — staff are upskilled to invoice in lots of different ways. And R4 is the systems: three ERPs, Oracle, SAP and PeopleSoft, poorly integrated, forcing a lot of manual work.</a:t>
+            </a:r>
+          </a:p>
+        </p:txBody>
+      </p:sp>
+      <p:sp>
+        <p:nvSpPr>
+          <p:cNvPr id="4" name="Slide Number Placeholder 3"/>
+          <p:cNvSpPr>
+            <a:spLocks noGrp="1"/>
+          </p:cNvSpPr>
+          <p:nvPr>
+            <p:ph type="sldNum" idx="5" sz="quarter"/>
+          </p:nvPr>
+        </p:nvSpPr>
+        <p:spPr/>
+      </p:sp>
+    </p:spTree>
+  </p:cSld>
+  <p:clrMapOvr>
+    <a:masterClrMapping/>
+  </p:clrMapOvr>
+</p:notes>
+</file>
+
+<file path=ppt/notesSlides/notesSlide4.xml><?xml version="1.0" encoding="utf-8"?>
+<p:notes xmlns:a="http://schemas.openxmlformats.org/drawingml/2006/main" xmlns:p="http://schemas.openxmlformats.org/presentationml/2006/main" xmlns:r="http://schemas.openxmlformats.org/officeDocument/2006/relationships">
+  <p:cSld>
+    <p:spTree>
+      <p:nvGrpSpPr>
+        <p:cNvPr id="1" name=""/>
+        <p:cNvGrpSpPr/>
+        <p:nvPr/>
+      </p:nvGrpSpPr>
+      <p:grpSpPr>
+        <a:xfrm>
+          <a:off x="0" y="0"/>
+          <a:ext cx="0" cy="0"/>
+          <a:chOff x="0" y="0"/>
+          <a:chExt cx="0" cy="0"/>
+        </a:xfrm>
+      </p:grpSpPr>
+      <p:sp>
+        <p:nvSpPr>
+          <p:cNvPr id="2" name="Slide Image Placeholder 1"/>
+          <p:cNvSpPr>
+            <a:spLocks noGrp="1"/>
+          </p:cNvSpPr>
+          <p:nvPr>
+            <p:ph type="sldImg" idx="2"/>
+          </p:nvPr>
+        </p:nvSpPr>
+        <p:spPr/>
+      </p:sp>
+      <p:sp>
+        <p:nvSpPr>
+          <p:cNvPr id="3" name="Notes Placeholder 2"/>
+          <p:cNvSpPr>
+            <a:spLocks noGrp="1"/>
+          </p:cNvSpPr>
+          <p:nvPr>
+            <p:ph type="body" idx="3" sz="quarter"/>
+          </p:nvPr>
+        </p:nvSpPr>
+        <p:spPr/>
+        <p:txBody>
+          <a:bodyPr/>
+          <a:lstStyle/>
+          <a:p>
+            <a:r>
+              <a:t>Those root causes produce five symptoms. Protracted payables — slow invoice processing. Lost economies of scale. Catalogue proliferation and tail spend, where a single low-value item needs multiple orders to different suppliers. The resourcing imbalance between the two teams — Team 1 is understaffed with two vacancies and part-timers while Team 2 is much stronger. And low morale, because procurement is seen as low-value back-office work. I'd flag that the cost of late payments and the morale-driven attrition are assumptions at this stage — sensible, but not yet quantified.</a:t>
+            </a:r>
+          </a:p>
+        </p:txBody>
+      </p:sp>
+      <p:sp>
+        <p:nvSpPr>
+          <p:cNvPr id="4" name="Slide Number Placeholder 3"/>
+          <p:cNvSpPr>
+            <a:spLocks noGrp="1"/>
+          </p:cNvSpPr>
+          <p:nvPr>
+            <p:ph type="sldNum" idx="5" sz="quarter"/>
+          </p:nvPr>
+        </p:nvSpPr>
+        <p:spPr/>
+      </p:sp>
+    </p:spTree>
+  </p:cSld>
+  <p:clrMapOvr>
+    <a:masterClrMapping/>
+  </p:clrMapOvr>
+</p:notes>
+</file>
+
+<file path=ppt/notesSlides/notesSlide5.xml><?xml version="1.0" encoding="utf-8"?>
+<p:notes xmlns:a="http://schemas.openxmlformats.org/drawingml/2006/main" xmlns:p="http://schemas.openxmlformats.org/presentationml/2006/main" xmlns:r="http://schemas.openxmlformats.org/officeDocument/2006/relationships">
+  <p:cSld>
+    <p:spTree>
+      <p:nvGrpSpPr>
+        <p:cNvPr id="1" name=""/>
+        <p:cNvGrpSpPr/>
+        <p:nvPr/>
+      </p:nvGrpSpPr>
+      <p:grpSpPr>
+        <a:xfrm>
+          <a:off x="0" y="0"/>
+          <a:ext cx="0" cy="0"/>
+          <a:chOff x="0" y="0"/>
+          <a:chExt cx="0" cy="0"/>
+        </a:xfrm>
+      </p:grpSpPr>
+      <p:sp>
+        <p:nvSpPr>
+          <p:cNvPr id="2" name="Slide Image Placeholder 1"/>
+          <p:cNvSpPr>
+            <a:spLocks noGrp="1"/>
+          </p:cNvSpPr>
+          <p:nvPr>
+            <p:ph type="sldImg" idx="2"/>
+          </p:nvPr>
+        </p:nvSpPr>
+        <p:spPr/>
+      </p:sp>
+      <p:sp>
+        <p:nvSpPr>
+          <p:cNvPr id="3" name="Notes Placeholder 2"/>
+          <p:cNvSpPr>
+            <a:spLocks noGrp="1"/>
+          </p:cNvSpPr>
+          <p:nvPr>
+            <p:ph type="body" idx="3" sz="quarter"/>
+          </p:nvPr>
+        </p:nvSpPr>
+        <p:spPr/>
+        <p:txBody>
+          <a:bodyPr/>
+          <a:lstStyle/>
+          <a:p>
+            <a:r>
+              <a:t>This is the strongest piece of evidence. Between 2023 and 2024 the supplier count went up 18%, from 224 to 264, and spend rose 16% to just over a billion. But average spend per supplier actually fell. So as the business grows it's adding suppliers faster than it's consolidating them — it's fragmenting, not concentrating. That's direct evidence for the lost economies of scale and the un-integrated operating model. The assumption is that these are group-wide numbers; a per-unit split would let us size the opportunity precisely.</a:t>
+            </a:r>
+          </a:p>
+        </p:txBody>
+      </p:sp>
+      <p:sp>
+        <p:nvSpPr>
+          <p:cNvPr id="4" name="Slide Number Placeholder 3"/>
+          <p:cNvSpPr>
+            <a:spLocks noGrp="1"/>
+          </p:cNvSpPr>
+          <p:nvPr>
+            <p:ph type="sldNum" idx="5" sz="quarter"/>
+          </p:nvPr>
+        </p:nvSpPr>
+        <p:spPr/>
+      </p:sp>
+    </p:spTree>
+  </p:cSld>
+  <p:clrMapOvr>
+    <a:masterClrMapping/>
+  </p:clrMapOvr>
+</p:notes>
+</file>
+
+<file path=ppt/notesSlides/notesSlide6.xml><?xml version="1.0" encoding="utf-8"?>
+<p:notes xmlns:a="http://schemas.openxmlformats.org/drawingml/2006/main" xmlns:p="http://schemas.openxmlformats.org/presentationml/2006/main" xmlns:r="http://schemas.openxmlformats.org/officeDocument/2006/relationships">
+  <p:cSld>
+    <p:spTree>
+      <p:nvGrpSpPr>
+        <p:cNvPr id="1" name=""/>
+        <p:cNvGrpSpPr/>
+        <p:nvPr/>
+      </p:nvGrpSpPr>
+      <p:grpSpPr>
+        <a:xfrm>
+          <a:off x="0" y="0"/>
+          <a:ext cx="0" cy="0"/>
+          <a:chOff x="0" y="0"/>
+          <a:chExt cx="0" cy="0"/>
+        </a:xfrm>
+      </p:grpSpPr>
+      <p:sp>
+        <p:nvSpPr>
+          <p:cNvPr id="2" name="Slide Image Placeholder 1"/>
+          <p:cNvSpPr>
+            <a:spLocks noGrp="1"/>
+          </p:cNvSpPr>
+          <p:nvPr>
+            <p:ph type="sldImg" idx="2"/>
+          </p:nvPr>
+        </p:nvSpPr>
+        <p:spPr/>
+      </p:sp>
+      <p:sp>
+        <p:nvSpPr>
+          <p:cNvPr id="3" name="Notes Placeholder 2"/>
+          <p:cNvSpPr>
+            <a:spLocks noGrp="1"/>
+          </p:cNvSpPr>
+          <p:nvPr>
+            <p:ph type="body" idx="3" sz="quarter"/>
+          </p:nvPr>
+        </p:nvSpPr>
+        <p:spPr/>
+        <p:txBody>
+          <a:bodyPr/>
+          <a:lstStyle/>
+          <a:p>
+            <a:r>
+              <a:t>If I had to pick the single most important issue, it's R1 — the lack of an executive mandate. It's not the most expensive problem to fix, but it's the dependency that unblocks everything else. You simply can't standardise processes, consolidate systems or rationalise suppliers across 59 autonomous units unless leadership mandates it. And the business impact of not fixing it is exactly what that supplier chart shows — continued fragmentation. Low cost, high leverage, so we fix it first.</a:t>
+            </a:r>
+          </a:p>
+        </p:txBody>
+      </p:sp>
+      <p:sp>
+        <p:nvSpPr>
+          <p:cNvPr id="4" name="Slide Number Placeholder 3"/>
+          <p:cNvSpPr>
+            <a:spLocks noGrp="1"/>
+          </p:cNvSpPr>
+          <p:nvPr>
+            <p:ph type="sldNum" idx="5" sz="quarter"/>
+          </p:nvPr>
+        </p:nvSpPr>
+        <p:spPr/>
+      </p:sp>
+    </p:spTree>
+  </p:cSld>
+  <p:clrMapOvr>
+    <a:masterClrMapping/>
+  </p:clrMapOvr>
+</p:notes>
+</file>
+
+<file path=ppt/notesSlides/notesSlide7.xml><?xml version="1.0" encoding="utf-8"?>
+<p:notes xmlns:a="http://schemas.openxmlformats.org/drawingml/2006/main" xmlns:p="http://schemas.openxmlformats.org/presentationml/2006/main" xmlns:r="http://schemas.openxmlformats.org/officeDocument/2006/relationships">
+  <p:cSld>
+    <p:spTree>
+      <p:nvGrpSpPr>
+        <p:cNvPr id="1" name=""/>
+        <p:cNvGrpSpPr/>
+        <p:nvPr/>
+      </p:nvGrpSpPr>
+      <p:grpSpPr>
+        <a:xfrm>
+          <a:off x="0" y="0"/>
+          <a:ext cx="0" cy="0"/>
+          <a:chOff x="0" y="0"/>
+          <a:chExt cx="0" cy="0"/>
+        </a:xfrm>
+      </p:grpSpPr>
+      <p:sp>
+        <p:nvSpPr>
+          <p:cNvPr id="2" name="Slide Image Placeholder 1"/>
+          <p:cNvSpPr>
+            <a:spLocks noGrp="1"/>
+          </p:cNvSpPr>
+          <p:nvPr>
+            <p:ph type="sldImg" idx="2"/>
+          </p:nvPr>
+        </p:nvSpPr>
+        <p:spPr/>
+      </p:sp>
+      <p:sp>
+        <p:nvSpPr>
+          <p:cNvPr id="3" name="Notes Placeholder 2"/>
+          <p:cNvSpPr>
+            <a:spLocks noGrp="1"/>
+          </p:cNvSpPr>
+          <p:nvPr>
+            <p:ph type="body" idx="3" sz="quarter"/>
+          </p:nvPr>
+        </p:nvSpPr>
+        <p:spPr/>
+        <p:txBody>
+          <a:bodyPr/>
+          <a:lstStyle/>
+          <a:p>
+            <a:r>
+              <a:t>So onto what we'd prioritise. Deliberately, this is three high-impact moves rather than a big multi-year transformation. One: secure executive sponsorship and a compliance mandate — fast, cheap, unlocks everything. Two: standardise the procure-to-pay process and rationalise the catalogue and tail spend — this is the biggest near-term efficiency win at 1.8 million transactions a day, and crucially it doesn't require replacing any systems. Three: rebalance the two teams — fill Team 1's vacancies or shift workload — a quick operational win that also helps morale. Our assumption is these three deliver most of the benefit.</a:t>
+            </a:r>
+          </a:p>
+        </p:txBody>
+      </p:sp>
+      <p:sp>
+        <p:nvSpPr>
+          <p:cNvPr id="4" name="Slide Number Placeholder 3"/>
+          <p:cNvSpPr>
+            <a:spLocks noGrp="1"/>
+          </p:cNvSpPr>
+          <p:nvPr>
+            <p:ph type="sldNum" idx="5" sz="quarter"/>
+          </p:nvPr>
+        </p:nvSpPr>
+        <p:spPr/>
+      </p:sp>
+    </p:spTree>
+  </p:cSld>
+  <p:clrMapOvr>
+    <a:masterClrMapping/>
+  </p:clrMapOvr>
+</p:notes>
+</file>
+
+<file path=ppt/notesSlides/notesSlide8.xml><?xml version="1.0" encoding="utf-8"?>
+<p:notes xmlns:a="http://schemas.openxmlformats.org/drawingml/2006/main" xmlns:p="http://schemas.openxmlformats.org/presentationml/2006/main" xmlns:r="http://schemas.openxmlformats.org/officeDocument/2006/relationships">
+  <p:cSld>
+    <p:spTree>
+      <p:nvGrpSpPr>
+        <p:cNvPr id="1" name=""/>
+        <p:cNvGrpSpPr/>
+        <p:nvPr/>
+      </p:nvGrpSpPr>
+      <p:grpSpPr>
+        <a:xfrm>
+          <a:off x="0" y="0"/>
+          <a:ext cx="0" cy="0"/>
+          <a:chOff x="0" y="0"/>
+          <a:chExt cx="0" cy="0"/>
+        </a:xfrm>
+      </p:grpSpPr>
+      <p:sp>
+        <p:nvSpPr>
+          <p:cNvPr id="2" name="Slide Image Placeholder 1"/>
+          <p:cNvSpPr>
+            <a:spLocks noGrp="1"/>
+          </p:cNvSpPr>
+          <p:nvPr>
+            <p:ph type="sldImg" idx="2"/>
+          </p:nvPr>
+        </p:nvSpPr>
+        <p:spPr/>
+      </p:sp>
+      <p:sp>
+        <p:nvSpPr>
+          <p:cNvPr id="3" name="Notes Placeholder 2"/>
+          <p:cNvSpPr>
+            <a:spLocks noGrp="1"/>
+          </p:cNvSpPr>
+          <p:nvPr>
+            <p:ph type="body" idx="3" sz="quarter"/>
+          </p:nvPr>
+        </p:nvSpPr>
+        <p:spPr/>
+        <p:txBody>
+          <a:bodyPr/>
+          <a:lstStyle/>
+          <a:p>
+            <a:r>
+              <a:t>The bigger structural items we'd treat as longer-term and only do if the data justifies them: consolidating the ERPs, rationalising the supplier base, and moving toward a shared-services model. I want to be clear — we are not assuming a full ERP consolidation is the right answer yet. That's a significant business case and it should be decided on spend, cost-to-serve and contractual lock-in data, not assumed up front.</a:t>
+            </a:r>
+          </a:p>
+        </p:txBody>
+      </p:sp>
+      <p:sp>
+        <p:nvSpPr>
+          <p:cNvPr id="4" name="Slide Number Placeholder 3"/>
+          <p:cNvSpPr>
+            <a:spLocks noGrp="1"/>
+          </p:cNvSpPr>
+          <p:nvPr>
+            <p:ph type="sldNum" idx="5" sz="quarter"/>
+          </p:nvPr>
+        </p:nvSpPr>
+        <p:spPr/>
+      </p:sp>
+    </p:spTree>
+  </p:cSld>
+  <p:clrMapOvr>
+    <a:masterClrMapping/>
+  </p:clrMapOvr>
+</p:notes>
+</file>
+
+<file path=ppt/notesSlides/notesSlide9.xml><?xml version="1.0" encoding="utf-8"?>
+<p:notes xmlns:a="http://schemas.openxmlformats.org/drawingml/2006/main" xmlns:p="http://schemas.openxmlformats.org/presentationml/2006/main" xmlns:r="http://schemas.openxmlformats.org/officeDocument/2006/relationships">
+  <p:cSld>
+    <p:spTree>
+      <p:nvGrpSpPr>
+        <p:cNvPr id="1" name=""/>
+        <p:cNvGrpSpPr/>
+        <p:nvPr/>
+      </p:nvGrpSpPr>
+      <p:grpSpPr>
+        <a:xfrm>
+          <a:off x="0" y="0"/>
+          <a:ext cx="0" cy="0"/>
+          <a:chOff x="0" y="0"/>
+          <a:chExt cx="0" cy="0"/>
+        </a:xfrm>
+      </p:grpSpPr>
+      <p:sp>
+        <p:nvSpPr>
+          <p:cNvPr id="2" name="Slide Image Placeholder 1"/>
+          <p:cNvSpPr>
+            <a:spLocks noGrp="1"/>
+          </p:cNvSpPr>
+          <p:nvPr>
+            <p:ph type="sldImg" idx="2"/>
+          </p:nvPr>
+        </p:nvSpPr>
+        <p:spPr/>
+      </p:sp>
+      <p:sp>
+        <p:nvSpPr>
+          <p:cNvPr id="3" name="Notes Placeholder 2"/>
+          <p:cNvSpPr>
+            <a:spLocks noGrp="1"/>
+          </p:cNvSpPr>
+          <p:nvPr>
+            <p:ph type="body" idx="3" sz="quarter"/>
+          </p:nvPr>
+        </p:nvSpPr>
+        <p:spPr/>
+        <p:txBody>
+          <a:bodyPr/>
+          <a:lstStyle/>
+          <a:p>
+            <a:r>
+              <a:t>Why are these a priority organisationally? It helps to look across four lenses. People: the teams are imbalanced, morale is low, and procurement is seen as low value — so capacity and appetite for change are limited. Process: no standard process, manual work, catalogue sprawl — and that scales to 1.8 million transactions. Governance: no executive mandate, which is the thing that elevates all of this to a priority. And systems: three poorly integrated ERPs with no consolidated spend data. It's embedded across all four, which is exactly why it needs addressing now.</a:t>
+            </a:r>
+          </a:p>
+        </p:txBody>
+      </p:sp>
+      <p:sp>
+        <p:nvSpPr>
+          <p:cNvPr id="4" name="Slide Number Placeholder 3"/>
+          <p:cNvSpPr>
+            <a:spLocks noGrp="1"/>
+          </p:cNvSpPr>
+          <p:nvPr>
+            <p:ph type="sldNum" idx="5" sz="quarter"/>
+          </p:nvPr>
+        </p:nvSpPr>
+        <p:spPr/>
+      </p:sp>
+    </p:spTree>
+  </p:cSld>
+  <p:clrMapOvr>
+    <a:masterClrMapping/>
+  </p:clrMapOvr>
+</p:notes>
 </file>
 
 <file path=ppt/slideLayouts/slideLayout1.xml><?xml version="1.0" encoding="utf-8"?>
@@ -5402,4 +6592,324 @@
   </a:objectDefaults>
   <a:extraClrSchemeLst/>
 </a:theme>
+</file>
+
+<file path=ppt/theme/theme2.xml><?xml version="1.0" encoding="utf-8"?>
+<a:theme xmlns:a="http://schemas.openxmlformats.org/drawingml/2006/main" name="Office Theme">
+  <a:themeElements>
+    <a:clrScheme name="Office">
+      <a:dk1>
+        <a:sysClr val="windowText" lastClr="000000"/>
+      </a:dk1>
+      <a:lt1>
+        <a:sysClr val="window" lastClr="FFFFFF"/>
+      </a:lt1>
+      <a:dk2>
+        <a:srgbClr val="1F497D"/>
+      </a:dk2>
+      <a:lt2>
+        <a:srgbClr val="EEECE1"/>
+      </a:lt2>
+      <a:accent1>
+        <a:srgbClr val="4F81BD"/>
+      </a:accent1>
+      <a:accent2>
+        <a:srgbClr val="C0504D"/>
+      </a:accent2>
+      <a:accent3>
+        <a:srgbClr val="9BBB59"/>
+      </a:accent3>
+      <a:accent4>
+        <a:srgbClr val="8064A2"/>
+      </a:accent4>
+      <a:accent5>
+        <a:srgbClr val="4BACC6"/>
+      </a:accent5>
+      <a:accent6>
+        <a:srgbClr val="F79646"/>
+      </a:accent6>
+      <a:hlink>
+        <a:srgbClr val="0000FF"/>
+      </a:hlink>
+      <a:folHlink>
+        <a:srgbClr val="800080"/>
+      </a:folHlink>
+    </a:clrScheme>
+    <a:fontScheme name="Office">
+      <a:majorFont>
+        <a:latin typeface="Calibri"/>
+        <a:ea typeface=""/>
+        <a:cs typeface=""/>
+        <a:font script="Jpan" typeface="ＭＳ Ｐゴシック"/>
+        <a:font script="Hang" typeface="맑은 고딕"/>
+        <a:font script="Hans" typeface="宋体"/>
+        <a:font script="Hant" typeface="新細明體"/>
+        <a:font script="Arab" typeface="Times New Roman"/>
+        <a:font script="Hebr" typeface="Times New Roman"/>
+        <a:font script="Thai" typeface="Angsana New"/>
+        <a:font script="Ethi" typeface="Nyala"/>
+        <a:font script="Beng" typeface="Vrinda"/>
+        <a:font script="Gujr" typeface="Shruti"/>
+        <a:font script="Khmr" typeface="MoolBoran"/>
+        <a:font script="Knda" typeface="Tunga"/>
+        <a:font script="Guru" typeface="Raavi"/>
+        <a:font script="Cans" typeface="Euphemia"/>
+        <a:font script="Cher" typeface="Plantagenet Cherokee"/>
+        <a:font script="Yiii" typeface="Microsoft Yi Baiti"/>
+        <a:font script="Tibt" typeface="Microsoft Himalaya"/>
+        <a:font script="Thaa" typeface="MV Boli"/>
+        <a:font script="Deva" typeface="Mangal"/>
+        <a:font script="Telu" typeface="Gautami"/>
+        <a:font script="Taml" typeface="Latha"/>
+        <a:font script="Syrc" typeface="Estrangelo Edessa"/>
+        <a:font script="Orya" typeface="Kalinga"/>
+        <a:font script="Mlym" typeface="Kartika"/>
+        <a:font script="Laoo" typeface="DokChampa"/>
+        <a:font script="Sinh" typeface="Iskoola Pota"/>
+        <a:font script="Mong" typeface="Mongolian Baiti"/>
+        <a:font script="Viet" typeface="Times New Roman"/>
+        <a:font script="Uigh" typeface="Microsoft Uighur"/>
+        <a:font script="Geor" typeface="Sylfaen"/>
+      </a:majorFont>
+      <a:minorFont>
+        <a:latin typeface="Calibri"/>
+        <a:ea typeface=""/>
+        <a:cs typeface=""/>
+        <a:font script="Jpan" typeface="ＭＳ Ｐゴシック"/>
+        <a:font script="Hang" typeface="맑은 고딕"/>
+        <a:font script="Hans" typeface="宋体"/>
+        <a:font script="Hant" typeface="新細明體"/>
+        <a:font script="Arab" typeface="Arial"/>
+        <a:font script="Hebr" typeface="Arial"/>
+        <a:font script="Thai" typeface="Cordia New"/>
+        <a:font script="Ethi" typeface="Nyala"/>
+        <a:font script="Beng" typeface="Vrinda"/>
+        <a:font script="Gujr" typeface="Shruti"/>
+        <a:font script="Khmr" typeface="DaunPenh"/>
+        <a:font script="Knda" typeface="Tunga"/>
+        <a:font script="Guru" typeface="Raavi"/>
+        <a:font script="Cans" typeface="Euphemia"/>
+        <a:font script="Cher" typeface="Plantagenet Cherokee"/>
+        <a:font script="Yiii" typeface="Microsoft Yi Baiti"/>
+        <a:font script="Tibt" typeface="Microsoft Himalaya"/>
+        <a:font script="Thaa" typeface="MV Boli"/>
+        <a:font script="Deva" typeface="Mangal"/>
+        <a:font script="Telu" typeface="Gautami"/>
+        <a:font script="Taml" typeface="Latha"/>
+        <a:font script="Syrc" typeface="Estrangelo Edessa"/>
+        <a:font script="Orya" typeface="Kalinga"/>
+        <a:font script="Mlym" typeface="Kartika"/>
+        <a:font script="Laoo" typeface="DokChampa"/>
+        <a:font script="Sinh" typeface="Iskoola Pota"/>
+        <a:font script="Mong" typeface="Mongolian Baiti"/>
+        <a:font script="Viet" typeface="Arial"/>
+        <a:font script="Uigh" typeface="Microsoft Uighur"/>
+        <a:font script="Geor" typeface="Sylfaen"/>
+      </a:minorFont>
+    </a:fontScheme>
+    <a:fmtScheme name="Office">
+      <a:fillStyleLst>
+        <a:solidFill>
+          <a:schemeClr val="phClr"/>
+        </a:solidFill>
+        <a:gradFill rotWithShape="1">
+          <a:gsLst>
+            <a:gs pos="0">
+              <a:schemeClr val="phClr">
+                <a:tint val="50000"/>
+                <a:satMod val="300000"/>
+              </a:schemeClr>
+            </a:gs>
+            <a:gs pos="35000">
+              <a:schemeClr val="phClr">
+                <a:tint val="37000"/>
+                <a:satMod val="300000"/>
+              </a:schemeClr>
+            </a:gs>
+            <a:gs pos="100000">
+              <a:schemeClr val="phClr">
+                <a:tint val="15000"/>
+                <a:satMod val="350000"/>
+              </a:schemeClr>
+            </a:gs>
+          </a:gsLst>
+          <a:lin ang="16200000" scaled="1"/>
+        </a:gradFill>
+        <a:gradFill rotWithShape="1">
+          <a:gsLst>
+            <a:gs pos="0">
+              <a:schemeClr val="phClr">
+                <a:tint val="100000"/>
+                <a:shade val="100000"/>
+                <a:satMod val="130000"/>
+              </a:schemeClr>
+            </a:gs>
+            <a:gs pos="100000">
+              <a:schemeClr val="phClr">
+                <a:tint val="50000"/>
+                <a:shade val="100000"/>
+                <a:satMod val="350000"/>
+              </a:schemeClr>
+            </a:gs>
+          </a:gsLst>
+          <a:lin ang="16200000" scaled="0"/>
+        </a:gradFill>
+      </a:fillStyleLst>
+      <a:lnStyleLst>
+        <a:ln w="9525" cap="flat" cmpd="sng" algn="ctr">
+          <a:solidFill>
+            <a:schemeClr val="phClr">
+              <a:shade val="95000"/>
+              <a:satMod val="105000"/>
+            </a:schemeClr>
+          </a:solidFill>
+          <a:prstDash val="solid"/>
+        </a:ln>
+        <a:ln w="25400" cap="flat" cmpd="sng" algn="ctr">
+          <a:solidFill>
+            <a:schemeClr val="phClr"/>
+          </a:solidFill>
+          <a:prstDash val="solid"/>
+        </a:ln>
+        <a:ln w="38100" cap="flat" cmpd="sng" algn="ctr">
+          <a:solidFill>
+            <a:schemeClr val="phClr"/>
+          </a:solidFill>
+          <a:prstDash val="solid"/>
+        </a:ln>
+      </a:lnStyleLst>
+      <a:effectStyleLst>
+        <a:effectStyle>
+          <a:effectLst>
+            <a:outerShdw blurRad="40000" dist="20000" dir="5400000" rotWithShape="0">
+              <a:srgbClr val="000000">
+                <a:alpha val="38000"/>
+              </a:srgbClr>
+            </a:outerShdw>
+          </a:effectLst>
+        </a:effectStyle>
+        <a:effectStyle>
+          <a:effectLst>
+            <a:outerShdw blurRad="40000" dist="23000" dir="5400000" rotWithShape="0">
+              <a:srgbClr val="000000">
+                <a:alpha val="35000"/>
+              </a:srgbClr>
+            </a:outerShdw>
+          </a:effectLst>
+        </a:effectStyle>
+        <a:effectStyle>
+          <a:effectLst>
+            <a:outerShdw blurRad="40000" dist="23000" dir="5400000" rotWithShape="0">
+              <a:srgbClr val="000000">
+                <a:alpha val="35000"/>
+              </a:srgbClr>
+            </a:outerShdw>
+          </a:effectLst>
+          <a:scene3d>
+            <a:camera prst="orthographicFront">
+              <a:rot lat="0" lon="0" rev="0"/>
+            </a:camera>
+            <a:lightRig rig="threePt" dir="t">
+              <a:rot lat="0" lon="0" rev="1200000"/>
+            </a:lightRig>
+          </a:scene3d>
+          <a:sp3d>
+            <a:bevelT w="63500" h="25400"/>
+          </a:sp3d>
+        </a:effectStyle>
+      </a:effectStyleLst>
+      <a:bgFillStyleLst>
+        <a:solidFill>
+          <a:schemeClr val="phClr"/>
+        </a:solidFill>
+        <a:gradFill rotWithShape="1">
+          <a:gsLst>
+            <a:gs pos="0">
+              <a:schemeClr val="phClr">
+                <a:tint val="40000"/>
+                <a:satMod val="350000"/>
+              </a:schemeClr>
+            </a:gs>
+            <a:gs pos="40000">
+              <a:schemeClr val="phClr">
+                <a:tint val="45000"/>
+                <a:shade val="99000"/>
+                <a:satMod val="350000"/>
+              </a:schemeClr>
+            </a:gs>
+            <a:gs pos="100000">
+              <a:schemeClr val="phClr">
+                <a:shade val="20000"/>
+                <a:satMod val="255000"/>
+              </a:schemeClr>
+            </a:gs>
+          </a:gsLst>
+          <a:path path="circle">
+            <a:fillToRect l="50000" t="-80000" r="50000" b="180000"/>
+          </a:path>
+        </a:gradFill>
+        <a:gradFill rotWithShape="1">
+          <a:gsLst>
+            <a:gs pos="0">
+              <a:schemeClr val="phClr">
+                <a:tint val="80000"/>
+                <a:satMod val="300000"/>
+              </a:schemeClr>
+            </a:gs>
+            <a:gs pos="100000">
+              <a:schemeClr val="phClr">
+                <a:shade val="30000"/>
+                <a:satMod val="200000"/>
+              </a:schemeClr>
+            </a:gs>
+          </a:gsLst>
+          <a:path path="circle">
+            <a:fillToRect l="50000" t="50000" r="50000" b="50000"/>
+          </a:path>
+        </a:gradFill>
+      </a:bgFillStyleLst>
+    </a:fmtScheme>
+  </a:themeElements>
+  <a:objectDefaults>
+    <a:spDef>
+      <a:spPr/>
+      <a:bodyPr/>
+      <a:lstStyle/>
+      <a:style>
+        <a:lnRef idx="1">
+          <a:schemeClr val="accent1"/>
+        </a:lnRef>
+        <a:fillRef idx="3">
+          <a:schemeClr val="accent1"/>
+        </a:fillRef>
+        <a:effectRef idx="2">
+          <a:schemeClr val="accent1"/>
+        </a:effectRef>
+        <a:fontRef idx="minor">
+          <a:schemeClr val="lt1"/>
+        </a:fontRef>
+      </a:style>
+    </a:spDef>
+    <a:lnDef>
+      <a:spPr/>
+      <a:bodyPr/>
+      <a:lstStyle/>
+      <a:style>
+        <a:lnRef idx="2">
+          <a:schemeClr val="accent1"/>
+        </a:lnRef>
+        <a:fillRef idx="0">
+          <a:schemeClr val="accent1"/>
+        </a:fillRef>
+        <a:effectRef idx="1">
+          <a:schemeClr val="accent1"/>
+        </a:effectRef>
+        <a:fontRef idx="minor">
+          <a:schemeClr val="tx1"/>
+        </a:fontRef>
+      </a:style>
+    </a:lnDef>
+  </a:objectDefaults>
+  <a:extraClrSchemeLst/>
+</a:theme>
 </file>
</xml_diff>

<commit_message>
Remove speaker notes and em dashes, rewrite wording to read naturally
Strip all slide notes, eliminate em dashes throughout, and rephrase the content in plain first-person language.

https://claude.ai/code/session_014EpSpf3QcBHWNPw4UskYmj
</commit_message>
<xml_diff>
--- a/NextTech_Procurement_Analysis.pptx
+++ b/NextTech_Procurement_Analysis.pptx
@@ -116,1196 +116,6 @@
     </a:lvl9pPr>
   </p:defaultTextStyle>
 </p:presentation>
-</file>
-
-<file path=ppt/notesMasters/notesMaster1.xml><?xml version="1.0" encoding="utf-8"?>
-<p:notesMaster xmlns:a="http://schemas.openxmlformats.org/drawingml/2006/main" xmlns:p="http://schemas.openxmlformats.org/presentationml/2006/main" xmlns:r="http://schemas.openxmlformats.org/officeDocument/2006/relationships">
-  <p:cSld>
-    <p:bg>
-      <p:bgRef idx="1001">
-        <a:schemeClr val="bg1"/>
-      </p:bgRef>
-    </p:bg>
-    <p:spTree>
-      <p:nvGrpSpPr>
-        <p:cNvPr id="1" name=""/>
-        <p:cNvGrpSpPr/>
-        <p:nvPr/>
-      </p:nvGrpSpPr>
-      <p:grpSpPr>
-        <a:xfrm>
-          <a:off x="0" y="0"/>
-          <a:ext cx="0" cy="0"/>
-          <a:chOff x="0" y="0"/>
-          <a:chExt cx="0" cy="0"/>
-        </a:xfrm>
-      </p:grpSpPr>
-      <p:sp>
-        <p:nvSpPr>
-          <p:cNvPr id="2" name="Header Placeholder 1"/>
-          <p:cNvSpPr>
-            <a:spLocks noGrp="1"/>
-          </p:cNvSpPr>
-          <p:nvPr>
-            <p:ph type="hdr" sz="quarter"/>
-          </p:nvPr>
-        </p:nvSpPr>
-        <p:spPr>
-          <a:xfrm>
-            <a:off x="0" y="0"/>
-            <a:ext cx="2971800" cy="457200"/>
-          </a:xfrm>
-          <a:prstGeom prst="rect">
-            <a:avLst/>
-          </a:prstGeom>
-        </p:spPr>
-        <p:txBody>
-          <a:bodyPr vert="horz" lIns="91440" tIns="45720" rIns="91440" bIns="45720" rtlCol="0"/>
-          <a:lstStyle>
-            <a:lvl1pPr algn="l">
-              <a:defRPr sz="1200"/>
-            </a:lvl1pPr>
-          </a:lstStyle>
-          <a:p>
-            <a:endParaRPr lang="en-US"/>
-          </a:p>
-        </p:txBody>
-      </p:sp>
-      <p:sp>
-        <p:nvSpPr>
-          <p:cNvPr id="3" name="Date Placeholder 2"/>
-          <p:cNvSpPr>
-            <a:spLocks noGrp="1"/>
-          </p:cNvSpPr>
-          <p:nvPr>
-            <p:ph type="dt" idx="1"/>
-          </p:nvPr>
-        </p:nvSpPr>
-        <p:spPr>
-          <a:xfrm>
-            <a:off x="3884613" y="0"/>
-            <a:ext cx="2971800" cy="457200"/>
-          </a:xfrm>
-          <a:prstGeom prst="rect">
-            <a:avLst/>
-          </a:prstGeom>
-        </p:spPr>
-        <p:txBody>
-          <a:bodyPr vert="horz" lIns="91440" tIns="45720" rIns="91440" bIns="45720" rtlCol="0"/>
-          <a:lstStyle>
-            <a:lvl1pPr algn="r">
-              <a:defRPr sz="1200"/>
-            </a:lvl1pPr>
-          </a:lstStyle>
-          <a:p>
-            <a:fld id="{0F89C1C7-3DCD-1040-A9CF-14679D8B5DDD}" type="datetimeFigureOut">
-              <a:rPr lang="en-US" smtClean="0"/>
-              <a:t>10/17/16</a:t>
-            </a:fld>
-            <a:endParaRPr lang="en-US"/>
-          </a:p>
-        </p:txBody>
-      </p:sp>
-      <p:sp>
-        <p:nvSpPr>
-          <p:cNvPr id="4" name="Slide Image Placeholder 3"/>
-          <p:cNvSpPr>
-            <a:spLocks noGrp="1" noRot="1" noChangeAspect="1"/>
-          </p:cNvSpPr>
-          <p:nvPr>
-            <p:ph type="sldImg" idx="2"/>
-          </p:nvPr>
-        </p:nvSpPr>
-        <p:spPr>
-          <a:xfrm>
-            <a:off x="1143000" y="685800"/>
-            <a:ext cx="4572000" cy="3429000"/>
-          </a:xfrm>
-          <a:prstGeom prst="rect">
-            <a:avLst/>
-          </a:prstGeom>
-          <a:noFill/>
-          <a:ln w="12700">
-            <a:solidFill>
-              <a:prstClr val="black"/>
-            </a:solidFill>
-          </a:ln>
-        </p:spPr>
-        <p:txBody>
-          <a:bodyPr vert="horz" lIns="91440" tIns="45720" rIns="91440" bIns="45720" rtlCol="0" anchor="ctr"/>
-          <a:lstStyle/>
-          <a:p>
-            <a:endParaRPr lang="en-US"/>
-          </a:p>
-        </p:txBody>
-      </p:sp>
-      <p:sp>
-        <p:nvSpPr>
-          <p:cNvPr id="5" name="Notes Placeholder 4"/>
-          <p:cNvSpPr>
-            <a:spLocks noGrp="1"/>
-          </p:cNvSpPr>
-          <p:nvPr>
-            <p:ph type="body" sz="quarter" idx="3"/>
-          </p:nvPr>
-        </p:nvSpPr>
-        <p:spPr>
-          <a:xfrm>
-            <a:off x="685800" y="4343400"/>
-            <a:ext cx="5486400" cy="4114800"/>
-          </a:xfrm>
-          <a:prstGeom prst="rect">
-            <a:avLst/>
-          </a:prstGeom>
-        </p:spPr>
-        <p:txBody>
-          <a:bodyPr vert="horz" lIns="91440" tIns="45720" rIns="91440" bIns="45720" rtlCol="0"/>
-          <a:lstStyle/>
-          <a:p>
-            <a:pPr lvl="0"/>
-            <a:r>
-              <a:rPr lang="en-US" smtClean="0"/>
-              <a:t>Click to edit Master text styles</a:t>
-            </a:r>
-          </a:p>
-          <a:p>
-            <a:pPr lvl="1"/>
-            <a:r>
-              <a:rPr lang="en-US" smtClean="0"/>
-              <a:t>Second level</a:t>
-            </a:r>
-          </a:p>
-          <a:p>
-            <a:pPr lvl="2"/>
-            <a:r>
-              <a:rPr lang="en-US" smtClean="0"/>
-              <a:t>Third level</a:t>
-            </a:r>
-          </a:p>
-          <a:p>
-            <a:pPr lvl="3"/>
-            <a:r>
-              <a:rPr lang="en-US" smtClean="0"/>
-              <a:t>Fourth level</a:t>
-            </a:r>
-          </a:p>
-          <a:p>
-            <a:pPr lvl="4"/>
-            <a:r>
-              <a:rPr lang="en-US" smtClean="0"/>
-              <a:t>Fifth level</a:t>
-            </a:r>
-            <a:endParaRPr lang="en-US"/>
-          </a:p>
-        </p:txBody>
-      </p:sp>
-      <p:sp>
-        <p:nvSpPr>
-          <p:cNvPr id="6" name="Footer Placeholder 5"/>
-          <p:cNvSpPr>
-            <a:spLocks noGrp="1"/>
-          </p:cNvSpPr>
-          <p:nvPr>
-            <p:ph type="ftr" sz="quarter" idx="4"/>
-          </p:nvPr>
-        </p:nvSpPr>
-        <p:spPr>
-          <a:xfrm>
-            <a:off x="0" y="8685213"/>
-            <a:ext cx="2971800" cy="457200"/>
-          </a:xfrm>
-          <a:prstGeom prst="rect">
-            <a:avLst/>
-          </a:prstGeom>
-        </p:spPr>
-        <p:txBody>
-          <a:bodyPr vert="horz" lIns="91440" tIns="45720" rIns="91440" bIns="45720" rtlCol="0" anchor="b"/>
-          <a:lstStyle>
-            <a:lvl1pPr algn="l">
-              <a:defRPr sz="1200"/>
-            </a:lvl1pPr>
-          </a:lstStyle>
-          <a:p>
-            <a:endParaRPr lang="en-US"/>
-          </a:p>
-        </p:txBody>
-      </p:sp>
-      <p:sp>
-        <p:nvSpPr>
-          <p:cNvPr id="7" name="Slide Number Placeholder 6"/>
-          <p:cNvSpPr>
-            <a:spLocks noGrp="1"/>
-          </p:cNvSpPr>
-          <p:nvPr>
-            <p:ph type="sldNum" sz="quarter" idx="5"/>
-          </p:nvPr>
-        </p:nvSpPr>
-        <p:spPr>
-          <a:xfrm>
-            <a:off x="3884613" y="8685213"/>
-            <a:ext cx="2971800" cy="457200"/>
-          </a:xfrm>
-          <a:prstGeom prst="rect">
-            <a:avLst/>
-          </a:prstGeom>
-        </p:spPr>
-        <p:txBody>
-          <a:bodyPr vert="horz" lIns="91440" tIns="45720" rIns="91440" bIns="45720" rtlCol="0" anchor="b"/>
-          <a:lstStyle>
-            <a:lvl1pPr algn="r">
-              <a:defRPr sz="1200"/>
-            </a:lvl1pPr>
-          </a:lstStyle>
-          <a:p>
-            <a:fld id="{BB5E49A5-4136-284D-997B-48E1D791AD67}" type="slidenum">
-              <a:rPr lang="en-US" smtClean="0"/>
-              <a:t>‹#›</a:t>
-            </a:fld>
-            <a:endParaRPr lang="en-US"/>
-          </a:p>
-        </p:txBody>
-      </p:sp>
-    </p:spTree>
-    <p:extLst>
-      <p:ext uri="{BB962C8B-B14F-4D97-AF65-F5344CB8AC3E}">
-        <p14:creationId xmlns:p14="http://schemas.microsoft.com/office/powerpoint/2010/main" val="2623252185"/>
-      </p:ext>
-    </p:extLst>
-  </p:cSld>
-  <p:clrMap bg1="lt1" tx1="dk1" bg2="lt2" tx2="dk2" accent1="accent1" accent2="accent2" accent3="accent3" accent4="accent4" accent5="accent5" accent6="accent6" hlink="hlink" folHlink="folHlink"/>
-  <p:notesStyle>
-    <a:lvl1pPr marL="0" algn="l" defTabSz="457200" rtl="0" eaLnBrk="1" latinLnBrk="0" hangingPunct="1">
-      <a:defRPr sz="1200" kern="1200">
-        <a:solidFill>
-          <a:schemeClr val="tx1"/>
-        </a:solidFill>
-        <a:latin typeface="+mn-lt"/>
-        <a:ea typeface="+mn-ea"/>
-        <a:cs typeface="+mn-cs"/>
-      </a:defRPr>
-    </a:lvl1pPr>
-    <a:lvl2pPr marL="457200" algn="l" defTabSz="457200" rtl="0" eaLnBrk="1" latinLnBrk="0" hangingPunct="1">
-      <a:defRPr sz="1200" kern="1200">
-        <a:solidFill>
-          <a:schemeClr val="tx1"/>
-        </a:solidFill>
-        <a:latin typeface="+mn-lt"/>
-        <a:ea typeface="+mn-ea"/>
-        <a:cs typeface="+mn-cs"/>
-      </a:defRPr>
-    </a:lvl2pPr>
-    <a:lvl3pPr marL="914400" algn="l" defTabSz="457200" rtl="0" eaLnBrk="1" latinLnBrk="0" hangingPunct="1">
-      <a:defRPr sz="1200" kern="1200">
-        <a:solidFill>
-          <a:schemeClr val="tx1"/>
-        </a:solidFill>
-        <a:latin typeface="+mn-lt"/>
-        <a:ea typeface="+mn-ea"/>
-        <a:cs typeface="+mn-cs"/>
-      </a:defRPr>
-    </a:lvl3pPr>
-    <a:lvl4pPr marL="1371600" algn="l" defTabSz="457200" rtl="0" eaLnBrk="1" latinLnBrk="0" hangingPunct="1">
-      <a:defRPr sz="1200" kern="1200">
-        <a:solidFill>
-          <a:schemeClr val="tx1"/>
-        </a:solidFill>
-        <a:latin typeface="+mn-lt"/>
-        <a:ea typeface="+mn-ea"/>
-        <a:cs typeface="+mn-cs"/>
-      </a:defRPr>
-    </a:lvl4pPr>
-    <a:lvl5pPr marL="1828800" algn="l" defTabSz="457200" rtl="0" eaLnBrk="1" latinLnBrk="0" hangingPunct="1">
-      <a:defRPr sz="1200" kern="1200">
-        <a:solidFill>
-          <a:schemeClr val="tx1"/>
-        </a:solidFill>
-        <a:latin typeface="+mn-lt"/>
-        <a:ea typeface="+mn-ea"/>
-        <a:cs typeface="+mn-cs"/>
-      </a:defRPr>
-    </a:lvl5pPr>
-    <a:lvl6pPr marL="2286000" algn="l" defTabSz="457200" rtl="0" eaLnBrk="1" latinLnBrk="0" hangingPunct="1">
-      <a:defRPr sz="1200" kern="1200">
-        <a:solidFill>
-          <a:schemeClr val="tx1"/>
-        </a:solidFill>
-        <a:latin typeface="+mn-lt"/>
-        <a:ea typeface="+mn-ea"/>
-        <a:cs typeface="+mn-cs"/>
-      </a:defRPr>
-    </a:lvl6pPr>
-    <a:lvl7pPr marL="2743200" algn="l" defTabSz="457200" rtl="0" eaLnBrk="1" latinLnBrk="0" hangingPunct="1">
-      <a:defRPr sz="1200" kern="1200">
-        <a:solidFill>
-          <a:schemeClr val="tx1"/>
-        </a:solidFill>
-        <a:latin typeface="+mn-lt"/>
-        <a:ea typeface="+mn-ea"/>
-        <a:cs typeface="+mn-cs"/>
-      </a:defRPr>
-    </a:lvl7pPr>
-    <a:lvl8pPr marL="3200400" algn="l" defTabSz="457200" rtl="0" eaLnBrk="1" latinLnBrk="0" hangingPunct="1">
-      <a:defRPr sz="1200" kern="1200">
-        <a:solidFill>
-          <a:schemeClr val="tx1"/>
-        </a:solidFill>
-        <a:latin typeface="+mn-lt"/>
-        <a:ea typeface="+mn-ea"/>
-        <a:cs typeface="+mn-cs"/>
-      </a:defRPr>
-    </a:lvl8pPr>
-    <a:lvl9pPr marL="3657600" algn="l" defTabSz="457200" rtl="0" eaLnBrk="1" latinLnBrk="0" hangingPunct="1">
-      <a:defRPr sz="1200" kern="1200">
-        <a:solidFill>
-          <a:schemeClr val="tx1"/>
-        </a:solidFill>
-        <a:latin typeface="+mn-lt"/>
-        <a:ea typeface="+mn-ea"/>
-        <a:cs typeface="+mn-cs"/>
-      </a:defRPr>
-    </a:lvl9pPr>
-  </p:notesStyle>
-</p:notesMaster>
-</file>
-
-<file path=ppt/notesSlides/notesSlide1.xml><?xml version="1.0" encoding="utf-8"?>
-<p:notes xmlns:a="http://schemas.openxmlformats.org/drawingml/2006/main" xmlns:p="http://schemas.openxmlformats.org/presentationml/2006/main" xmlns:r="http://schemas.openxmlformats.org/officeDocument/2006/relationships">
-  <p:cSld>
-    <p:spTree>
-      <p:nvGrpSpPr>
-        <p:cNvPr id="1" name=""/>
-        <p:cNvGrpSpPr/>
-        <p:nvPr/>
-      </p:nvGrpSpPr>
-      <p:grpSpPr>
-        <a:xfrm>
-          <a:off x="0" y="0"/>
-          <a:ext cx="0" cy="0"/>
-          <a:chOff x="0" y="0"/>
-          <a:chExt cx="0" cy="0"/>
-        </a:xfrm>
-      </p:grpSpPr>
-      <p:sp>
-        <p:nvSpPr>
-          <p:cNvPr id="2" name="Slide Image Placeholder 1"/>
-          <p:cNvSpPr>
-            <a:spLocks noGrp="1"/>
-          </p:cNvSpPr>
-          <p:nvPr>
-            <p:ph type="sldImg" idx="2"/>
-          </p:nvPr>
-        </p:nvSpPr>
-        <p:spPr/>
-      </p:sp>
-      <p:sp>
-        <p:nvSpPr>
-          <p:cNvPr id="3" name="Notes Placeholder 2"/>
-          <p:cNvSpPr>
-            <a:spLocks noGrp="1"/>
-          </p:cNvSpPr>
-          <p:nvPr>
-            <p:ph type="body" idx="3" sz="quarter"/>
-          </p:nvPr>
-        </p:nvSpPr>
-        <p:spPr/>
-        <p:txBody>
-          <a:bodyPr/>
-          <a:lstStyle/>
-          <a:p>
-            <a:r>
-              <a:t>Thanks everyone. Over the next few minutes I'll walk through three things: first the procurement issues we've identified and the impact they're having; second what we'd prioritise and why; and third the questions we'd put back to the client. I'll flag where we've made assumptions, because some of this needs data to confirm.</a:t>
-            </a:r>
-          </a:p>
-        </p:txBody>
-      </p:sp>
-      <p:sp>
-        <p:nvSpPr>
-          <p:cNvPr id="4" name="Slide Number Placeholder 3"/>
-          <p:cNvSpPr>
-            <a:spLocks noGrp="1"/>
-          </p:cNvSpPr>
-          <p:nvPr>
-            <p:ph type="sldNum" idx="5" sz="quarter"/>
-          </p:nvPr>
-        </p:nvSpPr>
-        <p:spPr/>
-      </p:sp>
-    </p:spTree>
-  </p:cSld>
-  <p:clrMapOvr>
-    <a:masterClrMapping/>
-  </p:clrMapOvr>
-</p:notes>
-</file>
-
-<file path=ppt/notesSlides/notesSlide10.xml><?xml version="1.0" encoding="utf-8"?>
-<p:notes xmlns:a="http://schemas.openxmlformats.org/drawingml/2006/main" xmlns:p="http://schemas.openxmlformats.org/presentationml/2006/main" xmlns:r="http://schemas.openxmlformats.org/officeDocument/2006/relationships">
-  <p:cSld>
-    <p:spTree>
-      <p:nvGrpSpPr>
-        <p:cNvPr id="1" name=""/>
-        <p:cNvGrpSpPr/>
-        <p:nvPr/>
-      </p:nvGrpSpPr>
-      <p:grpSpPr>
-        <a:xfrm>
-          <a:off x="0" y="0"/>
-          <a:ext cx="0" cy="0"/>
-          <a:chOff x="0" y="0"/>
-          <a:chExt cx="0" cy="0"/>
-        </a:xfrm>
-      </p:grpSpPr>
-      <p:sp>
-        <p:nvSpPr>
-          <p:cNvPr id="2" name="Slide Image Placeholder 1"/>
-          <p:cNvSpPr>
-            <a:spLocks noGrp="1"/>
-          </p:cNvSpPr>
-          <p:nvPr>
-            <p:ph type="sldImg" idx="2"/>
-          </p:nvPr>
-        </p:nvSpPr>
-        <p:spPr/>
-      </p:sp>
-      <p:sp>
-        <p:nvSpPr>
-          <p:cNvPr id="3" name="Notes Placeholder 2"/>
-          <p:cNvSpPr>
-            <a:spLocks noGrp="1"/>
-          </p:cNvSpPr>
-          <p:nvPr>
-            <p:ph type="body" idx="3" sz="quarter"/>
-          </p:nvPr>
-        </p:nvSpPr>
-        <p:spPr/>
-        <p:txBody>
-          <a:bodyPr/>
-          <a:lstStyle/>
-          <a:p>
-            <a:r>
-              <a:t>On risks and dependencies that could affect how we prioritise. The gating dependency is executive sponsorship — without it the plan stalls, full stop. We'd expect cultural resistance from 59 units used to autonomy. Being multinational, local tax and regulatory rules limit how far we can impose a single standard. Team 1's thin capacity limits how much change they can absorb. ERP consolidation carries real cost and business-continuity risk. And ongoing M&amp;A could keep re-introducing fragmentation, so this needs to be sustainable, not a one-off.</a:t>
-            </a:r>
-          </a:p>
-        </p:txBody>
-      </p:sp>
-      <p:sp>
-        <p:nvSpPr>
-          <p:cNvPr id="4" name="Slide Number Placeholder 3"/>
-          <p:cNvSpPr>
-            <a:spLocks noGrp="1"/>
-          </p:cNvSpPr>
-          <p:nvPr>
-            <p:ph type="sldNum" idx="5" sz="quarter"/>
-          </p:nvPr>
-        </p:nvSpPr>
-        <p:spPr/>
-      </p:sp>
-    </p:spTree>
-  </p:cSld>
-  <p:clrMapOvr>
-    <a:masterClrMapping/>
-  </p:clrMapOvr>
-</p:notes>
-</file>
-
-<file path=ppt/notesSlides/notesSlide11.xml><?xml version="1.0" encoding="utf-8"?>
-<p:notes xmlns:a="http://schemas.openxmlformats.org/drawingml/2006/main" xmlns:p="http://schemas.openxmlformats.org/presentationml/2006/main" xmlns:r="http://schemas.openxmlformats.org/officeDocument/2006/relationships">
-  <p:cSld>
-    <p:spTree>
-      <p:nvGrpSpPr>
-        <p:cNvPr id="1" name=""/>
-        <p:cNvGrpSpPr/>
-        <p:nvPr/>
-      </p:nvGrpSpPr>
-      <p:grpSpPr>
-        <a:xfrm>
-          <a:off x="0" y="0"/>
-          <a:ext cx="0" cy="0"/>
-          <a:chOff x="0" y="0"/>
-          <a:chExt cx="0" cy="0"/>
-        </a:xfrm>
-      </p:grpSpPr>
-      <p:sp>
-        <p:nvSpPr>
-          <p:cNvPr id="2" name="Slide Image Placeholder 1"/>
-          <p:cNvSpPr>
-            <a:spLocks noGrp="1"/>
-          </p:cNvSpPr>
-          <p:nvPr>
-            <p:ph type="sldImg" idx="2"/>
-          </p:nvPr>
-        </p:nvSpPr>
-        <p:spPr/>
-      </p:sp>
-      <p:sp>
-        <p:nvSpPr>
-          <p:cNvPr id="3" name="Notes Placeholder 2"/>
-          <p:cNvSpPr>
-            <a:spLocks noGrp="1"/>
-          </p:cNvSpPr>
-          <p:nvPr>
-            <p:ph type="body" idx="3" sz="quarter"/>
-          </p:nvPr>
-        </p:nvSpPr>
-        <p:spPr/>
-        <p:txBody>
-          <a:bodyPr/>
-          <a:lstStyle/>
-          <a:p>
-            <a:r>
-              <a:t>Before we commit to this prioritisation, there's information we'd want: spend by unit, category and supplier, and how much supplier overlap there is; invoice volumes, cycle times and any late-payment penalties; the cost of running the three ERPs; what share of the 1.8 million daily transactions is low-value tail spend and what one order costs to process; the number of catalogue items and contracts; and the budget, timeline and genuine executive appetite for change.</a:t>
-            </a:r>
-          </a:p>
-        </p:txBody>
-      </p:sp>
-      <p:sp>
-        <p:nvSpPr>
-          <p:cNvPr id="4" name="Slide Number Placeholder 3"/>
-          <p:cNvSpPr>
-            <a:spLocks noGrp="1"/>
-          </p:cNvSpPr>
-          <p:nvPr>
-            <p:ph type="sldNum" idx="5" sz="quarter"/>
-          </p:nvPr>
-        </p:nvSpPr>
-        <p:spPr/>
-      </p:sp>
-    </p:spTree>
-  </p:cSld>
-  <p:clrMapOvr>
-    <a:masterClrMapping/>
-  </p:clrMapOvr>
-</p:notes>
-</file>
-
-<file path=ppt/notesSlides/notesSlide12.xml><?xml version="1.0" encoding="utf-8"?>
-<p:notes xmlns:a="http://schemas.openxmlformats.org/drawingml/2006/main" xmlns:p="http://schemas.openxmlformats.org/presentationml/2006/main" xmlns:r="http://schemas.openxmlformats.org/officeDocument/2006/relationships">
-  <p:cSld>
-    <p:spTree>
-      <p:nvGrpSpPr>
-        <p:cNvPr id="1" name=""/>
-        <p:cNvGrpSpPr/>
-        <p:nvPr/>
-      </p:nvGrpSpPr>
-      <p:grpSpPr>
-        <a:xfrm>
-          <a:off x="0" y="0"/>
-          <a:ext cx="0" cy="0"/>
-          <a:chOff x="0" y="0"/>
-          <a:chExt cx="0" cy="0"/>
-        </a:xfrm>
-      </p:grpSpPr>
-      <p:sp>
-        <p:nvSpPr>
-          <p:cNvPr id="2" name="Slide Image Placeholder 1"/>
-          <p:cNvSpPr>
-            <a:spLocks noGrp="1"/>
-          </p:cNvSpPr>
-          <p:nvPr>
-            <p:ph type="sldImg" idx="2"/>
-          </p:nvPr>
-        </p:nvSpPr>
-        <p:spPr/>
-      </p:sp>
-      <p:sp>
-        <p:nvSpPr>
-          <p:cNvPr id="3" name="Notes Placeholder 2"/>
-          <p:cNvSpPr>
-            <a:spLocks noGrp="1"/>
-          </p:cNvSpPr>
-          <p:nvPr>
-            <p:ph type="body" idx="3" sz="quarter"/>
-          </p:nvPr>
-        </p:nvSpPr>
-        <p:spPr/>
-        <p:txBody>
-          <a:bodyPr/>
-          <a:lstStyle/>
-          <a:p>
-            <a:r>
-              <a:t>Which leads to the five questions we'd put to the client. One — spend and suppliers: total spend, how it splits across the 59 units, and the supplier overlap. Two — governance: is there appetite to mandate a single operating model, and who'd sponsor it. Three — transaction mix: how much of the 1.8 million is tail spend and what does an order cost to process. Four — systems: is ERP consolidation on the table, what's locked in, and is the target shared services or continued autonomy. And five — people: what's driving the low morale, are the vacancies funded, and can resource move between the teams. Those answers would let us confirm the plan. Happy to take questions.</a:t>
-            </a:r>
-          </a:p>
-        </p:txBody>
-      </p:sp>
-      <p:sp>
-        <p:nvSpPr>
-          <p:cNvPr id="4" name="Slide Number Placeholder 3"/>
-          <p:cNvSpPr>
-            <a:spLocks noGrp="1"/>
-          </p:cNvSpPr>
-          <p:nvPr>
-            <p:ph type="sldNum" idx="5" sz="quarter"/>
-          </p:nvPr>
-        </p:nvSpPr>
-        <p:spPr/>
-      </p:sp>
-    </p:spTree>
-  </p:cSld>
-  <p:clrMapOvr>
-    <a:masterClrMapping/>
-  </p:clrMapOvr>
-</p:notes>
-</file>
-
-<file path=ppt/notesSlides/notesSlide2.xml><?xml version="1.0" encoding="utf-8"?>
-<p:notes xmlns:a="http://schemas.openxmlformats.org/drawingml/2006/main" xmlns:p="http://schemas.openxmlformats.org/presentationml/2006/main" xmlns:r="http://schemas.openxmlformats.org/officeDocument/2006/relationships">
-  <p:cSld>
-    <p:spTree>
-      <p:nvGrpSpPr>
-        <p:cNvPr id="1" name=""/>
-        <p:cNvGrpSpPr/>
-        <p:nvPr/>
-      </p:nvGrpSpPr>
-      <p:grpSpPr>
-        <a:xfrm>
-          <a:off x="0" y="0"/>
-          <a:ext cx="0" cy="0"/>
-          <a:chOff x="0" y="0"/>
-          <a:chExt cx="0" cy="0"/>
-        </a:xfrm>
-      </p:grpSpPr>
-      <p:sp>
-        <p:nvSpPr>
-          <p:cNvPr id="2" name="Slide Image Placeholder 1"/>
-          <p:cNvSpPr>
-            <a:spLocks noGrp="1"/>
-          </p:cNvSpPr>
-          <p:nvPr>
-            <p:ph type="sldImg" idx="2"/>
-          </p:nvPr>
-        </p:nvSpPr>
-        <p:spPr/>
-      </p:sp>
-      <p:sp>
-        <p:nvSpPr>
-          <p:cNvPr id="3" name="Notes Placeholder 2"/>
-          <p:cNvSpPr>
-            <a:spLocks noGrp="1"/>
-          </p:cNvSpPr>
-          <p:nvPr>
-            <p:ph type="body" idx="3" sz="quarter"/>
-          </p:nvPr>
-        </p:nvSpPr>
-        <p:spPr/>
-        <p:txBody>
-          <a:bodyPr/>
-          <a:lstStyle/>
-          <a:p>
-            <a:r>
-              <a:t>The key thing to understand is that this isn't really 59 separate problems — it's one. The company grew by acquisition but never integrated those businesses, so today 59 sites run as independent organisations, each with their own processes, suppliers and back-end systems. Two central teams are accountable across all of them. And the scale matters: at roughly 1.8 million transactions a day, even a tiny inefficiency per transaction becomes enormous. Everything that follows comes from the manager's own internal analysis.</a:t>
-            </a:r>
-          </a:p>
-        </p:txBody>
-      </p:sp>
-      <p:sp>
-        <p:nvSpPr>
-          <p:cNvPr id="4" name="Slide Number Placeholder 3"/>
-          <p:cNvSpPr>
-            <a:spLocks noGrp="1"/>
-          </p:cNvSpPr>
-          <p:nvPr>
-            <p:ph type="sldNum" idx="5" sz="quarter"/>
-          </p:nvPr>
-        </p:nvSpPr>
-        <p:spPr/>
-      </p:sp>
-    </p:spTree>
-  </p:cSld>
-  <p:clrMapOvr>
-    <a:masterClrMapping/>
-  </p:clrMapOvr>
-</p:notes>
-</file>
-
-<file path=ppt/notesSlides/notesSlide3.xml><?xml version="1.0" encoding="utf-8"?>
-<p:notes xmlns:a="http://schemas.openxmlformats.org/drawingml/2006/main" xmlns:p="http://schemas.openxmlformats.org/presentationml/2006/main" xmlns:r="http://schemas.openxmlformats.org/officeDocument/2006/relationships">
-  <p:cSld>
-    <p:spTree>
-      <p:nvGrpSpPr>
-        <p:cNvPr id="1" name=""/>
-        <p:cNvGrpSpPr/>
-        <p:nvPr/>
-      </p:nvGrpSpPr>
-      <p:grpSpPr>
-        <a:xfrm>
-          <a:off x="0" y="0"/>
-          <a:ext cx="0" cy="0"/>
-          <a:chOff x="0" y="0"/>
-          <a:chExt cx="0" cy="0"/>
-        </a:xfrm>
-      </p:grpSpPr>
-      <p:sp>
-        <p:nvSpPr>
-          <p:cNvPr id="2" name="Slide Image Placeholder 1"/>
-          <p:cNvSpPr>
-            <a:spLocks noGrp="1"/>
-          </p:cNvSpPr>
-          <p:nvPr>
-            <p:ph type="sldImg" idx="2"/>
-          </p:nvPr>
-        </p:nvSpPr>
-        <p:spPr/>
-      </p:sp>
-      <p:sp>
-        <p:nvSpPr>
-          <p:cNvPr id="3" name="Notes Placeholder 2"/>
-          <p:cNvSpPr>
-            <a:spLocks noGrp="1"/>
-          </p:cNvSpPr>
-          <p:nvPr>
-            <p:ph type="body" idx="3" sz="quarter"/>
-          </p:nvPr>
-        </p:nvSpPr>
-        <p:spPr/>
-        <p:txBody>
-          <a:bodyPr/>
-          <a:lstStyle/>
-          <a:p>
-            <a:r>
-              <a:t>We've separated the findings into root causes — the drivers — and symptoms, because you fix the drivers, not the symptoms. There are four root causes. R1, and the most important, is that there's no executive mandate: the central teams are accountable but can't actually enforce compliance across 59 autonomous units. R2 is the fragmented operating model from M&amp;A. R3 is that there's no standard process — staff are upskilled to invoice in lots of different ways. And R4 is the systems: three ERPs, Oracle, SAP and PeopleSoft, poorly integrated, forcing a lot of manual work.</a:t>
-            </a:r>
-          </a:p>
-        </p:txBody>
-      </p:sp>
-      <p:sp>
-        <p:nvSpPr>
-          <p:cNvPr id="4" name="Slide Number Placeholder 3"/>
-          <p:cNvSpPr>
-            <a:spLocks noGrp="1"/>
-          </p:cNvSpPr>
-          <p:nvPr>
-            <p:ph type="sldNum" idx="5" sz="quarter"/>
-          </p:nvPr>
-        </p:nvSpPr>
-        <p:spPr/>
-      </p:sp>
-    </p:spTree>
-  </p:cSld>
-  <p:clrMapOvr>
-    <a:masterClrMapping/>
-  </p:clrMapOvr>
-</p:notes>
-</file>
-
-<file path=ppt/notesSlides/notesSlide4.xml><?xml version="1.0" encoding="utf-8"?>
-<p:notes xmlns:a="http://schemas.openxmlformats.org/drawingml/2006/main" xmlns:p="http://schemas.openxmlformats.org/presentationml/2006/main" xmlns:r="http://schemas.openxmlformats.org/officeDocument/2006/relationships">
-  <p:cSld>
-    <p:spTree>
-      <p:nvGrpSpPr>
-        <p:cNvPr id="1" name=""/>
-        <p:cNvGrpSpPr/>
-        <p:nvPr/>
-      </p:nvGrpSpPr>
-      <p:grpSpPr>
-        <a:xfrm>
-          <a:off x="0" y="0"/>
-          <a:ext cx="0" cy="0"/>
-          <a:chOff x="0" y="0"/>
-          <a:chExt cx="0" cy="0"/>
-        </a:xfrm>
-      </p:grpSpPr>
-      <p:sp>
-        <p:nvSpPr>
-          <p:cNvPr id="2" name="Slide Image Placeholder 1"/>
-          <p:cNvSpPr>
-            <a:spLocks noGrp="1"/>
-          </p:cNvSpPr>
-          <p:nvPr>
-            <p:ph type="sldImg" idx="2"/>
-          </p:nvPr>
-        </p:nvSpPr>
-        <p:spPr/>
-      </p:sp>
-      <p:sp>
-        <p:nvSpPr>
-          <p:cNvPr id="3" name="Notes Placeholder 2"/>
-          <p:cNvSpPr>
-            <a:spLocks noGrp="1"/>
-          </p:cNvSpPr>
-          <p:nvPr>
-            <p:ph type="body" idx="3" sz="quarter"/>
-          </p:nvPr>
-        </p:nvSpPr>
-        <p:spPr/>
-        <p:txBody>
-          <a:bodyPr/>
-          <a:lstStyle/>
-          <a:p>
-            <a:r>
-              <a:t>Those root causes produce five symptoms. Protracted payables — slow invoice processing. Lost economies of scale. Catalogue proliferation and tail spend, where a single low-value item needs multiple orders to different suppliers. The resourcing imbalance between the two teams — Team 1 is understaffed with two vacancies and part-timers while Team 2 is much stronger. And low morale, because procurement is seen as low-value back-office work. I'd flag that the cost of late payments and the morale-driven attrition are assumptions at this stage — sensible, but not yet quantified.</a:t>
-            </a:r>
-          </a:p>
-        </p:txBody>
-      </p:sp>
-      <p:sp>
-        <p:nvSpPr>
-          <p:cNvPr id="4" name="Slide Number Placeholder 3"/>
-          <p:cNvSpPr>
-            <a:spLocks noGrp="1"/>
-          </p:cNvSpPr>
-          <p:nvPr>
-            <p:ph type="sldNum" idx="5" sz="quarter"/>
-          </p:nvPr>
-        </p:nvSpPr>
-        <p:spPr/>
-      </p:sp>
-    </p:spTree>
-  </p:cSld>
-  <p:clrMapOvr>
-    <a:masterClrMapping/>
-  </p:clrMapOvr>
-</p:notes>
-</file>
-
-<file path=ppt/notesSlides/notesSlide5.xml><?xml version="1.0" encoding="utf-8"?>
-<p:notes xmlns:a="http://schemas.openxmlformats.org/drawingml/2006/main" xmlns:p="http://schemas.openxmlformats.org/presentationml/2006/main" xmlns:r="http://schemas.openxmlformats.org/officeDocument/2006/relationships">
-  <p:cSld>
-    <p:spTree>
-      <p:nvGrpSpPr>
-        <p:cNvPr id="1" name=""/>
-        <p:cNvGrpSpPr/>
-        <p:nvPr/>
-      </p:nvGrpSpPr>
-      <p:grpSpPr>
-        <a:xfrm>
-          <a:off x="0" y="0"/>
-          <a:ext cx="0" cy="0"/>
-          <a:chOff x="0" y="0"/>
-          <a:chExt cx="0" cy="0"/>
-        </a:xfrm>
-      </p:grpSpPr>
-      <p:sp>
-        <p:nvSpPr>
-          <p:cNvPr id="2" name="Slide Image Placeholder 1"/>
-          <p:cNvSpPr>
-            <a:spLocks noGrp="1"/>
-          </p:cNvSpPr>
-          <p:nvPr>
-            <p:ph type="sldImg" idx="2"/>
-          </p:nvPr>
-        </p:nvSpPr>
-        <p:spPr/>
-      </p:sp>
-      <p:sp>
-        <p:nvSpPr>
-          <p:cNvPr id="3" name="Notes Placeholder 2"/>
-          <p:cNvSpPr>
-            <a:spLocks noGrp="1"/>
-          </p:cNvSpPr>
-          <p:nvPr>
-            <p:ph type="body" idx="3" sz="quarter"/>
-          </p:nvPr>
-        </p:nvSpPr>
-        <p:spPr/>
-        <p:txBody>
-          <a:bodyPr/>
-          <a:lstStyle/>
-          <a:p>
-            <a:r>
-              <a:t>This is the strongest piece of evidence. Between 2023 and 2024 the supplier count went up 18%, from 224 to 264, and spend rose 16% to just over a billion. But average spend per supplier actually fell. So as the business grows it's adding suppliers faster than it's consolidating them — it's fragmenting, not concentrating. That's direct evidence for the lost economies of scale and the un-integrated operating model. The assumption is that these are group-wide numbers; a per-unit split would let us size the opportunity precisely.</a:t>
-            </a:r>
-          </a:p>
-        </p:txBody>
-      </p:sp>
-      <p:sp>
-        <p:nvSpPr>
-          <p:cNvPr id="4" name="Slide Number Placeholder 3"/>
-          <p:cNvSpPr>
-            <a:spLocks noGrp="1"/>
-          </p:cNvSpPr>
-          <p:nvPr>
-            <p:ph type="sldNum" idx="5" sz="quarter"/>
-          </p:nvPr>
-        </p:nvSpPr>
-        <p:spPr/>
-      </p:sp>
-    </p:spTree>
-  </p:cSld>
-  <p:clrMapOvr>
-    <a:masterClrMapping/>
-  </p:clrMapOvr>
-</p:notes>
-</file>
-
-<file path=ppt/notesSlides/notesSlide6.xml><?xml version="1.0" encoding="utf-8"?>
-<p:notes xmlns:a="http://schemas.openxmlformats.org/drawingml/2006/main" xmlns:p="http://schemas.openxmlformats.org/presentationml/2006/main" xmlns:r="http://schemas.openxmlformats.org/officeDocument/2006/relationships">
-  <p:cSld>
-    <p:spTree>
-      <p:nvGrpSpPr>
-        <p:cNvPr id="1" name=""/>
-        <p:cNvGrpSpPr/>
-        <p:nvPr/>
-      </p:nvGrpSpPr>
-      <p:grpSpPr>
-        <a:xfrm>
-          <a:off x="0" y="0"/>
-          <a:ext cx="0" cy="0"/>
-          <a:chOff x="0" y="0"/>
-          <a:chExt cx="0" cy="0"/>
-        </a:xfrm>
-      </p:grpSpPr>
-      <p:sp>
-        <p:nvSpPr>
-          <p:cNvPr id="2" name="Slide Image Placeholder 1"/>
-          <p:cNvSpPr>
-            <a:spLocks noGrp="1"/>
-          </p:cNvSpPr>
-          <p:nvPr>
-            <p:ph type="sldImg" idx="2"/>
-          </p:nvPr>
-        </p:nvSpPr>
-        <p:spPr/>
-      </p:sp>
-      <p:sp>
-        <p:nvSpPr>
-          <p:cNvPr id="3" name="Notes Placeholder 2"/>
-          <p:cNvSpPr>
-            <a:spLocks noGrp="1"/>
-          </p:cNvSpPr>
-          <p:nvPr>
-            <p:ph type="body" idx="3" sz="quarter"/>
-          </p:nvPr>
-        </p:nvSpPr>
-        <p:spPr/>
-        <p:txBody>
-          <a:bodyPr/>
-          <a:lstStyle/>
-          <a:p>
-            <a:r>
-              <a:t>If I had to pick the single most important issue, it's R1 — the lack of an executive mandate. It's not the most expensive problem to fix, but it's the dependency that unblocks everything else. You simply can't standardise processes, consolidate systems or rationalise suppliers across 59 autonomous units unless leadership mandates it. And the business impact of not fixing it is exactly what that supplier chart shows — continued fragmentation. Low cost, high leverage, so we fix it first.</a:t>
-            </a:r>
-          </a:p>
-        </p:txBody>
-      </p:sp>
-      <p:sp>
-        <p:nvSpPr>
-          <p:cNvPr id="4" name="Slide Number Placeholder 3"/>
-          <p:cNvSpPr>
-            <a:spLocks noGrp="1"/>
-          </p:cNvSpPr>
-          <p:nvPr>
-            <p:ph type="sldNum" idx="5" sz="quarter"/>
-          </p:nvPr>
-        </p:nvSpPr>
-        <p:spPr/>
-      </p:sp>
-    </p:spTree>
-  </p:cSld>
-  <p:clrMapOvr>
-    <a:masterClrMapping/>
-  </p:clrMapOvr>
-</p:notes>
-</file>
-
-<file path=ppt/notesSlides/notesSlide7.xml><?xml version="1.0" encoding="utf-8"?>
-<p:notes xmlns:a="http://schemas.openxmlformats.org/drawingml/2006/main" xmlns:p="http://schemas.openxmlformats.org/presentationml/2006/main" xmlns:r="http://schemas.openxmlformats.org/officeDocument/2006/relationships">
-  <p:cSld>
-    <p:spTree>
-      <p:nvGrpSpPr>
-        <p:cNvPr id="1" name=""/>
-        <p:cNvGrpSpPr/>
-        <p:nvPr/>
-      </p:nvGrpSpPr>
-      <p:grpSpPr>
-        <a:xfrm>
-          <a:off x="0" y="0"/>
-          <a:ext cx="0" cy="0"/>
-          <a:chOff x="0" y="0"/>
-          <a:chExt cx="0" cy="0"/>
-        </a:xfrm>
-      </p:grpSpPr>
-      <p:sp>
-        <p:nvSpPr>
-          <p:cNvPr id="2" name="Slide Image Placeholder 1"/>
-          <p:cNvSpPr>
-            <a:spLocks noGrp="1"/>
-          </p:cNvSpPr>
-          <p:nvPr>
-            <p:ph type="sldImg" idx="2"/>
-          </p:nvPr>
-        </p:nvSpPr>
-        <p:spPr/>
-      </p:sp>
-      <p:sp>
-        <p:nvSpPr>
-          <p:cNvPr id="3" name="Notes Placeholder 2"/>
-          <p:cNvSpPr>
-            <a:spLocks noGrp="1"/>
-          </p:cNvSpPr>
-          <p:nvPr>
-            <p:ph type="body" idx="3" sz="quarter"/>
-          </p:nvPr>
-        </p:nvSpPr>
-        <p:spPr/>
-        <p:txBody>
-          <a:bodyPr/>
-          <a:lstStyle/>
-          <a:p>
-            <a:r>
-              <a:t>So onto what we'd prioritise. Deliberately, this is three high-impact moves rather than a big multi-year transformation. One: secure executive sponsorship and a compliance mandate — fast, cheap, unlocks everything. Two: standardise the procure-to-pay process and rationalise the catalogue and tail spend — this is the biggest near-term efficiency win at 1.8 million transactions a day, and crucially it doesn't require replacing any systems. Three: rebalance the two teams — fill Team 1's vacancies or shift workload — a quick operational win that also helps morale. Our assumption is these three deliver most of the benefit.</a:t>
-            </a:r>
-          </a:p>
-        </p:txBody>
-      </p:sp>
-      <p:sp>
-        <p:nvSpPr>
-          <p:cNvPr id="4" name="Slide Number Placeholder 3"/>
-          <p:cNvSpPr>
-            <a:spLocks noGrp="1"/>
-          </p:cNvSpPr>
-          <p:nvPr>
-            <p:ph type="sldNum" idx="5" sz="quarter"/>
-          </p:nvPr>
-        </p:nvSpPr>
-        <p:spPr/>
-      </p:sp>
-    </p:spTree>
-  </p:cSld>
-  <p:clrMapOvr>
-    <a:masterClrMapping/>
-  </p:clrMapOvr>
-</p:notes>
-</file>
-
-<file path=ppt/notesSlides/notesSlide8.xml><?xml version="1.0" encoding="utf-8"?>
-<p:notes xmlns:a="http://schemas.openxmlformats.org/drawingml/2006/main" xmlns:p="http://schemas.openxmlformats.org/presentationml/2006/main" xmlns:r="http://schemas.openxmlformats.org/officeDocument/2006/relationships">
-  <p:cSld>
-    <p:spTree>
-      <p:nvGrpSpPr>
-        <p:cNvPr id="1" name=""/>
-        <p:cNvGrpSpPr/>
-        <p:nvPr/>
-      </p:nvGrpSpPr>
-      <p:grpSpPr>
-        <a:xfrm>
-          <a:off x="0" y="0"/>
-          <a:ext cx="0" cy="0"/>
-          <a:chOff x="0" y="0"/>
-          <a:chExt cx="0" cy="0"/>
-        </a:xfrm>
-      </p:grpSpPr>
-      <p:sp>
-        <p:nvSpPr>
-          <p:cNvPr id="2" name="Slide Image Placeholder 1"/>
-          <p:cNvSpPr>
-            <a:spLocks noGrp="1"/>
-          </p:cNvSpPr>
-          <p:nvPr>
-            <p:ph type="sldImg" idx="2"/>
-          </p:nvPr>
-        </p:nvSpPr>
-        <p:spPr/>
-      </p:sp>
-      <p:sp>
-        <p:nvSpPr>
-          <p:cNvPr id="3" name="Notes Placeholder 2"/>
-          <p:cNvSpPr>
-            <a:spLocks noGrp="1"/>
-          </p:cNvSpPr>
-          <p:nvPr>
-            <p:ph type="body" idx="3" sz="quarter"/>
-          </p:nvPr>
-        </p:nvSpPr>
-        <p:spPr/>
-        <p:txBody>
-          <a:bodyPr/>
-          <a:lstStyle/>
-          <a:p>
-            <a:r>
-              <a:t>The bigger structural items we'd treat as longer-term and only do if the data justifies them: consolidating the ERPs, rationalising the supplier base, and moving toward a shared-services model. I want to be clear — we are not assuming a full ERP consolidation is the right answer yet. That's a significant business case and it should be decided on spend, cost-to-serve and contractual lock-in data, not assumed up front.</a:t>
-            </a:r>
-          </a:p>
-        </p:txBody>
-      </p:sp>
-      <p:sp>
-        <p:nvSpPr>
-          <p:cNvPr id="4" name="Slide Number Placeholder 3"/>
-          <p:cNvSpPr>
-            <a:spLocks noGrp="1"/>
-          </p:cNvSpPr>
-          <p:nvPr>
-            <p:ph type="sldNum" idx="5" sz="quarter"/>
-          </p:nvPr>
-        </p:nvSpPr>
-        <p:spPr/>
-      </p:sp>
-    </p:spTree>
-  </p:cSld>
-  <p:clrMapOvr>
-    <a:masterClrMapping/>
-  </p:clrMapOvr>
-</p:notes>
-</file>
-
-<file path=ppt/notesSlides/notesSlide9.xml><?xml version="1.0" encoding="utf-8"?>
-<p:notes xmlns:a="http://schemas.openxmlformats.org/drawingml/2006/main" xmlns:p="http://schemas.openxmlformats.org/presentationml/2006/main" xmlns:r="http://schemas.openxmlformats.org/officeDocument/2006/relationships">
-  <p:cSld>
-    <p:spTree>
-      <p:nvGrpSpPr>
-        <p:cNvPr id="1" name=""/>
-        <p:cNvGrpSpPr/>
-        <p:nvPr/>
-      </p:nvGrpSpPr>
-      <p:grpSpPr>
-        <a:xfrm>
-          <a:off x="0" y="0"/>
-          <a:ext cx="0" cy="0"/>
-          <a:chOff x="0" y="0"/>
-          <a:chExt cx="0" cy="0"/>
-        </a:xfrm>
-      </p:grpSpPr>
-      <p:sp>
-        <p:nvSpPr>
-          <p:cNvPr id="2" name="Slide Image Placeholder 1"/>
-          <p:cNvSpPr>
-            <a:spLocks noGrp="1"/>
-          </p:cNvSpPr>
-          <p:nvPr>
-            <p:ph type="sldImg" idx="2"/>
-          </p:nvPr>
-        </p:nvSpPr>
-        <p:spPr/>
-      </p:sp>
-      <p:sp>
-        <p:nvSpPr>
-          <p:cNvPr id="3" name="Notes Placeholder 2"/>
-          <p:cNvSpPr>
-            <a:spLocks noGrp="1"/>
-          </p:cNvSpPr>
-          <p:nvPr>
-            <p:ph type="body" idx="3" sz="quarter"/>
-          </p:nvPr>
-        </p:nvSpPr>
-        <p:spPr/>
-        <p:txBody>
-          <a:bodyPr/>
-          <a:lstStyle/>
-          <a:p>
-            <a:r>
-              <a:t>Why are these a priority organisationally? It helps to look across four lenses. People: the teams are imbalanced, morale is low, and procurement is seen as low value — so capacity and appetite for change are limited. Process: no standard process, manual work, catalogue sprawl — and that scales to 1.8 million transactions. Governance: no executive mandate, which is the thing that elevates all of this to a priority. And systems: three poorly integrated ERPs with no consolidated spend data. It's embedded across all four, which is exactly why it needs addressing now.</a:t>
-            </a:r>
-          </a:p>
-        </p:txBody>
-      </p:sp>
-      <p:sp>
-        <p:nvSpPr>
-          <p:cNvPr id="4" name="Slide Number Placeholder 3"/>
-          <p:cNvSpPr>
-            <a:spLocks noGrp="1"/>
-          </p:cNvSpPr>
-          <p:nvPr>
-            <p:ph type="sldNum" idx="5" sz="quarter"/>
-          </p:nvPr>
-        </p:nvSpPr>
-        <p:spPr/>
-      </p:sp>
-    </p:spTree>
-  </p:cSld>
-  <p:clrMapOvr>
-    <a:masterClrMapping/>
-  </p:clrMapOvr>
-</p:notes>
 </file>
 
 <file path=ppt/slideLayouts/slideLayout1.xml><?xml version="1.0" encoding="utf-8"?>
@@ -4317,7 +3127,7 @@
                   <a:srgbClr val="1F3864"/>
                 </a:solidFill>
               </a:rPr>
-              <a:t>Procurement Problem Analysis &amp; Prioritisation</a:t>
+              <a:t>Procurement Problem Analysis and Prioritisation</a:t>
             </a:r>
           </a:p>
           <a:p>
@@ -4327,7 +3137,7 @@
                   <a:srgbClr val="444444"/>
                 </a:solidFill>
               </a:rPr>
-              <a:t>Client: Multinational Semiconductor Major  |  Manager's internal review</a:t>
+              <a:t>Client: a multinational semiconductor major  |  Manager's internal review</a:t>
             </a:r>
           </a:p>
           <a:p>
@@ -4337,7 +3147,7 @@
                   <a:srgbClr val="C0392B"/>
                 </a:solidFill>
               </a:rPr>
-              <a:t>1. The issues, evidence &amp; impact   2. Prioritisation   3. Questions for the client</a:t>
+              <a:t>1. The issues, evidence and impact     2. What to prioritise     3. Questions for the client</a:t>
             </a:r>
           </a:p>
         </p:txBody>
@@ -4388,7 +3198,7 @@
                   <a:srgbClr val="1F3864"/>
                 </a:solidFill>
               </a:rPr>
-              <a:t>Key risks, constraints &amp; dependencies affecting prioritisation</a:t>
+              <a:t>Risks, constraints and dependencies that affect the priorities</a:t>
             </a:r>
           </a:p>
         </p:txBody>
@@ -4426,7 +3236,7 @@
                   <a:srgbClr val="1F3864"/>
                 </a:solidFill>
               </a:rPr>
-              <a:t>Dependency: executive sponsorship is the gating dependency — the plan stalls without it.</a:t>
+              <a:t>The big dependency is executive backing. Without it the whole plan stalls.</a:t>
             </a:r>
           </a:p>
           <a:p>
@@ -4441,7 +3251,7 @@
                   <a:srgbClr val="444444"/>
                 </a:solidFill>
               </a:rPr>
-              <a:t>Constraint: 59 autonomous units will resist giving up control (cultural).</a:t>
+              <a:t>The 59 sites are used to running themselves, so expect pushback on giving up control.</a:t>
             </a:r>
           </a:p>
           <a:p>
@@ -4456,7 +3266,7 @@
                   <a:srgbClr val="444444"/>
                 </a:solidFill>
               </a:rPr>
-              <a:t>Constraint: multinational tax / statutory / regulatory rules limit a single standard.</a:t>
+              <a:t>As a global business, local tax and legal rules limit how far one standard can go.</a:t>
             </a:r>
           </a:p>
           <a:p>
@@ -4471,7 +3281,7 @@
                   <a:srgbClr val="444444"/>
                 </a:solidFill>
               </a:rPr>
-              <a:t>Constraint: thin Team 1 capacity + low morale limit bandwidth to absorb change.</a:t>
+              <a:t>Team 1 is stretched thin, so there is little spare capacity to take on change.</a:t>
             </a:r>
           </a:p>
           <a:p>
@@ -4486,7 +3296,7 @@
                   <a:srgbClr val="444444"/>
                 </a:solidFill>
               </a:rPr>
-              <a:t>Risk: ERP consolidation carries cost, business-continuity and data-migration risk.</a:t>
+              <a:t>Bringing the ERPs together would be costly and carries a real risk to day-to-day operations.</a:t>
             </a:r>
           </a:p>
           <a:p>
@@ -4501,7 +3311,7 @@
                   <a:srgbClr val="444444"/>
                 </a:solidFill>
               </a:rPr>
-              <a:t>Risk: ongoing M&amp;A may keep re-introducing fragmentation; contractual lock-ins on systems/suppliers.</a:t>
+              <a:t>More acquisitions could keep adding to the problem, and some systems or suppliers may be locked into contracts.</a:t>
             </a:r>
           </a:p>
         </p:txBody>
@@ -4552,7 +3362,7 @@
                   <a:srgbClr val="1F3864"/>
                 </a:solidFill>
               </a:rPr>
-              <a:t>Information needed before confirming priorities</a:t>
+              <a:t>What I would want to know before confirming the priorities</a:t>
             </a:r>
           </a:p>
         </p:txBody>
@@ -4590,7 +3400,7 @@
                   <a:srgbClr val="444444"/>
                 </a:solidFill>
               </a:rPr>
-              <a:t>Spend by unit / category / supplier, and supplier overlap across units.</a:t>
+              <a:t>Spend by site, category and supplier, and how much supplier overlap there is.</a:t>
             </a:r>
           </a:p>
           <a:p>
@@ -4605,7 +3415,7 @@
                   <a:srgbClr val="444444"/>
                 </a:solidFill>
               </a:rPr>
-              <a:t>Invoice volumes, cycle times, late-payment penalties and maverick-spend rates.</a:t>
+              <a:t>Invoice volumes, how long payments take, and any late-payment charges.</a:t>
             </a:r>
           </a:p>
           <a:p>
@@ -4620,7 +3430,7 @@
                   <a:srgbClr val="444444"/>
                 </a:solidFill>
               </a:rPr>
-              <a:t>Cost of running the three ERPs (licences + support).</a:t>
+              <a:t>What it costs to run the three ERPs.</a:t>
             </a:r>
           </a:p>
           <a:p>
@@ -4635,7 +3445,7 @@
                   <a:srgbClr val="444444"/>
                 </a:solidFill>
               </a:rPr>
-              <a:t>Share of the 1.8M daily transactions that is low-value/tail vs strategic, and cost-to-process per order.</a:t>
+              <a:t>How much of the 1.8 million daily transactions is small-value, and what one order costs to process.</a:t>
             </a:r>
           </a:p>
           <a:p>
@@ -4650,7 +3460,7 @@
                   <a:srgbClr val="444444"/>
                 </a:solidFill>
               </a:rPr>
-              <a:t>Number of catalogue items and contracts; contractual lock-ins.</a:t>
+              <a:t>How many catalogue items and contracts there are, and which are locked in.</a:t>
             </a:r>
           </a:p>
           <a:p>
@@ -4665,7 +3475,7 @@
                   <a:srgbClr val="444444"/>
                 </a:solidFill>
               </a:rPr>
-              <a:t>Budget, timeline and genuine executive appetite for change.</a:t>
+              <a:t>The budget, the timeline, and whether leadership is genuinely willing to change.</a:t>
             </a:r>
           </a:p>
         </p:txBody>
@@ -4726,7 +3536,7 @@
                   <a:srgbClr val="C0392B"/>
                 </a:solidFill>
               </a:rPr>
-              <a:t>To better inform our work</a:t>
+              <a:t>To help us get this right</a:t>
             </a:r>
           </a:p>
         </p:txBody>
@@ -4764,7 +3574,7 @@
                   <a:srgbClr val="1F3864"/>
                 </a:solidFill>
               </a:rPr>
-              <a:t>1.  Spend &amp; suppliers — total spend, split across the 59 units, and how much supplier overlap exists between them?</a:t>
+              <a:t>1.  Spend and suppliers: what is the total spend, how does it split across the 59 sites, and how much supplier overlap is there?</a:t>
             </a:r>
           </a:p>
           <a:p>
@@ -4779,7 +3589,7 @@
                   <a:srgbClr val="1F3864"/>
                 </a:solidFill>
               </a:rPr>
-              <a:t>2.  Governance — is there executive appetite to mandate a single, compliant operating model, and who would sponsor it?</a:t>
+              <a:t>2.  Governance: is leadership willing to require one common way of working, and who would own it?</a:t>
             </a:r>
           </a:p>
           <a:p>
@@ -4794,7 +3604,7 @@
                   <a:srgbClr val="1F3864"/>
                 </a:solidFill>
               </a:rPr>
-              <a:t>3.  Transaction mix — of the 1.8M daily transactions, what share is low-value/tail, and what does one order cost to process today?</a:t>
+              <a:t>3.  Transactions: how much of the 1.8 million a day is small-value spend, and what does it cost to process one order today?</a:t>
             </a:r>
           </a:p>
           <a:p>
@@ -4809,7 +3619,7 @@
                   <a:srgbClr val="1F3864"/>
                 </a:solidFill>
               </a:rPr>
-              <a:t>4.  Systems — is ERP consolidation on the table, what lock-ins exist, and is the target shared services or continued unit autonomy?</a:t>
+              <a:t>4.  Systems: is bringing the ERPs together on the table, what is locked in by contract, and is the goal a shared service or keeping sites independent?</a:t>
             </a:r>
           </a:p>
           <a:p>
@@ -4824,7 +3634,7 @@
                   <a:srgbClr val="1F3864"/>
                 </a:solidFill>
               </a:rPr>
-              <a:t>5.  People — what's driving low morale, are Team 1's vacancies funded, and can resource move between the two teams?</a:t>
+              <a:t>5.  People: what is behind the low morale, are Team 1's open roles funded, and can people move between the two teams?</a:t>
             </a:r>
           </a:p>
         </p:txBody>
@@ -4875,7 +3685,7 @@
                   <a:srgbClr val="1F3864"/>
                 </a:solidFill>
               </a:rPr>
-              <a:t>Context: one company running as 59</a:t>
+              <a:t>The situation: one company running as 59</a:t>
             </a:r>
           </a:p>
         </p:txBody>
@@ -4913,7 +3723,7 @@
                   <a:srgbClr val="1F3864"/>
                 </a:solidFill>
               </a:rPr>
-              <a:t>A multinational semiconductor major grew through M&amp;A but never integrated the acquired businesses.</a:t>
+              <a:t>This is really one problem, not 59. The company grew through acquisitions but never brought those businesses together.</a:t>
             </a:r>
           </a:p>
           <a:p>
@@ -4928,7 +3738,7 @@
                   <a:srgbClr val="444444"/>
                 </a:solidFill>
               </a:rPr>
-              <a:t>59 operating locations run as independent organisations, each with its own procurement processes, supplier community and back-end systems (Oracle, SAP, PeopleSoft).</a:t>
+              <a:t>All 59 sites still run as separate organisations, each with its own procurement, supplier base and back-end systems (Oracle, SAP and PeopleSoft).</a:t>
             </a:r>
           </a:p>
           <a:p>
@@ -4943,7 +3753,7 @@
                   <a:srgbClr val="444444"/>
                 </a:solidFill>
               </a:rPr>
-              <a:t>Two central procurement teams are accountable for end-to-end process across all 59 locations.</a:t>
+              <a:t>Two central teams are meant to cover procurement across every site.</a:t>
             </a:r>
           </a:p>
           <a:p>
@@ -4958,7 +3768,7 @@
                   <a:srgbClr val="1F3864"/>
                 </a:solidFill>
               </a:rPr>
-              <a:t>Scale: ~1.8 million procurement transactions every day — so every inefficiency is multiplied massively.</a:t>
+              <a:t>The company handles about 1.8 million procurement transactions a day, so even a small inefficiency adds up fast.</a:t>
             </a:r>
           </a:p>
           <a:p>
@@ -4973,7 +3783,7 @@
                   <a:srgbClr val="444444"/>
                 </a:solidFill>
               </a:rPr>
-              <a:t>A manager's internal analysis surfaced the issues that follow.</a:t>
+              <a:t>Everything here comes from the manager's own internal analysis.</a:t>
             </a:r>
           </a:p>
         </p:txBody>
@@ -5024,7 +3834,7 @@
                   <a:srgbClr val="1F3864"/>
                 </a:solidFill>
               </a:rPr>
-              <a:t>1. The issues — root causes (the drivers)</a:t>
+              <a:t>1. The issues: root causes (the real drivers)</a:t>
             </a:r>
           </a:p>
           <a:p>
@@ -5034,7 +3844,7 @@
                   <a:srgbClr val="C0392B"/>
                 </a:solidFill>
               </a:rPr>
-              <a:t>Problem | evidence | business impact</a:t>
+              <a:t>Problem, evidence and business impact</a:t>
             </a:r>
           </a:p>
         </p:txBody>
@@ -5072,7 +3882,7 @@
                   <a:srgbClr val="1F3864"/>
                 </a:solidFill>
               </a:rPr>
-              <a:t>R1  No executive sponsorship to enforce compliance</a:t>
+              <a:t>R1  No executive backing to enforce a common way of working</a:t>
             </a:r>
           </a:p>
           <a:p>
@@ -5087,7 +3897,7 @@
                   <a:srgbClr val="444444"/>
                 </a:solidFill>
               </a:rPr>
-              <a:t>Teams are accountable but have no mandate; 'control of all 59 is a huge challenge' -&gt; nothing can be standardised. The keystone issue.</a:t>
+              <a:t>The central teams are responsible for the process but have no authority to make 59 independent sites follow it, so nothing gets standardised. This is the one that holds everything else back.</a:t>
             </a:r>
           </a:p>
           <a:p>
@@ -5102,7 +3912,7 @@
                   <a:srgbClr val="1F3864"/>
                 </a:solidFill>
               </a:rPr>
-              <a:t>R2  59 independent units from M&amp;A, never integrated</a:t>
+              <a:t>R2  59 separate units from M&amp;A that were never joined up</a:t>
             </a:r>
           </a:p>
           <a:p>
@@ -5117,7 +3927,7 @@
                   <a:srgbClr val="444444"/>
                 </a:solidFill>
               </a:rPr>
-              <a:t>Own processes, suppliers and systems -&gt; duplication, no single source of truth, no buying leverage.</a:t>
+              <a:t>Each has its own processes, suppliers and systems, which means duplication, no single view of spend and no buying power.</a:t>
             </a:r>
           </a:p>
           <a:p>
@@ -5132,7 +3942,7 @@
                   <a:srgbClr val="1F3864"/>
                 </a:solidFill>
               </a:rPr>
-              <a:t>R3  No standardised process design</a:t>
+              <a:t>R3  No standard process</a:t>
             </a:r>
           </a:p>
           <a:p>
@@ -5147,7 +3957,7 @@
                   <a:srgbClr val="444444"/>
                 </a:solidFill>
               </a:rPr>
-              <a:t>Staff upskilled to process invoices many different ways -&gt; errors, slow cycles, no end-to-end visibility.</a:t>
+              <a:t>Staff are trained to process invoices in lots of different ways, which causes errors, slow cycles and poor visibility.</a:t>
             </a:r>
           </a:p>
           <a:p>
@@ -5162,7 +3972,7 @@
                   <a:srgbClr val="1F3864"/>
                 </a:solidFill>
               </a:rPr>
-              <a:t>R4  Fragmented, poorly integrated systems (Oracle / SAP / PeopleSoft)</a:t>
+              <a:t>R4  Systems that barely talk to each other</a:t>
             </a:r>
           </a:p>
           <a:p>
@@ -5177,7 +3987,7 @@
                   <a:srgbClr val="444444"/>
                 </a:solidFill>
               </a:rPr>
-              <a:t>'Not well integrated', 'a lot of manual processes' -&gt; rework, high IT/training cost, no consolidated spend data.</a:t>
+              <a:t>Three ERPs (Oracle, SAP, PeopleSoft) are poorly connected, so people fall back on manual workarounds and there is no joined-up spend data.</a:t>
             </a:r>
           </a:p>
         </p:txBody>
@@ -5228,7 +4038,7 @@
                   <a:srgbClr val="1F3864"/>
                 </a:solidFill>
               </a:rPr>
-              <a:t>1. The issues — symptoms (what hurts day to day)</a:t>
+              <a:t>1. The issues: what it costs day to day</a:t>
             </a:r>
           </a:p>
         </p:txBody>
@@ -5266,7 +4076,7 @@
                   <a:srgbClr val="1F3864"/>
                 </a:solidFill>
               </a:rPr>
-              <a:t>S1  Protracted payables (stated)</a:t>
+              <a:t>S1  Slow payments to suppliers (from the analysis)</a:t>
             </a:r>
           </a:p>
           <a:p>
@@ -5281,7 +4091,7 @@
                   <a:srgbClr val="C0392B"/>
                 </a:solidFill>
               </a:rPr>
-              <a:t>Assumption: drives late-payment penalties, lost early-payment discounts and strained supplier relationships.</a:t>
+              <a:t>Assumption: this likely brings late-payment charges, missed early-payment discounts and frustrated suppliers.</a:t>
             </a:r>
           </a:p>
           <a:p>
@@ -5296,7 +4106,7 @@
                   <a:srgbClr val="1F3864"/>
                 </a:solidFill>
               </a:rPr>
-              <a:t>S2  Lost economies of scale (stated)</a:t>
+              <a:t>S2  Loss of buying power (from the analysis)</a:t>
             </a:r>
           </a:p>
           <a:p>
@@ -5311,7 +4121,7 @@
                   <a:srgbClr val="444444"/>
                 </a:solidFill>
               </a:rPr>
-              <a:t>Fragmented spend -&gt; higher prices and duplicate contracts (see supplier evidence next).</a:t>
+              <a:t>Spread across so many suppliers, the company pays more and ends up with duplicate contracts (see the next slide).</a:t>
             </a:r>
           </a:p>
           <a:p>
@@ -5326,7 +4136,7 @@
                   <a:srgbClr val="1F3864"/>
                 </a:solidFill>
               </a:rPr>
-              <a:t>S3  Catalogue proliferation &amp; tail spend (stated)</a:t>
+              <a:t>S3  Too many catalogue items and small purchases (from the analysis)</a:t>
             </a:r>
           </a:p>
           <a:p>
@@ -5341,7 +4151,7 @@
                   <a:srgbClr val="444444"/>
                 </a:solidFill>
               </a:rPr>
-              <a:t>Low-value items need multiple orders to different suppliers — costly at 1.8M txns/day.</a:t>
+              <a:t>A single low-value item can mean several separate orders to different suppliers, which is expensive at 1.8 million transactions a day.</a:t>
             </a:r>
           </a:p>
           <a:p>
@@ -5356,7 +4166,7 @@
                   <a:srgbClr val="1F3864"/>
                 </a:solidFill>
               </a:rPr>
-              <a:t>S4  Resourcing imbalance (stated)</a:t>
+              <a:t>S4  Uneven teams (from the analysis)</a:t>
             </a:r>
           </a:p>
           <a:p>
@@ -5371,7 +4181,7 @@
                   <a:srgbClr val="444444"/>
                 </a:solidFill>
               </a:rPr>
-              <a:t>Team 1: 2 FTE + part-timers + 2 vacancies (slow).  Team 2: 7 + 2 seniors (fast).</a:t>
+              <a:t>Team 1 has 2 full-timers plus part-timers and 2 open roles, and is slow. Team 2 has 7 people plus 2 seniors and is much quicker.</a:t>
             </a:r>
           </a:p>
           <a:p>
@@ -5386,7 +4196,7 @@
                   <a:srgbClr val="1F3864"/>
                 </a:solidFill>
               </a:rPr>
-              <a:t>S5  Low morale — procurement seen as low-value back-office work (stated)</a:t>
+              <a:t>S5  Low morale, with procurement seen as low-value admin (from the analysis)</a:t>
             </a:r>
           </a:p>
           <a:p>
@@ -5401,7 +4211,7 @@
                   <a:srgbClr val="C0392B"/>
                 </a:solidFill>
               </a:rPr>
-              <a:t>Assumption: creates attrition risk and change fatigue.</a:t>
+              <a:t>Assumption: this risks people leaving and makes change harder.</a:t>
             </a:r>
           </a:p>
         </p:txBody>
@@ -5452,7 +4262,7 @@
                   <a:srgbClr val="1F3864"/>
                 </a:solidFill>
               </a:rPr>
-              <a:t>Evidence: the supplier base is fragmenting, not consolidating</a:t>
+              <a:t>Evidence: the supplier base is growing, not consolidating</a:t>
             </a:r>
           </a:p>
         </p:txBody>
@@ -5490,7 +4300,7 @@
                   <a:srgbClr val="1F3864"/>
                 </a:solidFill>
               </a:rPr>
-              <a:t>2023:  224 suppliers  |  $900M spend</a:t>
+              <a:t>2023:  224 suppliers,  $900M spend</a:t>
             </a:r>
           </a:p>
           <a:p>
@@ -5505,7 +4315,7 @@
                   <a:srgbClr val="1F3864"/>
                 </a:solidFill>
               </a:rPr>
-              <a:t>2024:  264 suppliers  |  $1,045M spend</a:t>
+              <a:t>2024:  264 suppliers,  $1,045M spend</a:t>
             </a:r>
           </a:p>
           <a:p>
@@ -5520,7 +4330,7 @@
                   <a:srgbClr val="444444"/>
                 </a:solidFill>
               </a:rPr>
-              <a:t>Suppliers +40 (+18%); spend +$145M (+16%).</a:t>
+              <a:t>That is 40 more suppliers (up 18%) and $145M more spend (up 16%).</a:t>
             </a:r>
           </a:p>
           <a:p>
@@ -5535,7 +4345,7 @@
                   <a:srgbClr val="444444"/>
                 </a:solidFill>
               </a:rPr>
-              <a:t>Average spend per supplier FELL: $4.02M -&gt; $3.96M.</a:t>
+              <a:t>But the average spend per supplier fell, from $4.02M to $3.96M.</a:t>
             </a:r>
           </a:p>
           <a:p>
@@ -5550,7 +4360,7 @@
                   <a:srgbClr val="1F3864"/>
                 </a:solidFill>
               </a:rPr>
-              <a:t>So spend is rising but buying leverage per supplier is falling — adding suppliers faster than consolidating them.</a:t>
+              <a:t>So spend is rising while it is being spread across more suppliers, which is the opposite of building buying power.</a:t>
             </a:r>
           </a:p>
           <a:p>
@@ -5565,7 +4375,7 @@
                   <a:srgbClr val="444444"/>
                 </a:solidFill>
               </a:rPr>
-              <a:t>Direct evidence for S2 (lost economies of scale) and R2 (fragmented, un-integrated units).</a:t>
+              <a:t>This backs up the loss of buying power and the fact the units were never joined up.</a:t>
             </a:r>
           </a:p>
           <a:p>
@@ -5580,7 +4390,7 @@
                   <a:srgbClr val="C0392B"/>
                 </a:solidFill>
               </a:rPr>
-              <a:t>Assumption: figures are group-wide; a per-unit / per-category split would size the consolidation opportunity.</a:t>
+              <a:t>Assumption: these look like group totals, so a breakdown by site or category would show where the opportunity sits.</a:t>
             </a:r>
           </a:p>
         </p:txBody>
@@ -5631,7 +4441,7 @@
                   <a:srgbClr val="1F3864"/>
                 </a:solidFill>
               </a:rPr>
-              <a:t>Which issue matters most?</a:t>
+              <a:t>The issue I think matters most</a:t>
             </a:r>
           </a:p>
           <a:p>
@@ -5641,7 +4451,7 @@
                   <a:srgbClr val="C0392B"/>
                 </a:solidFill>
               </a:rPr>
-              <a:t>Our view</a:t>
+              <a:t>My view</a:t>
             </a:r>
           </a:p>
         </p:txBody>
@@ -5679,7 +4489,7 @@
                   <a:srgbClr val="1F3864"/>
                 </a:solidFill>
               </a:rPr>
-              <a:t>Most important = R1: secure executive sponsorship and a compliance mandate.</a:t>
+              <a:t>For me it is R1, the lack of executive backing.</a:t>
             </a:r>
           </a:p>
           <a:p>
@@ -5694,7 +4504,7 @@
                   <a:srgbClr val="444444"/>
                 </a:solidFill>
               </a:rPr>
-              <a:t>Not the most expensive problem, but the dependency that unblocks everything else.</a:t>
+              <a:t>It is not the costliest problem, but it is the one that has to be solved before any of the others can move.</a:t>
             </a:r>
           </a:p>
           <a:p>
@@ -5709,7 +4519,7 @@
                   <a:srgbClr val="444444"/>
                 </a:solidFill>
               </a:rPr>
-              <a:t>With 59 autonomous units, you cannot standardise processes, consolidate systems or rationalise suppliers unless leadership mandates it.</a:t>
+              <a:t>Across 59 independent sites you cannot standardise processes, bring systems together or tidy up suppliers unless leadership requires it.</a:t>
             </a:r>
           </a:p>
           <a:p>
@@ -5724,7 +4534,7 @@
                   <a:srgbClr val="444444"/>
                 </a:solidFill>
               </a:rPr>
-              <a:t>Business impact: without it, spend and the supplier base keep fragmenting (as 2023-&gt;2024 shows). Low cost, high leverage — fix it first.</a:t>
+              <a:t>If it is left alone, spend and the supplier base just keep spreading, which is exactly what the 2023 to 2024 figures show. It is cheap to fix and it makes everything else possible.</a:t>
             </a:r>
           </a:p>
         </p:txBody>
@@ -5775,7 +4585,7 @@
                   <a:srgbClr val="1F3864"/>
                 </a:solidFill>
               </a:rPr>
-              <a:t>2. Prioritisation — three high-impact moves</a:t>
+              <a:t>2. What I would prioritise: three moves that matter most</a:t>
             </a:r>
           </a:p>
           <a:p>
@@ -5785,7 +4595,7 @@
                   <a:srgbClr val="C0392B"/>
                 </a:solidFill>
               </a:rPr>
-              <a:t>Prioritised issue and why — not a full redesign</a:t>
+              <a:t>The priorities and the reasoning, not a full rebuild</a:t>
             </a:r>
           </a:p>
         </p:txBody>
@@ -5823,7 +4633,7 @@
                   <a:srgbClr val="444444"/>
                 </a:solidFill>
               </a:rPr>
-              <a:t>1.  R1 — Secure executive sponsorship &amp; a compliance mandate</a:t>
+              <a:t>1.  Get executive backing and a clear requirement to comply</a:t>
             </a:r>
           </a:p>
           <a:p>
@@ -5838,7 +4648,7 @@
                   <a:srgbClr val="444444"/>
                 </a:solidFill>
               </a:rPr>
-              <a:t>Low cost, fast, unlocks every other fix. Highest leverage move available.</a:t>
+              <a:t>Quick, low cost, and it makes everything else possible.</a:t>
             </a:r>
           </a:p>
           <a:p>
@@ -5853,7 +4663,7 @@
                   <a:srgbClr val="444444"/>
                 </a:solidFill>
               </a:rPr>
-              <a:t>2.  R3 + S3 — Standardise procure-to-pay &amp; rationalise catalogue / tail spend</a:t>
+              <a:t>2.  Agree one standard procure-to-pay process and tidy up the catalogue and small-value spend</a:t>
             </a:r>
           </a:p>
           <a:p>
@@ -5868,7 +4678,7 @@
                   <a:srgbClr val="444444"/>
                 </a:solidFill>
               </a:rPr>
-              <a:t>Biggest near-term efficiency gain at 1.8M txns/day — achievable WITHOUT replacing systems.</a:t>
+              <a:t>The biggest near-term gain at 1.8 million transactions a day, and it does not need new systems.</a:t>
             </a:r>
           </a:p>
           <a:p>
@@ -5883,7 +4693,7 @@
                   <a:srgbClr val="444444"/>
                 </a:solidFill>
               </a:rPr>
-              <a:t>3.  S4 — Rebalance the two central teams (fill Team 1 vacancies / shift workload)</a:t>
+              <a:t>3.  Even out the two teams by filling Team 1's open roles or moving work across</a:t>
             </a:r>
           </a:p>
           <a:p>
@@ -5898,7 +4708,7 @@
                   <a:srgbClr val="444444"/>
                 </a:solidFill>
               </a:rPr>
-              <a:t>Fast operational win that lifts throughput and morale.</a:t>
+              <a:t>A quick win that also helps morale.</a:t>
             </a:r>
           </a:p>
           <a:p>
@@ -5913,7 +4723,7 @@
                   <a:srgbClr val="C0392B"/>
                 </a:solidFill>
               </a:rPr>
-              <a:t>Assumption: these three deliver most of the benefit; structural changes are deferred until data justifies them.</a:t>
+              <a:t>Assumption: these three give most of the benefit, so bigger changes can wait until the data backs them.</a:t>
             </a:r>
           </a:p>
         </p:txBody>
@@ -5964,7 +4774,7 @@
                   <a:srgbClr val="1F3864"/>
                 </a:solidFill>
               </a:rPr>
-              <a:t>Related issues — longer-term focus</a:t>
+              <a:t>Related issues to come back to later</a:t>
             </a:r>
           </a:p>
           <a:p>
@@ -5974,7 +4784,7 @@
                   <a:srgbClr val="C0392B"/>
                 </a:solidFill>
               </a:rPr>
-              <a:t>Higher cost / risk: later-stage, data-led decisions</a:t>
+              <a:t>Bigger, costlier changes that should be led by data</a:t>
             </a:r>
           </a:p>
         </p:txBody>
@@ -6012,7 +4822,7 @@
                   <a:srgbClr val="1F3864"/>
                 </a:solidFill>
               </a:rPr>
-              <a:t>R4 — Consolidate / better integrate the ERPs (Oracle, SAP, PeopleSoft)</a:t>
+              <a:t>Bringing the ERPs (Oracle, SAP, PeopleSoft) together, or at least connecting them properly.</a:t>
             </a:r>
           </a:p>
           <a:p>
@@ -6027,7 +4837,7 @@
                   <a:srgbClr val="1F3864"/>
                 </a:solidFill>
               </a:rPr>
-              <a:t>S2 — Rationalise the supplier base to rebuild buying leverage</a:t>
+              <a:t>Tidying up the supplier base to rebuild buying power.</a:t>
             </a:r>
           </a:p>
           <a:p>
@@ -6042,7 +4852,7 @@
                   <a:srgbClr val="1F3864"/>
                 </a:solidFill>
               </a:rPr>
-              <a:t>R2 — Move the 59 units toward one operating model / shared services</a:t>
+              <a:t>Moving the 59 sites towards one way of working, or a shared service.</a:t>
             </a:r>
           </a:p>
           <a:p>
@@ -6057,7 +4867,7 @@
                   <a:srgbClr val="C0392B"/>
                 </a:solidFill>
               </a:rPr>
-              <a:t>Assumption: a full ERP consolidation is NOT assumed to be the right answer yet — it should be a business case decided on spend, cost-to-serve and lock-in data.</a:t>
+              <a:t>Assumption: I am not assuming a full system merge is the right answer yet. That is a big call and should be based on spend, running costs and contract lock-ins.</a:t>
             </a:r>
           </a:p>
         </p:txBody>
@@ -6108,7 +4918,7 @@
                   <a:srgbClr val="1F3864"/>
                 </a:solidFill>
               </a:rPr>
-              <a:t>Why this is a priority — organisational factors</a:t>
+              <a:t>Why this is a priority across the business</a:t>
             </a:r>
           </a:p>
           <a:p>
@@ -6118,7 +4928,7 @@
                   <a:srgbClr val="C0392B"/>
                 </a:solidFill>
               </a:rPr>
-              <a:t>People · Process · Governance · Systems</a:t>
+              <a:t>People, process, governance and systems</a:t>
             </a:r>
           </a:p>
         </p:txBody>
@@ -6171,7 +4981,7 @@
                   <a:srgbClr val="444444"/>
                 </a:solidFill>
               </a:rPr>
-              <a:t>Imbalanced teams (Team 1 understaffed, 2 vacancies, part-timers) + low morale + 'low-value' perception = limited capacity and appetite to deliver change.</a:t>
+              <a:t>The teams are uneven, morale is low and procurement is seen as low value, so there is limited capacity and appetite for change.</a:t>
             </a:r>
           </a:p>
           <a:p>
@@ -6201,7 +5011,7 @@
                   <a:srgbClr val="444444"/>
                 </a:solidFill>
               </a:rPr>
-              <a:t>No standard P2P, manual processes, catalogue proliferation, multiple orders for low-value items — inefficiency scales to 1.8M txns/day.</a:t>
+              <a:t>No standard process, a lot of manual work and too many catalogue items, all multiplied across 1.8 million transactions a day.</a:t>
             </a:r>
           </a:p>
           <a:p>
@@ -6231,7 +5041,7 @@
                   <a:srgbClr val="444444"/>
                 </a:solidFill>
               </a:rPr>
-              <a:t>No executive mandate; teams accountable but cannot enforce compliance across 59 units — this is what elevates everything to a priority.</a:t>
+              <a:t>No executive requirement to comply, which is what turns these problems into a real priority.</a:t>
             </a:r>
           </a:p>
           <a:p>
@@ -6261,7 +5071,7 @@
                   <a:srgbClr val="444444"/>
                 </a:solidFill>
               </a:rPr>
-              <a:t>Three poorly integrated ERPs (Oracle/SAP/PeopleSoft) -&gt; manual rework, no consolidated spend data, high IT/training cost.</a:t>
+              <a:t>Three poorly connected ERPs and no single view of spend.</a:t>
             </a:r>
           </a:p>
         </p:txBody>
@@ -6592,324 +5402,4 @@
   </a:objectDefaults>
   <a:extraClrSchemeLst/>
 </a:theme>
-</file>
-
-<file path=ppt/theme/theme2.xml><?xml version="1.0" encoding="utf-8"?>
-<a:theme xmlns:a="http://schemas.openxmlformats.org/drawingml/2006/main" name="Office Theme">
-  <a:themeElements>
-    <a:clrScheme name="Office">
-      <a:dk1>
-        <a:sysClr val="windowText" lastClr="000000"/>
-      </a:dk1>
-      <a:lt1>
-        <a:sysClr val="window" lastClr="FFFFFF"/>
-      </a:lt1>
-      <a:dk2>
-        <a:srgbClr val="1F497D"/>
-      </a:dk2>
-      <a:lt2>
-        <a:srgbClr val="EEECE1"/>
-      </a:lt2>
-      <a:accent1>
-        <a:srgbClr val="4F81BD"/>
-      </a:accent1>
-      <a:accent2>
-        <a:srgbClr val="C0504D"/>
-      </a:accent2>
-      <a:accent3>
-        <a:srgbClr val="9BBB59"/>
-      </a:accent3>
-      <a:accent4>
-        <a:srgbClr val="8064A2"/>
-      </a:accent4>
-      <a:accent5>
-        <a:srgbClr val="4BACC6"/>
-      </a:accent5>
-      <a:accent6>
-        <a:srgbClr val="F79646"/>
-      </a:accent6>
-      <a:hlink>
-        <a:srgbClr val="0000FF"/>
-      </a:hlink>
-      <a:folHlink>
-        <a:srgbClr val="800080"/>
-      </a:folHlink>
-    </a:clrScheme>
-    <a:fontScheme name="Office">
-      <a:majorFont>
-        <a:latin typeface="Calibri"/>
-        <a:ea typeface=""/>
-        <a:cs typeface=""/>
-        <a:font script="Jpan" typeface="ＭＳ Ｐゴシック"/>
-        <a:font script="Hang" typeface="맑은 고딕"/>
-        <a:font script="Hans" typeface="宋体"/>
-        <a:font script="Hant" typeface="新細明體"/>
-        <a:font script="Arab" typeface="Times New Roman"/>
-        <a:font script="Hebr" typeface="Times New Roman"/>
-        <a:font script="Thai" typeface="Angsana New"/>
-        <a:font script="Ethi" typeface="Nyala"/>
-        <a:font script="Beng" typeface="Vrinda"/>
-        <a:font script="Gujr" typeface="Shruti"/>
-        <a:font script="Khmr" typeface="MoolBoran"/>
-        <a:font script="Knda" typeface="Tunga"/>
-        <a:font script="Guru" typeface="Raavi"/>
-        <a:font script="Cans" typeface="Euphemia"/>
-        <a:font script="Cher" typeface="Plantagenet Cherokee"/>
-        <a:font script="Yiii" typeface="Microsoft Yi Baiti"/>
-        <a:font script="Tibt" typeface="Microsoft Himalaya"/>
-        <a:font script="Thaa" typeface="MV Boli"/>
-        <a:font script="Deva" typeface="Mangal"/>
-        <a:font script="Telu" typeface="Gautami"/>
-        <a:font script="Taml" typeface="Latha"/>
-        <a:font script="Syrc" typeface="Estrangelo Edessa"/>
-        <a:font script="Orya" typeface="Kalinga"/>
-        <a:font script="Mlym" typeface="Kartika"/>
-        <a:font script="Laoo" typeface="DokChampa"/>
-        <a:font script="Sinh" typeface="Iskoola Pota"/>
-        <a:font script="Mong" typeface="Mongolian Baiti"/>
-        <a:font script="Viet" typeface="Times New Roman"/>
-        <a:font script="Uigh" typeface="Microsoft Uighur"/>
-        <a:font script="Geor" typeface="Sylfaen"/>
-      </a:majorFont>
-      <a:minorFont>
-        <a:latin typeface="Calibri"/>
-        <a:ea typeface=""/>
-        <a:cs typeface=""/>
-        <a:font script="Jpan" typeface="ＭＳ Ｐゴシック"/>
-        <a:font script="Hang" typeface="맑은 고딕"/>
-        <a:font script="Hans" typeface="宋体"/>
-        <a:font script="Hant" typeface="新細明體"/>
-        <a:font script="Arab" typeface="Arial"/>
-        <a:font script="Hebr" typeface="Arial"/>
-        <a:font script="Thai" typeface="Cordia New"/>
-        <a:font script="Ethi" typeface="Nyala"/>
-        <a:font script="Beng" typeface="Vrinda"/>
-        <a:font script="Gujr" typeface="Shruti"/>
-        <a:font script="Khmr" typeface="DaunPenh"/>
-        <a:font script="Knda" typeface="Tunga"/>
-        <a:font script="Guru" typeface="Raavi"/>
-        <a:font script="Cans" typeface="Euphemia"/>
-        <a:font script="Cher" typeface="Plantagenet Cherokee"/>
-        <a:font script="Yiii" typeface="Microsoft Yi Baiti"/>
-        <a:font script="Tibt" typeface="Microsoft Himalaya"/>
-        <a:font script="Thaa" typeface="MV Boli"/>
-        <a:font script="Deva" typeface="Mangal"/>
-        <a:font script="Telu" typeface="Gautami"/>
-        <a:font script="Taml" typeface="Latha"/>
-        <a:font script="Syrc" typeface="Estrangelo Edessa"/>
-        <a:font script="Orya" typeface="Kalinga"/>
-        <a:font script="Mlym" typeface="Kartika"/>
-        <a:font script="Laoo" typeface="DokChampa"/>
-        <a:font script="Sinh" typeface="Iskoola Pota"/>
-        <a:font script="Mong" typeface="Mongolian Baiti"/>
-        <a:font script="Viet" typeface="Arial"/>
-        <a:font script="Uigh" typeface="Microsoft Uighur"/>
-        <a:font script="Geor" typeface="Sylfaen"/>
-      </a:minorFont>
-    </a:fontScheme>
-    <a:fmtScheme name="Office">
-      <a:fillStyleLst>
-        <a:solidFill>
-          <a:schemeClr val="phClr"/>
-        </a:solidFill>
-        <a:gradFill rotWithShape="1">
-          <a:gsLst>
-            <a:gs pos="0">
-              <a:schemeClr val="phClr">
-                <a:tint val="50000"/>
-                <a:satMod val="300000"/>
-              </a:schemeClr>
-            </a:gs>
-            <a:gs pos="35000">
-              <a:schemeClr val="phClr">
-                <a:tint val="37000"/>
-                <a:satMod val="300000"/>
-              </a:schemeClr>
-            </a:gs>
-            <a:gs pos="100000">
-              <a:schemeClr val="phClr">
-                <a:tint val="15000"/>
-                <a:satMod val="350000"/>
-              </a:schemeClr>
-            </a:gs>
-          </a:gsLst>
-          <a:lin ang="16200000" scaled="1"/>
-        </a:gradFill>
-        <a:gradFill rotWithShape="1">
-          <a:gsLst>
-            <a:gs pos="0">
-              <a:schemeClr val="phClr">
-                <a:tint val="100000"/>
-                <a:shade val="100000"/>
-                <a:satMod val="130000"/>
-              </a:schemeClr>
-            </a:gs>
-            <a:gs pos="100000">
-              <a:schemeClr val="phClr">
-                <a:tint val="50000"/>
-                <a:shade val="100000"/>
-                <a:satMod val="350000"/>
-              </a:schemeClr>
-            </a:gs>
-          </a:gsLst>
-          <a:lin ang="16200000" scaled="0"/>
-        </a:gradFill>
-      </a:fillStyleLst>
-      <a:lnStyleLst>
-        <a:ln w="9525" cap="flat" cmpd="sng" algn="ctr">
-          <a:solidFill>
-            <a:schemeClr val="phClr">
-              <a:shade val="95000"/>
-              <a:satMod val="105000"/>
-            </a:schemeClr>
-          </a:solidFill>
-          <a:prstDash val="solid"/>
-        </a:ln>
-        <a:ln w="25400" cap="flat" cmpd="sng" algn="ctr">
-          <a:solidFill>
-            <a:schemeClr val="phClr"/>
-          </a:solidFill>
-          <a:prstDash val="solid"/>
-        </a:ln>
-        <a:ln w="38100" cap="flat" cmpd="sng" algn="ctr">
-          <a:solidFill>
-            <a:schemeClr val="phClr"/>
-          </a:solidFill>
-          <a:prstDash val="solid"/>
-        </a:ln>
-      </a:lnStyleLst>
-      <a:effectStyleLst>
-        <a:effectStyle>
-          <a:effectLst>
-            <a:outerShdw blurRad="40000" dist="20000" dir="5400000" rotWithShape="0">
-              <a:srgbClr val="000000">
-                <a:alpha val="38000"/>
-              </a:srgbClr>
-            </a:outerShdw>
-          </a:effectLst>
-        </a:effectStyle>
-        <a:effectStyle>
-          <a:effectLst>
-            <a:outerShdw blurRad="40000" dist="23000" dir="5400000" rotWithShape="0">
-              <a:srgbClr val="000000">
-                <a:alpha val="35000"/>
-              </a:srgbClr>
-            </a:outerShdw>
-          </a:effectLst>
-        </a:effectStyle>
-        <a:effectStyle>
-          <a:effectLst>
-            <a:outerShdw blurRad="40000" dist="23000" dir="5400000" rotWithShape="0">
-              <a:srgbClr val="000000">
-                <a:alpha val="35000"/>
-              </a:srgbClr>
-            </a:outerShdw>
-          </a:effectLst>
-          <a:scene3d>
-            <a:camera prst="orthographicFront">
-              <a:rot lat="0" lon="0" rev="0"/>
-            </a:camera>
-            <a:lightRig rig="threePt" dir="t">
-              <a:rot lat="0" lon="0" rev="1200000"/>
-            </a:lightRig>
-          </a:scene3d>
-          <a:sp3d>
-            <a:bevelT w="63500" h="25400"/>
-          </a:sp3d>
-        </a:effectStyle>
-      </a:effectStyleLst>
-      <a:bgFillStyleLst>
-        <a:solidFill>
-          <a:schemeClr val="phClr"/>
-        </a:solidFill>
-        <a:gradFill rotWithShape="1">
-          <a:gsLst>
-            <a:gs pos="0">
-              <a:schemeClr val="phClr">
-                <a:tint val="40000"/>
-                <a:satMod val="350000"/>
-              </a:schemeClr>
-            </a:gs>
-            <a:gs pos="40000">
-              <a:schemeClr val="phClr">
-                <a:tint val="45000"/>
-                <a:shade val="99000"/>
-                <a:satMod val="350000"/>
-              </a:schemeClr>
-            </a:gs>
-            <a:gs pos="100000">
-              <a:schemeClr val="phClr">
-                <a:shade val="20000"/>
-                <a:satMod val="255000"/>
-              </a:schemeClr>
-            </a:gs>
-          </a:gsLst>
-          <a:path path="circle">
-            <a:fillToRect l="50000" t="-80000" r="50000" b="180000"/>
-          </a:path>
-        </a:gradFill>
-        <a:gradFill rotWithShape="1">
-          <a:gsLst>
-            <a:gs pos="0">
-              <a:schemeClr val="phClr">
-                <a:tint val="80000"/>
-                <a:satMod val="300000"/>
-              </a:schemeClr>
-            </a:gs>
-            <a:gs pos="100000">
-              <a:schemeClr val="phClr">
-                <a:shade val="30000"/>
-                <a:satMod val="200000"/>
-              </a:schemeClr>
-            </a:gs>
-          </a:gsLst>
-          <a:path path="circle">
-            <a:fillToRect l="50000" t="50000" r="50000" b="50000"/>
-          </a:path>
-        </a:gradFill>
-      </a:bgFillStyleLst>
-    </a:fmtScheme>
-  </a:themeElements>
-  <a:objectDefaults>
-    <a:spDef>
-      <a:spPr/>
-      <a:bodyPr/>
-      <a:lstStyle/>
-      <a:style>
-        <a:lnRef idx="1">
-          <a:schemeClr val="accent1"/>
-        </a:lnRef>
-        <a:fillRef idx="3">
-          <a:schemeClr val="accent1"/>
-        </a:fillRef>
-        <a:effectRef idx="2">
-          <a:schemeClr val="accent1"/>
-        </a:effectRef>
-        <a:fontRef idx="minor">
-          <a:schemeClr val="lt1"/>
-        </a:fontRef>
-      </a:style>
-    </a:spDef>
-    <a:lnDef>
-      <a:spPr/>
-      <a:bodyPr/>
-      <a:lstStyle/>
-      <a:style>
-        <a:lnRef idx="2">
-          <a:schemeClr val="accent1"/>
-        </a:lnRef>
-        <a:fillRef idx="0">
-          <a:schemeClr val="accent1"/>
-        </a:fillRef>
-        <a:effectRef idx="1">
-          <a:schemeClr val="accent1"/>
-        </a:effectRef>
-        <a:fontRef idx="minor">
-          <a:schemeClr val="tx1"/>
-        </a:fontRef>
-      </a:style>
-    </a:lnDef>
-  </a:objectDefaults>
-  <a:extraClrSchemeLst/>
-</a:theme>
 </file>
</xml_diff>